<commit_message>
feat: AvisoSistemaWidget post-it flutuante (draggable, criticidade baixa/media/alta, prazo/permanente, origem admin/diretoria); AdminTab aba Avisos CRUD; CrmTab area livre contenteditable; CrmTab split modal 9 abas; docs: Manual Word cap├¡tulos 30-31 (Avisos + CRM Modal/├ürea Livre); PPTX 4 novos slides (slides 35-38)
</commit_message>
<xml_diff>
--- a/ACN_Sinal_Verde_Treinamento.pptx
+++ b/ACN_Sinal_Verde_Treinamento.pptx
@@ -39,6 +39,10 @@
     <p:sldId id="285" r:id="rId31"/>
     <p:sldId id="286" r:id="rId32"/>
     <p:sldId id="290" r:id="rId41"/>
+    <p:sldId id="294" r:id="rId45"/>
+    <p:sldId id="293" r:id="rId44"/>
+    <p:sldId id="292" r:id="rId43"/>
+    <p:sldId id="291" r:id="rId42"/>
     <p:sldId id="287" r:id="rId33"/>
   </p:sldIdLst>
   <p:notesMasterIdLst>
@@ -23457,6 +23461,3680 @@
 </p:sld>
 </file>
 
+<file path=ppt/slides/slide36.xml><?xml version="1.0" encoding="utf-8"?>
+<p:sld xmlns:a="http://schemas.openxmlformats.org/drawingml/2006/main" xmlns:r="http://schemas.openxmlformats.org/officeDocument/2006/relationships" xmlns:p="http://schemas.openxmlformats.org/presentationml/2006/main">
+  <p:cSld name="Slide CRM Area Livre">
+    <p:spTree>
+      <p:nvGrpSpPr>
+        <p:cNvPr id="1" name=""/>
+        <p:cNvGrpSpPr/>
+        <p:nvPr/>
+      </p:nvGrpSpPr>
+      <p:grpSpPr>
+        <a:xfrm>
+          <a:off x="0" y="0"/>
+          <a:ext cx="0" cy="0"/>
+          <a:chOff x="0" y="0"/>
+          <a:chExt cx="0" cy="0"/>
+        </a:xfrm>
+      </p:grpSpPr>
+      <p:sp>
+        <p:nvSpPr>
+          <p:cNvPr id="2" name="BG"/>
+          <p:cNvSpPr/>
+          <p:nvPr/>
+        </p:nvSpPr>
+        <p:spPr>
+          <a:xfrm>
+            <a:off x="0" y="0"/>
+            <a:ext cx="9144000" cy="5143500"/>
+          </a:xfrm>
+          <a:prstGeom prst="rect">
+            <a:avLst/>
+          </a:prstGeom>
+          <a:solidFill>
+            <a:srgbClr val="FFFFFF"/>
+          </a:solidFill>
+          <a:ln w="12700">
+            <a:solidFill>
+              <a:srgbClr val="FFFFFF"/>
+            </a:solidFill>
+            <a:prstDash val="solid"/>
+          </a:ln>
+        </p:spPr>
+      </p:sp>
+      <p:sp>
+        <p:nvSpPr>
+          <p:cNvPr id="3" name="ModLabel"/>
+          <p:cNvSpPr/>
+          <p:nvPr/>
+        </p:nvSpPr>
+        <p:spPr>
+          <a:xfrm>
+            <a:off x="457200" y="182880"/>
+            <a:ext cx="7315200" cy="201168"/>
+          </a:xfrm>
+          <a:prstGeom prst="rect">
+            <a:avLst/>
+          </a:prstGeom>
+          <a:noFill/>
+          <a:ln/>
+        </p:spPr>
+        <p:txBody>
+          <a:bodyPr wrap="square" lIns="45720" tIns="45720" rIns="45720" bIns="45720" rtlCol="0" anchor="t"/>
+          <a:lstStyle/>
+          <a:p>
+            <a:pPr indent="0" marL="0">
+              <a:buNone/>
+            </a:pPr>
+            <a:r>
+              <a:rPr lang="pt-BR" sz="950" b="1" dirty="0">
+                <a:solidFill>
+                  <a:srgbClr val="94A3B8"/>
+                </a:solidFill>
+                <a:latin typeface="Calibri" pitchFamily="34" charset="0"/>
+              </a:rPr>
+              <a:t>MODULO CRM</a:t>
+            </a:r>
+            <a:endParaRPr lang="pt-BR" sz="950" dirty="0"/>
+          </a:p>
+        </p:txBody>
+      </p:sp>
+      <p:sp>
+        <p:nvSpPr>
+          <p:cNvPr id="4" name="Title"/>
+          <p:cNvSpPr/>
+          <p:nvPr/>
+        </p:nvSpPr>
+        <p:spPr>
+          <a:xfrm>
+            <a:off x="457200" y="384048"/>
+            <a:ext cx="8229600" cy="480000"/>
+          </a:xfrm>
+          <a:prstGeom prst="rect">
+            <a:avLst/>
+          </a:prstGeom>
+          <a:noFill/>
+          <a:ln/>
+        </p:spPr>
+        <p:txBody>
+          <a:bodyPr wrap="square" lIns="45720" tIns="45720" rIns="45720" bIns="45720" rtlCol="0" anchor="ctr"/>
+          <a:lstStyle/>
+          <a:p>
+            <a:pPr indent="0" marL="0">
+              <a:buNone/>
+            </a:pPr>
+            <a:r>
+              <a:rPr lang="pt-BR" sz="3000" b="1" dirty="0">
+                <a:solidFill>
+                  <a:srgbClr val="166534"/>
+                </a:solidFill>
+                <a:latin typeface="Cambria" pitchFamily="34" charset="0"/>
+              </a:rPr>
+              <a:t>CRM — Area Livre (Editor de Notas)</a:t>
+            </a:r>
+            <a:endParaRPr lang="pt-BR" sz="3000" dirty="0"/>
+          </a:p>
+        </p:txBody>
+      </p:sp>
+      <p:sp>
+        <p:nvSpPr>
+          <p:cNvPr id="5" name="Subtitle"/>
+          <p:cNvSpPr/>
+          <p:nvPr/>
+        </p:nvSpPr>
+        <p:spPr>
+          <a:xfrm>
+            <a:off x="457200" y="920000"/>
+            <a:ext cx="8229600" cy="200000"/>
+          </a:xfrm>
+          <a:prstGeom prst="rect">
+            <a:avLst/>
+          </a:prstGeom>
+          <a:noFill/>
+          <a:ln/>
+        </p:spPr>
+        <p:txBody>
+          <a:bodyPr wrap="square" lIns="45720" tIns="45720" rIns="45720" bIns="45720" rtlCol="0" anchor="t"/>
+          <a:lstStyle/>
+          <a:p>
+            <a:pPr indent="0" marL="0">
+              <a:buNone/>
+            </a:pPr>
+            <a:r>
+              <a:rPr lang="pt-BR" sz="1200" dirty="0">
+                <a:solidFill>
+                  <a:srgbClr val="64748B"/>
+                </a:solidFill>
+                <a:latin typeface="Calibri" pitchFamily="34" charset="0"/>
+              </a:rPr>
+              <a:t>Espaco exclusivo em cada aba do modal para anotacoes ricas, imagens e links vinculados ao negocio.</a:t>
+            </a:r>
+            <a:endParaRPr lang="pt-BR" sz="1200" dirty="0"/>
+          </a:p>
+        </p:txBody>
+      </p:sp>
+      <p:sp>
+        <p:nvSpPr>
+          <p:cNvPr id="6" name="C1BG"/>
+          <p:cNvSpPr/>
+          <p:nvPr/>
+        </p:nvSpPr>
+        <p:spPr>
+          <a:xfrm>
+            <a:off x="457200" y="1220000"/>
+            <a:ext cx="4024800" cy="1811750"/>
+          </a:xfrm>
+          <a:prstGeom prst="roundRect">
+            <a:avLst>
+              <a:gd name="adj" fmla="val 4082"/>
+            </a:avLst>
+          </a:prstGeom>
+          <a:solidFill>
+            <a:srgbClr val="F0FDF4"/>
+          </a:solidFill>
+          <a:ln w="12700">
+            <a:solidFill>
+              <a:srgbClr val="F0FDF4"/>
+            </a:solidFill>
+            <a:prstDash val="solid"/>
+          </a:ln>
+        </p:spPr>
+      </p:sp>
+      <p:sp>
+        <p:nvSpPr>
+          <p:cNvPr id="7" name="C1Title"/>
+          <p:cNvSpPr/>
+          <p:nvPr/>
+        </p:nvSpPr>
+        <p:spPr>
+          <a:xfrm>
+            <a:off x="557200" y="1320000"/>
+            <a:ext cx="3824800" cy="300000"/>
+          </a:xfrm>
+          <a:prstGeom prst="rect">
+            <a:avLst/>
+          </a:prstGeom>
+          <a:noFill/>
+          <a:ln/>
+        </p:spPr>
+        <p:txBody>
+          <a:bodyPr wrap="square" lIns="45720" tIns="45720" rIns="45720" bIns="45720" rtlCol="0" anchor="t"/>
+          <a:lstStyle/>
+          <a:p>
+            <a:pPr indent="0" marL="0">
+              <a:buNone/>
+            </a:pPr>
+            <a:r>
+              <a:rPr lang="pt-BR" sz="1400" b="1" dirty="0">
+                <a:solidFill>
+                  <a:srgbClr val="166534"/>
+                </a:solidFill>
+                <a:latin typeface="Calibri" pitchFamily="34" charset="0"/>
+              </a:rPr>
+              <a:t>✍️ Formatacao de Texto</a:t>
+            </a:r>
+            <a:endParaRPr lang="pt-BR" sz="1400" dirty="0"/>
+          </a:p>
+        </p:txBody>
+      </p:sp>
+      <p:sp>
+        <p:nvSpPr>
+          <p:cNvPr id="8" name="C1Body"/>
+          <p:cNvSpPr/>
+          <p:nvPr/>
+        </p:nvSpPr>
+        <p:spPr>
+          <a:xfrm>
+            <a:off x="557200" y="1670000"/>
+            <a:ext cx="3824800" cy="1261750"/>
+          </a:xfrm>
+          <a:prstGeom prst="rect">
+            <a:avLst/>
+          </a:prstGeom>
+          <a:noFill/>
+          <a:ln/>
+        </p:spPr>
+        <p:txBody>
+          <a:bodyPr wrap="square" lIns="45720" tIns="45720" rIns="45720" bIns="45720" rtlCol="0" anchor="t"/>
+          <a:lstStyle/>
+          <a:p>
+            <a:pPr indent="0" marL="0">
+              <a:buNone/>
+            </a:pPr>
+            <a:r>
+              <a:rPr lang="pt-BR" sz="1150" dirty="0">
+                <a:solidFill>
+                  <a:srgbClr val="374151"/>
+                </a:solidFill>
+                <a:latin typeface="Calibri" pitchFamily="34" charset="0"/>
+              </a:rPr>
+              <a:t>Negrito (B) e Italico (I) via barra de ferramentas. Formatacao rapida por atalhos do teclado. Texto rico preservado ao salvar.</a:t>
+            </a:r>
+            <a:endParaRPr lang="pt-BR" sz="1150" dirty="0"/>
+          </a:p>
+        </p:txBody>
+      </p:sp>
+      <p:sp>
+        <p:nvSpPr>
+          <p:cNvPr id="9" name="C2BG"/>
+          <p:cNvSpPr/>
+          <p:nvPr/>
+        </p:nvSpPr>
+        <p:spPr>
+          <a:xfrm>
+            <a:off x="4662000" y="1220000"/>
+            <a:ext cx="4024800" cy="1811750"/>
+          </a:xfrm>
+          <a:prstGeom prst="roundRect">
+            <a:avLst>
+              <a:gd name="adj" fmla="val 4082"/>
+            </a:avLst>
+          </a:prstGeom>
+          <a:solidFill>
+            <a:srgbClr val="EFF6FF"/>
+          </a:solidFill>
+          <a:ln w="12700">
+            <a:solidFill>
+              <a:srgbClr val="EFF6FF"/>
+            </a:solidFill>
+            <a:prstDash val="solid"/>
+          </a:ln>
+        </p:spPr>
+      </p:sp>
+      <p:sp>
+        <p:nvSpPr>
+          <p:cNvPr id="10" name="C2Title"/>
+          <p:cNvSpPr/>
+          <p:nvPr/>
+        </p:nvSpPr>
+        <p:spPr>
+          <a:xfrm>
+            <a:off x="4762000" y="1320000"/>
+            <a:ext cx="3824800" cy="300000"/>
+          </a:xfrm>
+          <a:prstGeom prst="rect">
+            <a:avLst/>
+          </a:prstGeom>
+          <a:noFill/>
+          <a:ln/>
+        </p:spPr>
+        <p:txBody>
+          <a:bodyPr wrap="square" lIns="45720" tIns="45720" rIns="45720" bIns="45720" rtlCol="0" anchor="t"/>
+          <a:lstStyle/>
+          <a:p>
+            <a:pPr indent="0" marL="0">
+              <a:buNone/>
+            </a:pPr>
+            <a:r>
+              <a:rPr lang="pt-BR" sz="1400" b="1" dirty="0">
+                <a:solidFill>
+                  <a:srgbClr val="1D4ED8"/>
+                </a:solidFill>
+                <a:latin typeface="Calibri" pitchFamily="34" charset="0"/>
+              </a:rPr>
+              <a:t>📷 Imagens e Capturas de Tela</a:t>
+            </a:r>
+            <a:endParaRPr lang="pt-BR" sz="1400" dirty="0"/>
+          </a:p>
+        </p:txBody>
+      </p:sp>
+      <p:sp>
+        <p:nvSpPr>
+          <p:cNvPr id="11" name="C2Body"/>
+          <p:cNvSpPr/>
+          <p:nvPr/>
+        </p:nvSpPr>
+        <p:spPr>
+          <a:xfrm>
+            <a:off x="4762000" y="1670000"/>
+            <a:ext cx="3824800" cy="1261750"/>
+          </a:xfrm>
+          <a:prstGeom prst="rect">
+            <a:avLst/>
+          </a:prstGeom>
+          <a:noFill/>
+          <a:ln/>
+        </p:spPr>
+        <p:txBody>
+          <a:bodyPr wrap="square" lIns="45720" tIns="45720" rIns="45720" bIns="45720" rtlCol="0" anchor="t"/>
+          <a:lstStyle/>
+          <a:p>
+            <a:pPr indent="0" marL="0">
+              <a:buNone/>
+            </a:pPr>
+            <a:r>
+              <a:rPr lang="pt-BR" sz="1150" dirty="0">
+                <a:solidFill>
+                  <a:srgbClr val="374151"/>
+                </a:solidFill>
+                <a:latin typeface="Calibri" pitchFamily="34" charset="0"/>
+              </a:rPr>
+              <a:t>Insira imagens pelo botao 📷 ou cole direto da area de transferencia (Ctrl+V). Suporta prints de tela, fotos e prints de documentos.</a:t>
+            </a:r>
+            <a:endParaRPr lang="pt-BR" sz="1150" dirty="0"/>
+          </a:p>
+        </p:txBody>
+      </p:sp>
+      <p:sp>
+        <p:nvSpPr>
+          <p:cNvPr id="12" name="C3BG"/>
+          <p:cNvSpPr/>
+          <p:nvPr/>
+        </p:nvSpPr>
+        <p:spPr>
+          <a:xfrm>
+            <a:off x="457200" y="3211750"/>
+            <a:ext cx="4024800" cy="1811750"/>
+          </a:xfrm>
+          <a:prstGeom prst="roundRect">
+            <a:avLst>
+              <a:gd name="adj" fmla="val 4082"/>
+            </a:avLst>
+          </a:prstGeom>
+          <a:solidFill>
+            <a:srgbClr val="FFFBEB"/>
+          </a:solidFill>
+          <a:ln w="12700">
+            <a:solidFill>
+              <a:srgbClr val="FFFBEB"/>
+            </a:solidFill>
+            <a:prstDash val="solid"/>
+          </a:ln>
+        </p:spPr>
+      </p:sp>
+      <p:sp>
+        <p:nvSpPr>
+          <p:cNvPr id="13" name="C3Title"/>
+          <p:cNvSpPr/>
+          <p:nvPr/>
+        </p:nvSpPr>
+        <p:spPr>
+          <a:xfrm>
+            <a:off x="557200" y="3311750"/>
+            <a:ext cx="3824800" cy="300000"/>
+          </a:xfrm>
+          <a:prstGeom prst="rect">
+            <a:avLst/>
+          </a:prstGeom>
+          <a:noFill/>
+          <a:ln/>
+        </p:spPr>
+        <p:txBody>
+          <a:bodyPr wrap="square" lIns="45720" tIns="45720" rIns="45720" bIns="45720" rtlCol="0" anchor="t"/>
+          <a:lstStyle/>
+          <a:p>
+            <a:pPr indent="0" marL="0">
+              <a:buNone/>
+            </a:pPr>
+            <a:r>
+              <a:rPr lang="pt-BR" sz="1400" b="1" dirty="0">
+                <a:solidFill>
+                  <a:srgbClr val="D97706"/>
+                </a:solidFill>
+                <a:latin typeface="Calibri" pitchFamily="34" charset="0"/>
+              </a:rPr>
+              <a:t>🔗 Links e Referencias</a:t>
+            </a:r>
+            <a:endParaRPr lang="pt-BR" sz="1400" dirty="0"/>
+          </a:p>
+        </p:txBody>
+      </p:sp>
+      <p:sp>
+        <p:nvSpPr>
+          <p:cNvPr id="14" name="C3Body"/>
+          <p:cNvSpPr/>
+          <p:nvPr/>
+        </p:nvSpPr>
+        <p:spPr>
+          <a:xfrm>
+            <a:off x="557200" y="3661750"/>
+            <a:ext cx="3824800" cy="1261750"/>
+          </a:xfrm>
+          <a:prstGeom prst="rect">
+            <a:avLst/>
+          </a:prstGeom>
+          <a:noFill/>
+          <a:ln/>
+        </p:spPr>
+        <p:txBody>
+          <a:bodyPr wrap="square" lIns="45720" tIns="45720" rIns="45720" bIns="45720" rtlCol="0" anchor="t"/>
+          <a:lstStyle/>
+          <a:p>
+            <a:pPr indent="0" marL="0">
+              <a:buNone/>
+            </a:pPr>
+            <a:r>
+              <a:rPr lang="pt-BR" sz="1150" dirty="0">
+                <a:solidFill>
+                  <a:srgbClr val="374151"/>
+                </a:solidFill>
+                <a:latin typeface="Calibri" pitchFamily="34" charset="0"/>
+              </a:rPr>
+              <a:t>Insira links para documentos externos, propostas ou sistemas. O botao 🔗 abre um campo para digitar a URL e o texto do link.</a:t>
+            </a:r>
+            <a:endParaRPr lang="pt-BR" sz="1150" dirty="0"/>
+          </a:p>
+        </p:txBody>
+      </p:sp>
+      <p:sp>
+        <p:nvSpPr>
+          <p:cNvPr id="15" name="C4BG"/>
+          <p:cNvSpPr/>
+          <p:nvPr/>
+        </p:nvSpPr>
+        <p:spPr>
+          <a:xfrm>
+            <a:off x="4662000" y="3211750"/>
+            <a:ext cx="4024800" cy="1811750"/>
+          </a:xfrm>
+          <a:prstGeom prst="roundRect">
+            <a:avLst>
+              <a:gd name="adj" fmla="val 4082"/>
+            </a:avLst>
+          </a:prstGeom>
+          <a:solidFill>
+            <a:srgbClr val="F5F3FF"/>
+          </a:solidFill>
+          <a:ln w="12700">
+            <a:solidFill>
+              <a:srgbClr val="F5F3FF"/>
+            </a:solidFill>
+            <a:prstDash val="solid"/>
+          </a:ln>
+        </p:spPr>
+      </p:sp>
+      <p:sp>
+        <p:nvSpPr>
+          <p:cNvPr id="16" name="C4Title"/>
+          <p:cNvSpPr/>
+          <p:nvPr/>
+        </p:nvSpPr>
+        <p:spPr>
+          <a:xfrm>
+            <a:off x="4762000" y="3311750"/>
+            <a:ext cx="3824800" cy="300000"/>
+          </a:xfrm>
+          <a:prstGeom prst="rect">
+            <a:avLst/>
+          </a:prstGeom>
+          <a:noFill/>
+          <a:ln/>
+        </p:spPr>
+        <p:txBody>
+          <a:bodyPr wrap="square" lIns="45720" tIns="45720" rIns="45720" bIns="45720" rtlCol="0" anchor="t"/>
+          <a:lstStyle/>
+          <a:p>
+            <a:pPr indent="0" marL="0">
+              <a:buNone/>
+            </a:pPr>
+            <a:r>
+              <a:rPr lang="pt-BR" sz="1400" b="1" dirty="0">
+                <a:solidFill>
+                  <a:srgbClr val="7C3AED"/>
+                </a:solidFill>
+                <a:latin typeface="Calibri" pitchFamily="34" charset="0"/>
+              </a:rPr>
+              <a:t>💾 Salvo por Aba e Negocio</a:t>
+            </a:r>
+            <a:endParaRPr lang="pt-BR" sz="1400" dirty="0"/>
+          </a:p>
+        </p:txBody>
+      </p:sp>
+      <p:sp>
+        <p:nvSpPr>
+          <p:cNvPr id="17" name="C4Body"/>
+          <p:cNvSpPr/>
+          <p:nvPr/>
+        </p:nvSpPr>
+        <p:spPr>
+          <a:xfrm>
+            <a:off x="4762000" y="3661750"/>
+            <a:ext cx="3824800" cy="1261750"/>
+          </a:xfrm>
+          <a:prstGeom prst="rect">
+            <a:avLst/>
+          </a:prstGeom>
+          <a:noFill/>
+          <a:ln/>
+        </p:spPr>
+        <p:txBody>
+          <a:bodyPr wrap="square" lIns="45720" tIns="45720" rIns="45720" bIns="45720" rtlCol="0" anchor="t"/>
+          <a:lstStyle/>
+          <a:p>
+            <a:pPr indent="0" marL="0">
+              <a:buNone/>
+            </a:pPr>
+            <a:r>
+              <a:rPr lang="pt-BR" sz="1150" dirty="0">
+                <a:solidFill>
+                  <a:srgbClr val="374151"/>
+                </a:solidFill>
+                <a:latin typeface="Calibri" pitchFamily="34" charset="0"/>
+              </a:rPr>
+              <a:t>Cada aba do CRM tem sua propria Area Livre independente. O conteudo e salvo e carregado automaticamente ao reabrir o negocio.</a:t>
+            </a:r>
+            <a:endParaRPr lang="pt-BR" sz="1150" dirty="0"/>
+          </a:p>
+        </p:txBody>
+      </p:sp>
+    </p:spTree>
+  </p:cSld>
+  <p:clrMapOvr>
+    <a:masterClrMapping/>
+  </p:clrMapOvr>
+</p:sld>
+</file>
+
+<file path=ppt/slides/slide37.xml><?xml version="1.0" encoding="utf-8"?>
+<p:sld xmlns:a="http://schemas.openxmlformats.org/drawingml/2006/main" xmlns:r="http://schemas.openxmlformats.org/officeDocument/2006/relationships" xmlns:p="http://schemas.openxmlformats.org/presentationml/2006/main">
+  <p:cSld name="Slide CRM Modal">
+    <p:spTree>
+      <p:nvGrpSpPr>
+        <p:cNvPr id="1" name=""/>
+        <p:cNvGrpSpPr/>
+        <p:nvPr/>
+      </p:nvGrpSpPr>
+      <p:grpSpPr>
+        <a:xfrm>
+          <a:off x="0" y="0"/>
+          <a:ext cx="0" cy="0"/>
+          <a:chOff x="0" y="0"/>
+          <a:chExt cx="0" cy="0"/>
+        </a:xfrm>
+      </p:grpSpPr>
+      <p:sp>
+        <p:nvSpPr>
+          <p:cNvPr id="2" name="BG"/>
+          <p:cNvSpPr/>
+          <p:nvPr/>
+        </p:nvSpPr>
+        <p:spPr>
+          <a:xfrm>
+            <a:off x="0" y="0"/>
+            <a:ext cx="9144000" cy="5143500"/>
+          </a:xfrm>
+          <a:prstGeom prst="rect">
+            <a:avLst/>
+          </a:prstGeom>
+          <a:solidFill>
+            <a:srgbClr val="FFFFFF"/>
+          </a:solidFill>
+          <a:ln w="12700">
+            <a:solidFill>
+              <a:srgbClr val="FFFFFF"/>
+            </a:solidFill>
+            <a:prstDash val="solid"/>
+          </a:ln>
+        </p:spPr>
+      </p:sp>
+      <p:sp>
+        <p:nvSpPr>
+          <p:cNvPr id="3" name="ModLabel"/>
+          <p:cNvSpPr/>
+          <p:nvPr/>
+        </p:nvSpPr>
+        <p:spPr>
+          <a:xfrm>
+            <a:off x="457200" y="182880"/>
+            <a:ext cx="7315200" cy="201168"/>
+          </a:xfrm>
+          <a:prstGeom prst="rect">
+            <a:avLst/>
+          </a:prstGeom>
+          <a:noFill/>
+          <a:ln/>
+        </p:spPr>
+        <p:txBody>
+          <a:bodyPr wrap="square" lIns="45720" tIns="45720" rIns="45720" bIns="45720" rtlCol="0" anchor="t"/>
+          <a:lstStyle/>
+          <a:p>
+            <a:pPr indent="0" marL="0">
+              <a:buNone/>
+            </a:pPr>
+            <a:r>
+              <a:rPr lang="pt-BR" sz="950" b="1" dirty="0">
+                <a:solidFill>
+                  <a:srgbClr val="94A3B8"/>
+                </a:solidFill>
+                <a:latin typeface="Calibri" pitchFamily="34" charset="0"/>
+              </a:rPr>
+              <a:t>MODULO CRM</a:t>
+            </a:r>
+            <a:endParaRPr lang="pt-BR" sz="950" dirty="0"/>
+          </a:p>
+        </p:txBody>
+      </p:sp>
+      <p:sp>
+        <p:nvSpPr>
+          <p:cNvPr id="4" name="Title"/>
+          <p:cNvSpPr/>
+          <p:nvPr/>
+        </p:nvSpPr>
+        <p:spPr>
+          <a:xfrm>
+            <a:off x="457200" y="384048"/>
+            <a:ext cx="8229600" cy="480000"/>
+          </a:xfrm>
+          <a:prstGeom prst="rect">
+            <a:avLst/>
+          </a:prstGeom>
+          <a:noFill/>
+          <a:ln/>
+        </p:spPr>
+        <p:txBody>
+          <a:bodyPr wrap="square" lIns="45720" tIns="45720" rIns="45720" bIns="45720" rtlCol="0" anchor="ctr"/>
+          <a:lstStyle/>
+          <a:p>
+            <a:pPr indent="0" marL="0">
+              <a:buNone/>
+            </a:pPr>
+            <a:r>
+              <a:rPr lang="pt-BR" sz="3000" b="1" dirty="0">
+                <a:solidFill>
+                  <a:srgbClr val="166534"/>
+                </a:solidFill>
+                <a:latin typeface="Cambria" pitchFamily="34" charset="0"/>
+              </a:rPr>
+              <a:t>CRM — Modal Abrir (📂) e 9 Abas</a:t>
+            </a:r>
+            <a:endParaRPr lang="pt-BR" sz="3000" dirty="0"/>
+          </a:p>
+        </p:txBody>
+      </p:sp>
+      <p:sp>
+        <p:nvSpPr>
+          <p:cNvPr id="5" name="LeftBG"/>
+          <p:cNvSpPr/>
+          <p:nvPr/>
+        </p:nvSpPr>
+        <p:spPr>
+          <a:xfrm>
+            <a:off x="457200" y="1000000"/>
+            <a:ext cx="3200000" cy="4023500"/>
+          </a:xfrm>
+          <a:prstGeom prst="roundRect">
+            <a:avLst>
+              <a:gd name="adj" fmla="val 4082"/>
+            </a:avLst>
+          </a:prstGeom>
+          <a:solidFill>
+            <a:srgbClr val="F0FDF4"/>
+          </a:solidFill>
+          <a:ln w="12700">
+            <a:solidFill>
+              <a:srgbClr val="F0FDF4"/>
+            </a:solidFill>
+            <a:prstDash val="solid"/>
+          </a:ln>
+        </p:spPr>
+      </p:sp>
+      <p:sp>
+        <p:nvSpPr>
+          <p:cNvPr id="6" name="LeftTitle"/>
+          <p:cNvSpPr/>
+          <p:nvPr/>
+        </p:nvSpPr>
+        <p:spPr>
+          <a:xfrm>
+            <a:off x="547200" y="1110000"/>
+            <a:ext cx="3020000" cy="330000"/>
+          </a:xfrm>
+          <a:prstGeom prst="rect">
+            <a:avLst/>
+          </a:prstGeom>
+          <a:noFill/>
+          <a:ln/>
+        </p:spPr>
+        <p:txBody>
+          <a:bodyPr wrap="square" lIns="45720" tIns="45720" rIns="45720" bIns="45720" rtlCol="0" anchor="t"/>
+          <a:lstStyle/>
+          <a:p>
+            <a:pPr indent="0" marL="0">
+              <a:buNone/>
+            </a:pPr>
+            <a:r>
+              <a:rPr lang="pt-BR" sz="1400" b="1" dirty="0">
+                <a:solidFill>
+                  <a:srgbClr val="166534"/>
+                </a:solidFill>
+                <a:latin typeface="Calibri" pitchFamily="34" charset="0"/>
+              </a:rPr>
+              <a:t>📂 O que e o Modal Abrir</a:t>
+            </a:r>
+            <a:endParaRPr lang="pt-BR" sz="1400" dirty="0"/>
+          </a:p>
+        </p:txBody>
+      </p:sp>
+      <p:sp>
+        <p:nvSpPr>
+          <p:cNvPr id="7" name="LI7"/>
+          <p:cNvSpPr/>
+          <p:nvPr/>
+        </p:nvSpPr>
+        <p:spPr>
+          <a:xfrm>
+            <a:off x="547200" y="1530000"/>
+            <a:ext cx="3020000" cy="330000"/>
+          </a:xfrm>
+          <a:prstGeom prst="rect">
+            <a:avLst/>
+          </a:prstGeom>
+          <a:noFill/>
+          <a:ln/>
+        </p:spPr>
+        <p:txBody>
+          <a:bodyPr wrap="square" lIns="45720" tIns="45720" rIns="45720" bIns="45720" rtlCol="0" anchor="t"/>
+          <a:lstStyle/>
+          <a:p>
+            <a:pPr indent="0" marL="0">
+              <a:buNone/>
+            </a:pPr>
+            <a:r>
+              <a:rPr lang="pt-BR" sz="1100" dirty="0">
+                <a:solidFill>
+                  <a:srgbClr val="1E293B"/>
+                </a:solidFill>
+                <a:latin typeface="Calibri" pitchFamily="34" charset="0"/>
+              </a:rPr>
+              <a:t>Clique em 📂 Abrir em qualquer card do CRM Kanban para abrir o painel completo do negocio.</a:t>
+            </a:r>
+            <a:endParaRPr lang="pt-BR" sz="1100" dirty="0"/>
+          </a:p>
+        </p:txBody>
+      </p:sp>
+      <p:sp>
+        <p:nvSpPr>
+          <p:cNvPr id="8" name="LI8"/>
+          <p:cNvSpPr/>
+          <p:nvPr/>
+        </p:nvSpPr>
+        <p:spPr>
+          <a:xfrm>
+            <a:off x="547200" y="1910000"/>
+            <a:ext cx="3020000" cy="330000"/>
+          </a:xfrm>
+          <a:prstGeom prst="rect">
+            <a:avLst/>
+          </a:prstGeom>
+          <a:noFill/>
+          <a:ln/>
+        </p:spPr>
+        <p:txBody>
+          <a:bodyPr wrap="square" lIns="45720" tIns="45720" rIns="45720" bIns="45720" rtlCol="0" anchor="t"/>
+          <a:lstStyle/>
+          <a:p>
+            <a:pPr indent="0" marL="0">
+              <a:buNone/>
+            </a:pPr>
+            <a:r>
+              <a:rPr lang="pt-BR" sz="1100" dirty="0">
+                <a:solidFill>
+                  <a:srgbClr val="374151"/>
+                </a:solidFill>
+                <a:latin typeface="Calibri" pitchFamily="34" charset="0"/>
+              </a:rPr>
+              <a:t>Layout dividido: formulario de dados a esquerda + abas de historico a direita.</a:t>
+            </a:r>
+            <a:endParaRPr lang="pt-BR" sz="1100" dirty="0"/>
+          </a:p>
+        </p:txBody>
+      </p:sp>
+      <p:sp>
+        <p:nvSpPr>
+          <p:cNvPr id="9" name="LI9"/>
+          <p:cNvSpPr/>
+          <p:nvPr/>
+        </p:nvSpPr>
+        <p:spPr>
+          <a:xfrm>
+            <a:off x="547200" y="2290000"/>
+            <a:ext cx="3020000" cy="330000"/>
+          </a:xfrm>
+          <a:prstGeom prst="rect">
+            <a:avLst/>
+          </a:prstGeom>
+          <a:noFill/>
+          <a:ln/>
+        </p:spPr>
+        <p:txBody>
+          <a:bodyPr wrap="square" lIns="45720" tIns="45720" rIns="45720" bIns="45720" rtlCol="0" anchor="t"/>
+          <a:lstStyle/>
+          <a:p>
+            <a:pPr indent="0" marL="0">
+              <a:buNone/>
+            </a:pPr>
+            <a:r>
+              <a:rPr lang="pt-BR" sz="1100" dirty="0">
+                <a:solidFill>
+                  <a:srgbClr val="374151"/>
+                </a:solidFill>
+                <a:latin typeface="Calibri" pitchFamily="34" charset="0"/>
+              </a:rPr>
+              <a:t>Navegue entre as 9 abas sem fechar o modal.</a:t>
+            </a:r>
+            <a:endParaRPr lang="pt-BR" sz="1100" dirty="0"/>
+          </a:p>
+        </p:txBody>
+      </p:sp>
+      <p:sp>
+        <p:nvSpPr>
+          <p:cNvPr id="10" name="LI10"/>
+          <p:cNvSpPr/>
+          <p:nvPr/>
+        </p:nvSpPr>
+        <p:spPr>
+          <a:xfrm>
+            <a:off x="547200" y="2670000"/>
+            <a:ext cx="3020000" cy="330000"/>
+          </a:xfrm>
+          <a:prstGeom prst="rect">
+            <a:avLst/>
+          </a:prstGeom>
+          <a:noFill/>
+          <a:ln/>
+        </p:spPr>
+        <p:txBody>
+          <a:bodyPr wrap="square" lIns="45720" tIns="45720" rIns="45720" bIns="45720" rtlCol="0" anchor="t"/>
+          <a:lstStyle/>
+          <a:p>
+            <a:pPr indent="0" marL="0">
+              <a:buNone/>
+            </a:pPr>
+            <a:r>
+              <a:rPr lang="pt-BR" sz="1100" dirty="0">
+                <a:solidFill>
+                  <a:srgbClr val="374151"/>
+                </a:solidFill>
+                <a:latin typeface="Calibri" pitchFamily="34" charset="0"/>
+              </a:rPr>
+              <a:t>Todas as informacoes do negocio em uma unica tela.</a:t>
+            </a:r>
+            <a:endParaRPr lang="pt-BR" sz="1100" dirty="0"/>
+          </a:p>
+        </p:txBody>
+      </p:sp>
+      <p:sp>
+        <p:nvSpPr>
+          <p:cNvPr id="11" name="HlBG"/>
+          <p:cNvSpPr/>
+          <p:nvPr/>
+        </p:nvSpPr>
+        <p:spPr>
+          <a:xfrm>
+            <a:off x="547200" y="4523500"/>
+            <a:ext cx="3020000" cy="400000"/>
+          </a:xfrm>
+          <a:prstGeom prst="roundRect">
+            <a:avLst>
+              <a:gd name="adj" fmla="val 4082"/>
+            </a:avLst>
+          </a:prstGeom>
+          <a:solidFill>
+            <a:srgbClr val="DCFCE7"/>
+          </a:solidFill>
+          <a:ln w="12700">
+            <a:solidFill>
+              <a:srgbClr val="DCFCE7"/>
+            </a:solidFill>
+            <a:prstDash val="solid"/>
+          </a:ln>
+        </p:spPr>
+      </p:sp>
+      <p:sp>
+        <p:nvSpPr>
+          <p:cNvPr id="12" name="HlTxt"/>
+          <p:cNvSpPr/>
+          <p:nvPr/>
+        </p:nvSpPr>
+        <p:spPr>
+          <a:xfrm>
+            <a:off x="597200" y="4603500"/>
+            <a:ext cx="2920000" cy="260000"/>
+          </a:xfrm>
+          <a:prstGeom prst="rect">
+            <a:avLst/>
+          </a:prstGeom>
+          <a:noFill/>
+          <a:ln/>
+        </p:spPr>
+        <p:txBody>
+          <a:bodyPr wrap="square" lIns="45720" tIns="45720" rIns="45720" bIns="45720" rtlCol="0" anchor="t"/>
+          <a:lstStyle/>
+          <a:p>
+            <a:pPr indent="0" marL="0">
+              <a:buNone/>
+            </a:pPr>
+            <a:r>
+              <a:rPr lang="pt-BR" sz="1050" b="1" dirty="0">
+                <a:solidFill>
+                  <a:srgbClr val="15803D"/>
+                </a:solidFill>
+                <a:latin typeface="Calibri" pitchFamily="34" charset="0"/>
+              </a:rPr>
+              <a:t>Atalho: clique duas vezes no card para abrir rapidamente.</a:t>
+            </a:r>
+            <a:endParaRPr lang="pt-BR" sz="1050" dirty="0"/>
+          </a:p>
+        </p:txBody>
+      </p:sp>
+      <p:sp>
+        <p:nvSpPr>
+          <p:cNvPr id="13" name="RightBG"/>
+          <p:cNvSpPr/>
+          <p:nvPr/>
+        </p:nvSpPr>
+        <p:spPr>
+          <a:xfrm>
+            <a:off x="3857200" y="1000000"/>
+            <a:ext cx="4829600" cy="4023500"/>
+          </a:xfrm>
+          <a:prstGeom prst="roundRect">
+            <a:avLst>
+              <a:gd name="adj" fmla="val 4082"/>
+            </a:avLst>
+          </a:prstGeom>
+          <a:solidFill>
+            <a:srgbClr val="F8FAFC"/>
+          </a:solidFill>
+          <a:ln w="12700">
+            <a:solidFill>
+              <a:srgbClr val="F8FAFC"/>
+            </a:solidFill>
+            <a:prstDash val="solid"/>
+          </a:ln>
+        </p:spPr>
+      </p:sp>
+      <p:sp>
+        <p:nvSpPr>
+          <p:cNvPr id="14" name="RightTitle"/>
+          <p:cNvSpPr/>
+          <p:nvPr/>
+        </p:nvSpPr>
+        <p:spPr>
+          <a:xfrm>
+            <a:off x="3947200" y="1110000"/>
+            <a:ext cx="4649600" cy="300000"/>
+          </a:xfrm>
+          <a:prstGeom prst="rect">
+            <a:avLst/>
+          </a:prstGeom>
+          <a:noFill/>
+          <a:ln/>
+        </p:spPr>
+        <p:txBody>
+          <a:bodyPr wrap="square" lIns="45720" tIns="45720" rIns="45720" bIns="45720" rtlCol="0" anchor="t"/>
+          <a:lstStyle/>
+          <a:p>
+            <a:pPr indent="0" marL="0">
+              <a:buNone/>
+            </a:pPr>
+            <a:r>
+              <a:rPr lang="pt-BR" sz="1400" b="1" dirty="0">
+                <a:solidFill>
+                  <a:srgbClr val="0369A1"/>
+                </a:solidFill>
+                <a:latin typeface="Calibri" pitchFamily="34" charset="0"/>
+              </a:rPr>
+              <a:t>9 Abas disponiveis no painel direito</a:t>
+            </a:r>
+            <a:endParaRPr lang="pt-BR" sz="1400" dirty="0"/>
+          </a:p>
+        </p:txBody>
+      </p:sp>
+      <p:sp>
+        <p:nvSpPr>
+          <p:cNvPr id="15" name="Tab0BG"/>
+          <p:cNvSpPr/>
+          <p:nvPr/>
+        </p:nvSpPr>
+        <p:spPr>
+          <a:xfrm>
+            <a:off x="3947200" y="1500000"/>
+            <a:ext cx="1496533" cy="1084500"/>
+          </a:xfrm>
+          <a:prstGeom prst="roundRect">
+            <a:avLst>
+              <a:gd name="adj" fmla="val 4082"/>
+            </a:avLst>
+          </a:prstGeom>
+          <a:solidFill>
+            <a:srgbClr val="EFF6FF"/>
+          </a:solidFill>
+          <a:ln w="12700">
+            <a:solidFill>
+              <a:srgbClr val="EFF6FF"/>
+            </a:solidFill>
+            <a:prstDash val="solid"/>
+          </a:ln>
+        </p:spPr>
+      </p:sp>
+      <p:sp>
+        <p:nvSpPr>
+          <p:cNvPr id="16" name="Tab0Name"/>
+          <p:cNvSpPr/>
+          <p:nvPr/>
+        </p:nvSpPr>
+        <p:spPr>
+          <a:xfrm>
+            <a:off x="4007200" y="1560000"/>
+            <a:ext cx="1376533" cy="250000"/>
+          </a:xfrm>
+          <a:prstGeom prst="rect">
+            <a:avLst/>
+          </a:prstGeom>
+          <a:noFill/>
+          <a:ln/>
+        </p:spPr>
+        <p:txBody>
+          <a:bodyPr wrap="square" lIns="45720" tIns="45720" rIns="45720" bIns="45720" rtlCol="0" anchor="t"/>
+          <a:lstStyle/>
+          <a:p>
+            <a:pPr indent="0" marL="0">
+              <a:buNone/>
+            </a:pPr>
+            <a:r>
+              <a:rPr lang="pt-BR" sz="1100" b="1" dirty="0">
+                <a:solidFill>
+                  <a:srgbClr val="1D4ED8"/>
+                </a:solidFill>
+                <a:latin typeface="Calibri" pitchFamily="34" charset="0"/>
+              </a:rPr>
+              <a:t>📋 Andamento</a:t>
+            </a:r>
+            <a:endParaRPr lang="pt-BR" sz="1100" dirty="0"/>
+          </a:p>
+        </p:txBody>
+      </p:sp>
+      <p:sp>
+        <p:nvSpPr>
+          <p:cNvPr id="17" name="Tab0Desc"/>
+          <p:cNvSpPr/>
+          <p:nvPr/>
+        </p:nvSpPr>
+        <p:spPr>
+          <a:xfrm>
+            <a:off x="4007200" y="1810000"/>
+            <a:ext cx="1376533" cy="704500"/>
+          </a:xfrm>
+          <a:prstGeom prst="rect">
+            <a:avLst/>
+          </a:prstGeom>
+          <a:noFill/>
+          <a:ln/>
+        </p:spPr>
+        <p:txBody>
+          <a:bodyPr wrap="square" lIns="45720" tIns="45720" rIns="45720" bIns="45720" rtlCol="0" anchor="t"/>
+          <a:lstStyle/>
+          <a:p>
+            <a:pPr indent="0" marL="0">
+              <a:buNone/>
+            </a:pPr>
+            <a:r>
+              <a:rPr lang="pt-BR" sz="950" dirty="0">
+                <a:solidFill>
+                  <a:srgbClr val="475569"/>
+                </a:solidFill>
+                <a:latin typeface="Calibri" pitchFamily="34" charset="0"/>
+              </a:rPr>
+              <a:t>Timeline e status do negocio</a:t>
+            </a:r>
+            <a:endParaRPr lang="pt-BR" sz="950" dirty="0"/>
+          </a:p>
+        </p:txBody>
+      </p:sp>
+      <p:sp>
+        <p:nvSpPr>
+          <p:cNvPr id="18" name="Tab1BG"/>
+          <p:cNvSpPr/>
+          <p:nvPr/>
+        </p:nvSpPr>
+        <p:spPr>
+          <a:xfrm>
+            <a:off x="5523733" y="1500000"/>
+            <a:ext cx="1496533" cy="1084500"/>
+          </a:xfrm>
+          <a:prstGeom prst="roundRect">
+            <a:avLst>
+              <a:gd name="adj" fmla="val 4082"/>
+            </a:avLst>
+          </a:prstGeom>
+          <a:solidFill>
+            <a:srgbClr val="FEF9C3"/>
+          </a:solidFill>
+          <a:ln w="12700">
+            <a:solidFill>
+              <a:srgbClr val="FEF9C3"/>
+            </a:solidFill>
+            <a:prstDash val="solid"/>
+          </a:ln>
+        </p:spPr>
+      </p:sp>
+      <p:sp>
+        <p:nvSpPr>
+          <p:cNvPr id="19" name="Tab1Name"/>
+          <p:cNvSpPr/>
+          <p:nvPr/>
+        </p:nvSpPr>
+        <p:spPr>
+          <a:xfrm>
+            <a:off x="5583733" y="1560000"/>
+            <a:ext cx="1376533" cy="250000"/>
+          </a:xfrm>
+          <a:prstGeom prst="rect">
+            <a:avLst/>
+          </a:prstGeom>
+          <a:noFill/>
+          <a:ln/>
+        </p:spPr>
+        <p:txBody>
+          <a:bodyPr wrap="square" lIns="45720" tIns="45720" rIns="45720" bIns="45720" rtlCol="0" anchor="t"/>
+          <a:lstStyle/>
+          <a:p>
+            <a:pPr indent="0" marL="0">
+              <a:buNone/>
+            </a:pPr>
+            <a:r>
+              <a:rPr lang="pt-BR" sz="1100" b="1" dirty="0">
+                <a:solidFill>
+                  <a:srgbClr val="CA8A04"/>
+                </a:solidFill>
+                <a:latin typeface="Calibri" pitchFamily="34" charset="0"/>
+              </a:rPr>
+              <a:t>⚖️ Processo</a:t>
+            </a:r>
+            <a:endParaRPr lang="pt-BR" sz="1100" dirty="0"/>
+          </a:p>
+        </p:txBody>
+      </p:sp>
+      <p:sp>
+        <p:nvSpPr>
+          <p:cNvPr id="20" name="Tab1Desc"/>
+          <p:cNvSpPr/>
+          <p:nvPr/>
+        </p:nvSpPr>
+        <p:spPr>
+          <a:xfrm>
+            <a:off x="5583733" y="1810000"/>
+            <a:ext cx="1376533" cy="704500"/>
+          </a:xfrm>
+          <a:prstGeom prst="rect">
+            <a:avLst/>
+          </a:prstGeom>
+          <a:noFill/>
+          <a:ln/>
+        </p:spPr>
+        <p:txBody>
+          <a:bodyPr wrap="square" lIns="45720" tIns="45720" rIns="45720" bIns="45720" rtlCol="0" anchor="t"/>
+          <a:lstStyle/>
+          <a:p>
+            <a:pPr indent="0" marL="0">
+              <a:buNone/>
+            </a:pPr>
+            <a:r>
+              <a:rPr lang="pt-BR" sz="950" dirty="0">
+                <a:solidFill>
+                  <a:srgbClr val="475569"/>
+                </a:solidFill>
+                <a:latin typeface="Calibri" pitchFamily="34" charset="0"/>
+              </a:rPr>
+              <a:t>Dados juridicos e contratuais</a:t>
+            </a:r>
+            <a:endParaRPr lang="pt-BR" sz="950" dirty="0"/>
+          </a:p>
+        </p:txBody>
+      </p:sp>
+      <p:sp>
+        <p:nvSpPr>
+          <p:cNvPr id="21" name="Tab2BG"/>
+          <p:cNvSpPr/>
+          <p:nvPr/>
+        </p:nvSpPr>
+        <p:spPr>
+          <a:xfrm>
+            <a:off x="7100266" y="1500000"/>
+            <a:ext cx="1496533" cy="1084500"/>
+          </a:xfrm>
+          <a:prstGeom prst="roundRect">
+            <a:avLst>
+              <a:gd name="adj" fmla="val 4082"/>
+            </a:avLst>
+          </a:prstGeom>
+          <a:solidFill>
+            <a:srgbClr val="FEE2E2"/>
+          </a:solidFill>
+          <a:ln w="12700">
+            <a:solidFill>
+              <a:srgbClr val="FEE2E2"/>
+            </a:solidFill>
+            <a:prstDash val="solid"/>
+          </a:ln>
+        </p:spPr>
+      </p:sp>
+      <p:sp>
+        <p:nvSpPr>
+          <p:cNvPr id="22" name="Tab2Name"/>
+          <p:cNvSpPr/>
+          <p:nvPr/>
+        </p:nvSpPr>
+        <p:spPr>
+          <a:xfrm>
+            <a:off x="7160266" y="1560000"/>
+            <a:ext cx="1376533" cy="250000"/>
+          </a:xfrm>
+          <a:prstGeom prst="rect">
+            <a:avLst/>
+          </a:prstGeom>
+          <a:noFill/>
+          <a:ln/>
+        </p:spPr>
+        <p:txBody>
+          <a:bodyPr wrap="square" lIns="45720" tIns="45720" rIns="45720" bIns="45720" rtlCol="0" anchor="t"/>
+          <a:lstStyle/>
+          <a:p>
+            <a:pPr indent="0" marL="0">
+              <a:buNone/>
+            </a:pPr>
+            <a:r>
+              <a:rPr lang="pt-BR" sz="1100" b="1" dirty="0">
+                <a:solidFill>
+                  <a:srgbClr val="DC2626"/>
+                </a:solidFill>
+                <a:latin typeface="Calibri" pitchFamily="34" charset="0"/>
+              </a:rPr>
+              <a:t>🛡️ Impugnacoes</a:t>
+            </a:r>
+            <a:endParaRPr lang="pt-BR" sz="1100" dirty="0"/>
+          </a:p>
+        </p:txBody>
+      </p:sp>
+      <p:sp>
+        <p:nvSpPr>
+          <p:cNvPr id="23" name="Tab2Desc"/>
+          <p:cNvSpPr/>
+          <p:nvPr/>
+        </p:nvSpPr>
+        <p:spPr>
+          <a:xfrm>
+            <a:off x="7160266" y="1810000"/>
+            <a:ext cx="1376533" cy="704500"/>
+          </a:xfrm>
+          <a:prstGeom prst="rect">
+            <a:avLst/>
+          </a:prstGeom>
+          <a:noFill/>
+          <a:ln/>
+        </p:spPr>
+        <p:txBody>
+          <a:bodyPr wrap="square" lIns="45720" tIns="45720" rIns="45720" bIns="45720" rtlCol="0" anchor="t"/>
+          <a:lstStyle/>
+          <a:p>
+            <a:pPr indent="0" marL="0">
+              <a:buNone/>
+            </a:pPr>
+            <a:r>
+              <a:rPr lang="pt-BR" sz="950" dirty="0">
+                <a:solidFill>
+                  <a:srgbClr val="475569"/>
+                </a:solidFill>
+                <a:latin typeface="Calibri" pitchFamily="34" charset="0"/>
+              </a:rPr>
+              <a:t>Recursos e contestacoes</a:t>
+            </a:r>
+            <a:endParaRPr lang="pt-BR" sz="950" dirty="0"/>
+          </a:p>
+        </p:txBody>
+      </p:sp>
+      <p:sp>
+        <p:nvSpPr>
+          <p:cNvPr id="24" name="Tab3BG"/>
+          <p:cNvSpPr/>
+          <p:nvPr/>
+        </p:nvSpPr>
+        <p:spPr>
+          <a:xfrm>
+            <a:off x="3947200" y="2664500"/>
+            <a:ext cx="1496533" cy="1084500"/>
+          </a:xfrm>
+          <a:prstGeom prst="roundRect">
+            <a:avLst>
+              <a:gd name="adj" fmla="val 4082"/>
+            </a:avLst>
+          </a:prstGeom>
+          <a:solidFill>
+            <a:srgbClr val="F0FDF4"/>
+          </a:solidFill>
+          <a:ln w="12700">
+            <a:solidFill>
+              <a:srgbClr val="F0FDF4"/>
+            </a:solidFill>
+            <a:prstDash val="solid"/>
+          </a:ln>
+        </p:spPr>
+      </p:sp>
+      <p:sp>
+        <p:nvSpPr>
+          <p:cNvPr id="25" name="Tab3Name"/>
+          <p:cNvSpPr/>
+          <p:nvPr/>
+        </p:nvSpPr>
+        <p:spPr>
+          <a:xfrm>
+            <a:off x="4007200" y="2724500"/>
+            <a:ext cx="1376533" cy="250000"/>
+          </a:xfrm>
+          <a:prstGeom prst="rect">
+            <a:avLst/>
+          </a:prstGeom>
+          <a:noFill/>
+          <a:ln/>
+        </p:spPr>
+        <p:txBody>
+          <a:bodyPr wrap="square" lIns="45720" tIns="45720" rIns="45720" bIns="45720" rtlCol="0" anchor="t"/>
+          <a:lstStyle/>
+          <a:p>
+            <a:pPr indent="0" marL="0">
+              <a:buNone/>
+            </a:pPr>
+            <a:r>
+              <a:rPr lang="pt-BR" sz="1100" b="1" dirty="0">
+                <a:solidFill>
+                  <a:srgbClr val="16A34A"/>
+                </a:solidFill>
+                <a:latin typeface="Calibri" pitchFamily="34" charset="0"/>
+              </a:rPr>
+              <a:t>📁 Recursos</a:t>
+            </a:r>
+            <a:endParaRPr lang="pt-BR" sz="1100" dirty="0"/>
+          </a:p>
+        </p:txBody>
+      </p:sp>
+      <p:sp>
+        <p:nvSpPr>
+          <p:cNvPr id="26" name="Tab3Desc"/>
+          <p:cNvSpPr/>
+          <p:nvPr/>
+        </p:nvSpPr>
+        <p:spPr>
+          <a:xfrm>
+            <a:off x="4007200" y="2974500"/>
+            <a:ext cx="1376533" cy="704500"/>
+          </a:xfrm>
+          <a:prstGeom prst="rect">
+            <a:avLst/>
+          </a:prstGeom>
+          <a:noFill/>
+          <a:ln/>
+        </p:spPr>
+        <p:txBody>
+          <a:bodyPr wrap="square" lIns="45720" tIns="45720" rIns="45720" bIns="45720" rtlCol="0" anchor="t"/>
+          <a:lstStyle/>
+          <a:p>
+            <a:pPr indent="0" marL="0">
+              <a:buNone/>
+            </a:pPr>
+            <a:r>
+              <a:rPr lang="pt-BR" sz="950" dirty="0">
+                <a:solidFill>
+                  <a:srgbClr val="475569"/>
+                </a:solidFill>
+                <a:latin typeface="Calibri" pitchFamily="34" charset="0"/>
+              </a:rPr>
+              <a:t>Documentos de recurso</a:t>
+            </a:r>
+            <a:endParaRPr lang="pt-BR" sz="950" dirty="0"/>
+          </a:p>
+        </p:txBody>
+      </p:sp>
+      <p:sp>
+        <p:nvSpPr>
+          <p:cNvPr id="27" name="Tab4BG"/>
+          <p:cNvSpPr/>
+          <p:nvPr/>
+        </p:nvSpPr>
+        <p:spPr>
+          <a:xfrm>
+            <a:off x="5523733" y="2664500"/>
+            <a:ext cx="1496533" cy="1084500"/>
+          </a:xfrm>
+          <a:prstGeom prst="roundRect">
+            <a:avLst>
+              <a:gd name="adj" fmla="val 4082"/>
+            </a:avLst>
+          </a:prstGeom>
+          <a:solidFill>
+            <a:srgbClr val="EFF6FF"/>
+          </a:solidFill>
+          <a:ln w="12700">
+            <a:solidFill>
+              <a:srgbClr val="EFF6FF"/>
+            </a:solidFill>
+            <a:prstDash val="solid"/>
+          </a:ln>
+        </p:spPr>
+      </p:sp>
+      <p:sp>
+        <p:nvSpPr>
+          <p:cNvPr id="28" name="Tab4Name"/>
+          <p:cNvSpPr/>
+          <p:nvPr/>
+        </p:nvSpPr>
+        <p:spPr>
+          <a:xfrm>
+            <a:off x="5583733" y="2724500"/>
+            <a:ext cx="1376533" cy="250000"/>
+          </a:xfrm>
+          <a:prstGeom prst="rect">
+            <a:avLst/>
+          </a:prstGeom>
+          <a:noFill/>
+          <a:ln/>
+        </p:spPr>
+        <p:txBody>
+          <a:bodyPr wrap="square" lIns="45720" tIns="45720" rIns="45720" bIns="45720" rtlCol="0" anchor="t"/>
+          <a:lstStyle/>
+          <a:p>
+            <a:pPr indent="0" marL="0">
+              <a:buNone/>
+            </a:pPr>
+            <a:r>
+              <a:rPr lang="pt-BR" sz="1100" b="1" dirty="0">
+                <a:solidFill>
+                  <a:srgbClr val="1D4ED8"/>
+                </a:solidFill>
+                <a:latin typeface="Calibri" pitchFamily="34" charset="0"/>
+              </a:rPr>
+              <a:t>📄 Contratos</a:t>
+            </a:r>
+            <a:endParaRPr lang="pt-BR" sz="1100" dirty="0"/>
+          </a:p>
+        </p:txBody>
+      </p:sp>
+      <p:sp>
+        <p:nvSpPr>
+          <p:cNvPr id="29" name="Tab4Desc"/>
+          <p:cNvSpPr/>
+          <p:nvPr/>
+        </p:nvSpPr>
+        <p:spPr>
+          <a:xfrm>
+            <a:off x="5583733" y="2974500"/>
+            <a:ext cx="1376533" cy="704500"/>
+          </a:xfrm>
+          <a:prstGeom prst="rect">
+            <a:avLst/>
+          </a:prstGeom>
+          <a:noFill/>
+          <a:ln/>
+        </p:spPr>
+        <p:txBody>
+          <a:bodyPr wrap="square" lIns="45720" tIns="45720" rIns="45720" bIns="45720" rtlCol="0" anchor="t"/>
+          <a:lstStyle/>
+          <a:p>
+            <a:pPr indent="0" marL="0">
+              <a:buNone/>
+            </a:pPr>
+            <a:r>
+              <a:rPr lang="pt-BR" sz="950" dirty="0">
+                <a:solidFill>
+                  <a:srgbClr val="475569"/>
+                </a:solidFill>
+                <a:latin typeface="Calibri" pitchFamily="34" charset="0"/>
+              </a:rPr>
+              <a:t>Contratos assinados</a:t>
+            </a:r>
+            <a:endParaRPr lang="pt-BR" sz="950" dirty="0"/>
+          </a:p>
+        </p:txBody>
+      </p:sp>
+      <p:sp>
+        <p:nvSpPr>
+          <p:cNvPr id="30" name="Tab5BG"/>
+          <p:cNvSpPr/>
+          <p:nvPr/>
+        </p:nvSpPr>
+        <p:spPr>
+          <a:xfrm>
+            <a:off x="7100266" y="2664500"/>
+            <a:ext cx="1496533" cy="1084500"/>
+          </a:xfrm>
+          <a:prstGeom prst="roundRect">
+            <a:avLst>
+              <a:gd name="adj" fmla="val 4082"/>
+            </a:avLst>
+          </a:prstGeom>
+          <a:solidFill>
+            <a:srgbClr val="FFFBEB"/>
+          </a:solidFill>
+          <a:ln w="12700">
+            <a:solidFill>
+              <a:srgbClr val="FFFBEB"/>
+            </a:solidFill>
+            <a:prstDash val="solid"/>
+          </a:ln>
+        </p:spPr>
+      </p:sp>
+      <p:sp>
+        <p:nvSpPr>
+          <p:cNvPr id="31" name="Tab5Name"/>
+          <p:cNvSpPr/>
+          <p:nvPr/>
+        </p:nvSpPr>
+        <p:spPr>
+          <a:xfrm>
+            <a:off x="7160266" y="2724500"/>
+            <a:ext cx="1376533" cy="250000"/>
+          </a:xfrm>
+          <a:prstGeom prst="rect">
+            <a:avLst/>
+          </a:prstGeom>
+          <a:noFill/>
+          <a:ln/>
+        </p:spPr>
+        <p:txBody>
+          <a:bodyPr wrap="square" lIns="45720" tIns="45720" rIns="45720" bIns="45720" rtlCol="0" anchor="t"/>
+          <a:lstStyle/>
+          <a:p>
+            <a:pPr indent="0" marL="0">
+              <a:buNone/>
+            </a:pPr>
+            <a:r>
+              <a:rPr lang="pt-BR" sz="1100" b="1" dirty="0">
+                <a:solidFill>
+                  <a:srgbClr val="D97706"/>
+                </a:solidFill>
+                <a:latin typeface="Calibri" pitchFamily="34" charset="0"/>
+              </a:rPr>
+              <a:t>💰 Empenhos</a:t>
+            </a:r>
+            <a:endParaRPr lang="pt-BR" sz="1100" dirty="0"/>
+          </a:p>
+        </p:txBody>
+      </p:sp>
+      <p:sp>
+        <p:nvSpPr>
+          <p:cNvPr id="32" name="Tab5Desc"/>
+          <p:cNvSpPr/>
+          <p:nvPr/>
+        </p:nvSpPr>
+        <p:spPr>
+          <a:xfrm>
+            <a:off x="7160266" y="2974500"/>
+            <a:ext cx="1376533" cy="704500"/>
+          </a:xfrm>
+          <a:prstGeom prst="rect">
+            <a:avLst/>
+          </a:prstGeom>
+          <a:noFill/>
+          <a:ln/>
+        </p:spPr>
+        <p:txBody>
+          <a:bodyPr wrap="square" lIns="45720" tIns="45720" rIns="45720" bIns="45720" rtlCol="0" anchor="t"/>
+          <a:lstStyle/>
+          <a:p>
+            <a:pPr indent="0" marL="0">
+              <a:buNone/>
+            </a:pPr>
+            <a:r>
+              <a:rPr lang="pt-BR" sz="950" dirty="0">
+                <a:solidFill>
+                  <a:srgbClr val="475569"/>
+                </a:solidFill>
+                <a:latin typeface="Calibri" pitchFamily="34" charset="0"/>
+              </a:rPr>
+              <a:t>Empenhos emitidos</a:t>
+            </a:r>
+            <a:endParaRPr lang="pt-BR" sz="950" dirty="0"/>
+          </a:p>
+        </p:txBody>
+      </p:sp>
+      <p:sp>
+        <p:nvSpPr>
+          <p:cNvPr id="33" name="Tab6BG"/>
+          <p:cNvSpPr/>
+          <p:nvPr/>
+        </p:nvSpPr>
+        <p:spPr>
+          <a:xfrm>
+            <a:off x="3947200" y="3829000"/>
+            <a:ext cx="1496533" cy="1084500"/>
+          </a:xfrm>
+          <a:prstGeom prst="roundRect">
+            <a:avLst>
+              <a:gd name="adj" fmla="val 4082"/>
+            </a:avLst>
+          </a:prstGeom>
+          <a:solidFill>
+            <a:srgbClr val="F5F3FF"/>
+          </a:solidFill>
+          <a:ln w="12700">
+            <a:solidFill>
+              <a:srgbClr val="F5F3FF"/>
+            </a:solidFill>
+            <a:prstDash val="solid"/>
+          </a:ln>
+        </p:spPr>
+      </p:sp>
+      <p:sp>
+        <p:nvSpPr>
+          <p:cNvPr id="34" name="Tab6Name"/>
+          <p:cNvSpPr/>
+          <p:nvPr/>
+        </p:nvSpPr>
+        <p:spPr>
+          <a:xfrm>
+            <a:off x="4007200" y="3889000"/>
+            <a:ext cx="1376533" cy="250000"/>
+          </a:xfrm>
+          <a:prstGeom prst="rect">
+            <a:avLst/>
+          </a:prstGeom>
+          <a:noFill/>
+          <a:ln/>
+        </p:spPr>
+        <p:txBody>
+          <a:bodyPr wrap="square" lIns="45720" tIns="45720" rIns="45720" bIns="45720" rtlCol="0" anchor="t"/>
+          <a:lstStyle/>
+          <a:p>
+            <a:pPr indent="0" marL="0">
+              <a:buNone/>
+            </a:pPr>
+            <a:r>
+              <a:rPr lang="pt-BR" sz="1100" b="1" dirty="0">
+                <a:solidFill>
+                  <a:srgbClr val="7C3AED"/>
+                </a:solidFill>
+                <a:latin typeface="Calibri" pitchFamily="34" charset="0"/>
+              </a:rPr>
+              <a:t>🗂️ Doc.Terceiros</a:t>
+            </a:r>
+            <a:endParaRPr lang="pt-BR" sz="1100" dirty="0"/>
+          </a:p>
+        </p:txBody>
+      </p:sp>
+      <p:sp>
+        <p:nvSpPr>
+          <p:cNvPr id="35" name="Tab6Desc"/>
+          <p:cNvSpPr/>
+          <p:nvPr/>
+        </p:nvSpPr>
+        <p:spPr>
+          <a:xfrm>
+            <a:off x="4007200" y="4139000"/>
+            <a:ext cx="1376533" cy="704500"/>
+          </a:xfrm>
+          <a:prstGeom prst="rect">
+            <a:avLst/>
+          </a:prstGeom>
+          <a:noFill/>
+          <a:ln/>
+        </p:spPr>
+        <p:txBody>
+          <a:bodyPr wrap="square" lIns="45720" tIns="45720" rIns="45720" bIns="45720" rtlCol="0" anchor="t"/>
+          <a:lstStyle/>
+          <a:p>
+            <a:pPr indent="0" marL="0">
+              <a:buNone/>
+            </a:pPr>
+            <a:r>
+              <a:rPr lang="pt-BR" sz="950" dirty="0">
+                <a:solidFill>
+                  <a:srgbClr val="475569"/>
+                </a:solidFill>
+                <a:latin typeface="Calibri" pitchFamily="34" charset="0"/>
+              </a:rPr>
+              <a:t>Docs de parceiros</a:t>
+            </a:r>
+            <a:endParaRPr lang="pt-BR" sz="950" dirty="0"/>
+          </a:p>
+        </p:txBody>
+      </p:sp>
+      <p:sp>
+        <p:nvSpPr>
+          <p:cNvPr id="36" name="Tab7BG"/>
+          <p:cNvSpPr/>
+          <p:nvPr/>
+        </p:nvSpPr>
+        <p:spPr>
+          <a:xfrm>
+            <a:off x="5523733" y="3829000"/>
+            <a:ext cx="1496533" cy="1084500"/>
+          </a:xfrm>
+          <a:prstGeom prst="roundRect">
+            <a:avLst>
+              <a:gd name="adj" fmla="val 4082"/>
+            </a:avLst>
+          </a:prstGeom>
+          <a:solidFill>
+            <a:srgbClr val="FFF7ED"/>
+          </a:solidFill>
+          <a:ln w="12700">
+            <a:solidFill>
+              <a:srgbClr val="FFF7ED"/>
+            </a:solidFill>
+            <a:prstDash val="solid"/>
+          </a:ln>
+        </p:spPr>
+      </p:sp>
+      <p:sp>
+        <p:nvSpPr>
+          <p:cNvPr id="37" name="Tab7Name"/>
+          <p:cNvSpPr/>
+          <p:nvPr/>
+        </p:nvSpPr>
+        <p:spPr>
+          <a:xfrm>
+            <a:off x="5583733" y="3889000"/>
+            <a:ext cx="1376533" cy="250000"/>
+          </a:xfrm>
+          <a:prstGeom prst="rect">
+            <a:avLst/>
+          </a:prstGeom>
+          <a:noFill/>
+          <a:ln/>
+        </p:spPr>
+        <p:txBody>
+          <a:bodyPr wrap="square" lIns="45720" tIns="45720" rIns="45720" bIns="45720" rtlCol="0" anchor="t"/>
+          <a:lstStyle/>
+          <a:p>
+            <a:pPr indent="0" marL="0">
+              <a:buNone/>
+            </a:pPr>
+            <a:r>
+              <a:rPr lang="pt-BR" sz="1100" b="1" dirty="0">
+                <a:solidFill>
+                  <a:srgbClr val="EA580C"/>
+                </a:solidFill>
+                <a:latin typeface="Calibri" pitchFamily="34" charset="0"/>
+              </a:rPr>
+              <a:t>🔭 Prospeccoes</a:t>
+            </a:r>
+            <a:endParaRPr lang="pt-BR" sz="1100" dirty="0"/>
+          </a:p>
+        </p:txBody>
+      </p:sp>
+      <p:sp>
+        <p:nvSpPr>
+          <p:cNvPr id="38" name="Tab7Desc"/>
+          <p:cNvSpPr/>
+          <p:nvPr/>
+        </p:nvSpPr>
+        <p:spPr>
+          <a:xfrm>
+            <a:off x="5583733" y="4139000"/>
+            <a:ext cx="1376533" cy="704500"/>
+          </a:xfrm>
+          <a:prstGeom prst="rect">
+            <a:avLst/>
+          </a:prstGeom>
+          <a:noFill/>
+          <a:ln/>
+        </p:spPr>
+        <p:txBody>
+          <a:bodyPr wrap="square" lIns="45720" tIns="45720" rIns="45720" bIns="45720" rtlCol="0" anchor="t"/>
+          <a:lstStyle/>
+          <a:p>
+            <a:pPr indent="0" marL="0">
+              <a:buNone/>
+            </a:pPr>
+            <a:r>
+              <a:rPr lang="pt-BR" sz="950" dirty="0">
+                <a:solidFill>
+                  <a:srgbClr val="475569"/>
+                </a:solidFill>
+                <a:latin typeface="Calibri" pitchFamily="34" charset="0"/>
+              </a:rPr>
+              <a:t>Oportunidades futuras</a:t>
+            </a:r>
+            <a:endParaRPr lang="pt-BR" sz="950" dirty="0"/>
+          </a:p>
+        </p:txBody>
+      </p:sp>
+      <p:sp>
+        <p:nvSpPr>
+          <p:cNvPr id="39" name="Tab8BG"/>
+          <p:cNvSpPr/>
+          <p:nvPr/>
+        </p:nvSpPr>
+        <p:spPr>
+          <a:xfrm>
+            <a:off x="7100266" y="3829000"/>
+            <a:ext cx="1496533" cy="1084500"/>
+          </a:xfrm>
+          <a:prstGeom prst="roundRect">
+            <a:avLst>
+              <a:gd name="adj" fmla="val 4082"/>
+            </a:avLst>
+          </a:prstGeom>
+          <a:solidFill>
+            <a:srgbClr val="F0FDF4"/>
+          </a:solidFill>
+          <a:ln w="12700">
+            <a:solidFill>
+              <a:srgbClr val="F0FDF4"/>
+            </a:solidFill>
+            <a:prstDash val="solid"/>
+          </a:ln>
+        </p:spPr>
+      </p:sp>
+      <p:sp>
+        <p:nvSpPr>
+          <p:cNvPr id="40" name="Tab8Name"/>
+          <p:cNvSpPr/>
+          <p:nvPr/>
+        </p:nvSpPr>
+        <p:spPr>
+          <a:xfrm>
+            <a:off x="7160266" y="3889000"/>
+            <a:ext cx="1376533" cy="250000"/>
+          </a:xfrm>
+          <a:prstGeom prst="rect">
+            <a:avLst/>
+          </a:prstGeom>
+          <a:noFill/>
+          <a:ln/>
+        </p:spPr>
+        <p:txBody>
+          <a:bodyPr wrap="square" lIns="45720" tIns="45720" rIns="45720" bIns="45720" rtlCol="0" anchor="t"/>
+          <a:lstStyle/>
+          <a:p>
+            <a:pPr indent="0" marL="0">
+              <a:buNone/>
+            </a:pPr>
+            <a:r>
+              <a:rPr lang="pt-BR" sz="1100" b="1" dirty="0">
+                <a:solidFill>
+                  <a:srgbClr val="15803D"/>
+                </a:solidFill>
+                <a:latin typeface="Calibri" pitchFamily="34" charset="0"/>
+              </a:rPr>
+              <a:t>📊 Analise</a:t>
+            </a:r>
+            <a:endParaRPr lang="pt-BR" sz="1100" dirty="0"/>
+          </a:p>
+        </p:txBody>
+      </p:sp>
+      <p:sp>
+        <p:nvSpPr>
+          <p:cNvPr id="41" name="Tab8Desc"/>
+          <p:cNvSpPr/>
+          <p:nvPr/>
+        </p:nvSpPr>
+        <p:spPr>
+          <a:xfrm>
+            <a:off x="7160266" y="4139000"/>
+            <a:ext cx="1376533" cy="704500"/>
+          </a:xfrm>
+          <a:prstGeom prst="rect">
+            <a:avLst/>
+          </a:prstGeom>
+          <a:noFill/>
+          <a:ln/>
+        </p:spPr>
+        <p:txBody>
+          <a:bodyPr wrap="square" lIns="45720" tIns="45720" rIns="45720" bIns="45720" rtlCol="0" anchor="t"/>
+          <a:lstStyle/>
+          <a:p>
+            <a:pPr indent="0" marL="0">
+              <a:buNone/>
+            </a:pPr>
+            <a:r>
+              <a:rPr lang="pt-BR" sz="950" dirty="0">
+                <a:solidFill>
+                  <a:srgbClr val="475569"/>
+                </a:solidFill>
+                <a:latin typeface="Calibri" pitchFamily="34" charset="0"/>
+              </a:rPr>
+              <a:t>Analise tecnica e orcamento</a:t>
+            </a:r>
+            <a:endParaRPr lang="pt-BR" sz="950" dirty="0"/>
+          </a:p>
+        </p:txBody>
+      </p:sp>
+    </p:spTree>
+  </p:cSld>
+  <p:clrMapOvr>
+    <a:masterClrMapping/>
+  </p:clrMapOvr>
+</p:sld>
+</file>
+
+<file path=ppt/slides/slide38.xml><?xml version="1.0" encoding="utf-8"?>
+<p:sld xmlns:a="http://schemas.openxmlformats.org/drawingml/2006/main" xmlns:r="http://schemas.openxmlformats.org/officeDocument/2006/relationships" xmlns:p="http://schemas.openxmlformats.org/presentationml/2006/main">
+  <p:cSld name="Slide Avisos Permissoes">
+    <p:spTree>
+      <p:nvGrpSpPr>
+        <p:cNvPr id="1" name=""/>
+        <p:cNvGrpSpPr/>
+        <p:nvPr/>
+      </p:nvGrpSpPr>
+      <p:grpSpPr>
+        <a:xfrm>
+          <a:off x="0" y="0"/>
+          <a:ext cx="0" cy="0"/>
+          <a:chOff x="0" y="0"/>
+          <a:chExt cx="0" cy="0"/>
+        </a:xfrm>
+      </p:grpSpPr>
+      <p:sp>
+        <p:nvSpPr>
+          <p:cNvPr id="2" name="BG"/>
+          <p:cNvSpPr/>
+          <p:nvPr/>
+        </p:nvSpPr>
+        <p:spPr>
+          <a:xfrm>
+            <a:off x="0" y="0"/>
+            <a:ext cx="9144000" cy="5143500"/>
+          </a:xfrm>
+          <a:prstGeom prst="rect">
+            <a:avLst/>
+          </a:prstGeom>
+          <a:solidFill>
+            <a:srgbClr val="FFFFFF"/>
+          </a:solidFill>
+          <a:ln w="12700">
+            <a:solidFill>
+              <a:srgbClr val="FFFFFF"/>
+            </a:solidFill>
+            <a:prstDash val="solid"/>
+          </a:ln>
+        </p:spPr>
+      </p:sp>
+      <p:sp>
+        <p:nvSpPr>
+          <p:cNvPr id="3" name="ModLabel"/>
+          <p:cNvSpPr/>
+          <p:nvPr/>
+        </p:nvSpPr>
+        <p:spPr>
+          <a:xfrm>
+            <a:off x="457200" y="182880"/>
+            <a:ext cx="7315200" cy="201168"/>
+          </a:xfrm>
+          <a:prstGeom prst="rect">
+            <a:avLst/>
+          </a:prstGeom>
+          <a:noFill/>
+          <a:ln/>
+        </p:spPr>
+        <p:txBody>
+          <a:bodyPr wrap="square" lIns="45720" tIns="45720" rIns="45720" bIns="45720" rtlCol="0" anchor="t"/>
+          <a:lstStyle/>
+          <a:p>
+            <a:pPr indent="0" marL="0">
+              <a:buNone/>
+            </a:pPr>
+            <a:r>
+              <a:rPr lang="pt-BR" sz="950" b="1" dirty="0">
+                <a:solidFill>
+                  <a:srgbClr val="94A3B8"/>
+                </a:solidFill>
+                <a:latin typeface="Calibri" pitchFamily="34" charset="0"/>
+              </a:rPr>
+              <a:t>RECURSOS ESPECIAIS</a:t>
+            </a:r>
+            <a:endParaRPr lang="pt-BR" sz="950" dirty="0"/>
+          </a:p>
+        </p:txBody>
+      </p:sp>
+      <p:sp>
+        <p:nvSpPr>
+          <p:cNvPr id="4" name="Title"/>
+          <p:cNvSpPr/>
+          <p:nvPr/>
+        </p:nvSpPr>
+        <p:spPr>
+          <a:xfrm>
+            <a:off x="457200" y="384048"/>
+            <a:ext cx="8229600" cy="480000"/>
+          </a:xfrm>
+          <a:prstGeom prst="rect">
+            <a:avLst/>
+          </a:prstGeom>
+          <a:noFill/>
+          <a:ln/>
+        </p:spPr>
+        <p:txBody>
+          <a:bodyPr wrap="square" lIns="45720" tIns="45720" rIns="45720" bIns="45720" rtlCol="0" anchor="ctr"/>
+          <a:lstStyle/>
+          <a:p>
+            <a:pPr indent="0" marL="0">
+              <a:buNone/>
+            </a:pPr>
+            <a:r>
+              <a:rPr lang="pt-BR" sz="3000" b="1" dirty="0">
+                <a:solidFill>
+                  <a:srgbClr val="166534"/>
+                </a:solidFill>
+                <a:latin typeface="Cambria" pitchFamily="34" charset="0"/>
+              </a:rPr>
+              <a:t>Avisos do Sistema — Publicacao e Permissoes</a:t>
+            </a:r>
+            <a:endParaRPr lang="pt-BR" sz="3000" dirty="0"/>
+          </a:p>
+        </p:txBody>
+      </p:sp>
+      <p:sp>
+        <p:nvSpPr>
+          <p:cNvPr id="5" name="Col1BG"/>
+          <p:cNvSpPr/>
+          <p:nvPr/>
+        </p:nvSpPr>
+        <p:spPr>
+          <a:xfrm>
+            <a:off x="457200" y="1000000"/>
+            <a:ext cx="4000500" cy="4023500"/>
+          </a:xfrm>
+          <a:prstGeom prst="roundRect">
+            <a:avLst>
+              <a:gd name="adj" fmla="val 4082"/>
+            </a:avLst>
+          </a:prstGeom>
+          <a:solidFill>
+            <a:srgbClr val="F0FDF4"/>
+          </a:solidFill>
+          <a:ln w="12700">
+            <a:solidFill>
+              <a:srgbClr val="F0FDF4"/>
+            </a:solidFill>
+            <a:prstDash val="solid"/>
+          </a:ln>
+        </p:spPr>
+      </p:sp>
+      <p:sp>
+        <p:nvSpPr>
+          <p:cNvPr id="6" name="Col1Title"/>
+          <p:cNvSpPr/>
+          <p:nvPr/>
+        </p:nvSpPr>
+        <p:spPr>
+          <a:xfrm>
+            <a:off x="547200" y="1110000"/>
+            <a:ext cx="3820500" cy="330000"/>
+          </a:xfrm>
+          <a:prstGeom prst="rect">
+            <a:avLst/>
+          </a:prstGeom>
+          <a:noFill/>
+          <a:ln/>
+        </p:spPr>
+        <p:txBody>
+          <a:bodyPr wrap="square" lIns="45720" tIns="45720" rIns="45720" bIns="45720" rtlCol="0" anchor="t"/>
+          <a:lstStyle/>
+          <a:p>
+            <a:pPr indent="0" marL="0">
+              <a:buNone/>
+            </a:pPr>
+            <a:r>
+              <a:rPr lang="pt-BR" sz="1500" b="1" dirty="0">
+                <a:solidFill>
+                  <a:srgbClr val="166534"/>
+                </a:solidFill>
+                <a:latin typeface="Calibri" pitchFamily="34" charset="0"/>
+              </a:rPr>
+              <a:t>📢 Como Publicar um Aviso</a:t>
+            </a:r>
+            <a:endParaRPr lang="pt-BR" sz="1500" dirty="0"/>
+          </a:p>
+        </p:txBody>
+      </p:sp>
+      <p:sp>
+        <p:nvSpPr>
+          <p:cNvPr id="7" name="PermBG"/>
+          <p:cNvSpPr/>
+          <p:nvPr/>
+        </p:nvSpPr>
+        <p:spPr>
+          <a:xfrm>
+            <a:off x="547200" y="1520000"/>
+            <a:ext cx="3820500" cy="480000"/>
+          </a:xfrm>
+          <a:prstGeom prst="roundRect">
+            <a:avLst>
+              <a:gd name="adj" fmla="val 4082"/>
+            </a:avLst>
+          </a:prstGeom>
+          <a:solidFill>
+            <a:srgbClr val="DCFCE7"/>
+          </a:solidFill>
+          <a:ln w="12700">
+            <a:solidFill>
+              <a:srgbClr val="DCFCE7"/>
+            </a:solidFill>
+            <a:prstDash val="solid"/>
+          </a:ln>
+        </p:spPr>
+      </p:sp>
+      <p:sp>
+        <p:nvSpPr>
+          <p:cNvPr id="8" name="PermTitle"/>
+          <p:cNvSpPr/>
+          <p:nvPr/>
+        </p:nvSpPr>
+        <p:spPr>
+          <a:xfrm>
+            <a:off x="607200" y="1580000"/>
+            <a:ext cx="3700500" cy="240000"/>
+          </a:xfrm>
+          <a:prstGeom prst="rect">
+            <a:avLst/>
+          </a:prstGeom>
+          <a:noFill/>
+          <a:ln/>
+        </p:spPr>
+        <p:txBody>
+          <a:bodyPr wrap="square" lIns="45720" tIns="45720" rIns="45720" bIns="45720" rtlCol="0" anchor="t"/>
+          <a:lstStyle/>
+          <a:p>
+            <a:pPr indent="0" marL="0">
+              <a:buNone/>
+            </a:pPr>
+            <a:r>
+              <a:rPr lang="pt-BR" sz="1200" b="1" dirty="0">
+                <a:solidFill>
+                  <a:srgbClr val="15803D"/>
+                </a:solidFill>
+                <a:latin typeface="Calibri" pitchFamily="34" charset="0"/>
+              </a:rPr>
+              <a:t>🔑 Quem pode publicar</a:t>
+            </a:r>
+            <a:endParaRPr lang="pt-BR" sz="1200" dirty="0"/>
+          </a:p>
+        </p:txBody>
+      </p:sp>
+      <p:sp>
+        <p:nvSpPr>
+          <p:cNvPr id="9" name="PermBody"/>
+          <p:cNvSpPr/>
+          <p:nvPr/>
+        </p:nvSpPr>
+        <p:spPr>
+          <a:xfrm>
+            <a:off x="607200" y="1810000"/>
+            <a:ext cx="3700500" cy="190000"/>
+          </a:xfrm>
+          <a:prstGeom prst="rect">
+            <a:avLst/>
+          </a:prstGeom>
+          <a:noFill/>
+          <a:ln/>
+        </p:spPr>
+        <p:txBody>
+          <a:bodyPr wrap="square" lIns="45720" tIns="45720" rIns="45720" bIns="45720" rtlCol="0" anchor="t"/>
+          <a:lstStyle/>
+          <a:p>
+            <a:pPr indent="0" marL="0">
+              <a:buNone/>
+            </a:pPr>
+            <a:r>
+              <a:rPr lang="pt-BR" sz="1050" dirty="0">
+                <a:solidFill>
+                  <a:srgbClr val="166534"/>
+                </a:solidFill>
+                <a:latin typeface="Calibri" pitchFamily="34" charset="0"/>
+              </a:rPr>
+              <a:t>Usuarios com permissao pode_enviar_avisos ativada no Admin, ou perfil Admin.</a:t>
+            </a:r>
+            <a:endParaRPr lang="pt-BR" sz="1050" dirty="0"/>
+          </a:p>
+        </p:txBody>
+      </p:sp>
+      <p:sp>
+        <p:nvSpPr>
+          <p:cNvPr id="10" name="Step10"/>
+          <p:cNvSpPr/>
+          <p:nvPr/>
+        </p:nvSpPr>
+        <p:spPr>
+          <a:xfrm>
+            <a:off x="547200" y="2120000"/>
+            <a:ext cx="3820500" cy="240000"/>
+          </a:xfrm>
+          <a:prstGeom prst="rect">
+            <a:avLst/>
+          </a:prstGeom>
+          <a:noFill/>
+          <a:ln/>
+        </p:spPr>
+        <p:txBody>
+          <a:bodyPr wrap="square" lIns="45720" tIns="45720" rIns="45720" bIns="45720" rtlCol="0" anchor="t"/>
+          <a:lstStyle/>
+          <a:p>
+            <a:pPr indent="0" marL="0">
+              <a:buNone/>
+            </a:pPr>
+            <a:r>
+              <a:rPr lang="pt-BR" sz="1200" b="1" dirty="0">
+                <a:solidFill>
+                  <a:srgbClr val="16A34A"/>
+                </a:solidFill>
+                <a:latin typeface="Calibri" pitchFamily="34" charset="0"/>
+              </a:rPr>
+              <a:t>1.</a:t>
+            </a:r>
+            <a:endParaRPr lang="pt-BR" sz="1200" dirty="0"/>
+          </a:p>
+        </p:txBody>
+      </p:sp>
+      <p:sp>
+        <p:nvSpPr>
+          <p:cNvPr id="11" name="StepTxt11"/>
+          <p:cNvSpPr/>
+          <p:nvPr/>
+        </p:nvSpPr>
+        <p:spPr>
+          <a:xfrm>
+            <a:off x="697200" y="2120000"/>
+            <a:ext cx="3660500" cy="240000"/>
+          </a:xfrm>
+          <a:prstGeom prst="rect">
+            <a:avLst/>
+          </a:prstGeom>
+          <a:noFill/>
+          <a:ln/>
+        </p:spPr>
+        <p:txBody>
+          <a:bodyPr wrap="square" lIns="45720" tIns="45720" rIns="45720" bIns="45720" rtlCol="0" anchor="t"/>
+          <a:lstStyle/>
+          <a:p>
+            <a:pPr indent="0" marL="0">
+              <a:buNone/>
+            </a:pPr>
+            <a:r>
+              <a:rPr lang="pt-BR" sz="1150" dirty="0">
+                <a:solidFill>
+                  <a:srgbClr val="1E293B"/>
+                </a:solidFill>
+                <a:latin typeface="Calibri" pitchFamily="34" charset="0"/>
+              </a:rPr>
+              <a:t>Clique no botao + verde no cabecalho do widget</a:t>
+            </a:r>
+            <a:endParaRPr lang="pt-BR" sz="1150" dirty="0"/>
+          </a:p>
+        </p:txBody>
+      </p:sp>
+      <p:sp>
+        <p:nvSpPr>
+          <p:cNvPr id="12" name="Step12"/>
+          <p:cNvSpPr/>
+          <p:nvPr/>
+        </p:nvSpPr>
+        <p:spPr>
+          <a:xfrm>
+            <a:off x="547200" y="2410000"/>
+            <a:ext cx="3820500" cy="240000"/>
+          </a:xfrm>
+          <a:prstGeom prst="rect">
+            <a:avLst/>
+          </a:prstGeom>
+          <a:noFill/>
+          <a:ln/>
+        </p:spPr>
+        <p:txBody>
+          <a:bodyPr wrap="square" lIns="45720" tIns="45720" rIns="45720" bIns="45720" rtlCol="0" anchor="t"/>
+          <a:lstStyle/>
+          <a:p>
+            <a:pPr indent="0" marL="0">
+              <a:buNone/>
+            </a:pPr>
+            <a:r>
+              <a:rPr lang="pt-BR" sz="1200" b="1" dirty="0">
+                <a:solidFill>
+                  <a:srgbClr val="16A34A"/>
+                </a:solidFill>
+                <a:latin typeface="Calibri" pitchFamily="34" charset="0"/>
+              </a:rPr>
+              <a:t>2.</a:t>
+            </a:r>
+            <a:endParaRPr lang="pt-BR" sz="1200" dirty="0"/>
+          </a:p>
+        </p:txBody>
+      </p:sp>
+      <p:sp>
+        <p:nvSpPr>
+          <p:cNvPr id="13" name="StepTxt13"/>
+          <p:cNvSpPr/>
+          <p:nvPr/>
+        </p:nvSpPr>
+        <p:spPr>
+          <a:xfrm>
+            <a:off x="697200" y="2410000"/>
+            <a:ext cx="3660500" cy="240000"/>
+          </a:xfrm>
+          <a:prstGeom prst="rect">
+            <a:avLst/>
+          </a:prstGeom>
+          <a:noFill/>
+          <a:ln/>
+        </p:spPr>
+        <p:txBody>
+          <a:bodyPr wrap="square" lIns="45720" tIns="45720" rIns="45720" bIns="45720" rtlCol="0" anchor="t"/>
+          <a:lstStyle/>
+          <a:p>
+            <a:pPr indent="0" marL="0">
+              <a:buNone/>
+            </a:pPr>
+            <a:r>
+              <a:rPr lang="pt-BR" sz="1150" dirty="0">
+                <a:solidFill>
+                  <a:srgbClr val="1E293B"/>
+                </a:solidFill>
+                <a:latin typeface="Calibri" pitchFamily="34" charset="0"/>
+              </a:rPr>
+              <a:t>Preencha titulo, mensagem, tipo e criticidade</a:t>
+            </a:r>
+            <a:endParaRPr lang="pt-BR" sz="1150" dirty="0"/>
+          </a:p>
+        </p:txBody>
+      </p:sp>
+      <p:sp>
+        <p:nvSpPr>
+          <p:cNvPr id="14" name="Step14"/>
+          <p:cNvSpPr/>
+          <p:nvPr/>
+        </p:nvSpPr>
+        <p:spPr>
+          <a:xfrm>
+            <a:off x="547200" y="2700000"/>
+            <a:ext cx="3820500" cy="240000"/>
+          </a:xfrm>
+          <a:prstGeom prst="rect">
+            <a:avLst/>
+          </a:prstGeom>
+          <a:noFill/>
+          <a:ln/>
+        </p:spPr>
+        <p:txBody>
+          <a:bodyPr wrap="square" lIns="45720" tIns="45720" rIns="45720" bIns="45720" rtlCol="0" anchor="t"/>
+          <a:lstStyle/>
+          <a:p>
+            <a:pPr indent="0" marL="0">
+              <a:buNone/>
+            </a:pPr>
+            <a:r>
+              <a:rPr lang="pt-BR" sz="1200" b="1" dirty="0">
+                <a:solidFill>
+                  <a:srgbClr val="16A34A"/>
+                </a:solidFill>
+                <a:latin typeface="Calibri" pitchFamily="34" charset="0"/>
+              </a:rPr>
+              <a:t>3.</a:t>
+            </a:r>
+            <a:endParaRPr lang="pt-BR" sz="1200" dirty="0"/>
+          </a:p>
+        </p:txBody>
+      </p:sp>
+      <p:sp>
+        <p:nvSpPr>
+          <p:cNvPr id="15" name="StepTxt15"/>
+          <p:cNvSpPr/>
+          <p:nvPr/>
+        </p:nvSpPr>
+        <p:spPr>
+          <a:xfrm>
+            <a:off x="697200" y="2700000"/>
+            <a:ext cx="3660500" cy="240000"/>
+          </a:xfrm>
+          <a:prstGeom prst="rect">
+            <a:avLst/>
+          </a:prstGeom>
+          <a:noFill/>
+          <a:ln/>
+        </p:spPr>
+        <p:txBody>
+          <a:bodyPr wrap="square" lIns="45720" tIns="45720" rIns="45720" bIns="45720" rtlCol="0" anchor="t"/>
+          <a:lstStyle/>
+          <a:p>
+            <a:pPr indent="0" marL="0">
+              <a:buNone/>
+            </a:pPr>
+            <a:r>
+              <a:rPr lang="pt-BR" sz="1150" dirty="0">
+                <a:solidFill>
+                  <a:srgbClr val="1E293B"/>
+                </a:solidFill>
+                <a:latin typeface="Calibri" pitchFamily="34" charset="0"/>
+              </a:rPr>
+              <a:t>Defina prazo de exibicao ou marque Permanente</a:t>
+            </a:r>
+            <a:endParaRPr lang="pt-BR" sz="1150" dirty="0"/>
+          </a:p>
+        </p:txBody>
+      </p:sp>
+      <p:sp>
+        <p:nvSpPr>
+          <p:cNvPr id="16" name="Step16"/>
+          <p:cNvSpPr/>
+          <p:nvPr/>
+        </p:nvSpPr>
+        <p:spPr>
+          <a:xfrm>
+            <a:off x="547200" y="2990000"/>
+            <a:ext cx="3820500" cy="240000"/>
+          </a:xfrm>
+          <a:prstGeom prst="rect">
+            <a:avLst/>
+          </a:prstGeom>
+          <a:noFill/>
+          <a:ln/>
+        </p:spPr>
+        <p:txBody>
+          <a:bodyPr wrap="square" lIns="45720" tIns="45720" rIns="45720" bIns="45720" rtlCol="0" anchor="t"/>
+          <a:lstStyle/>
+          <a:p>
+            <a:pPr indent="0" marL="0">
+              <a:buNone/>
+            </a:pPr>
+            <a:r>
+              <a:rPr lang="pt-BR" sz="1200" b="1" dirty="0">
+                <a:solidFill>
+                  <a:srgbClr val="16A34A"/>
+                </a:solidFill>
+                <a:latin typeface="Calibri" pitchFamily="34" charset="0"/>
+              </a:rPr>
+              <a:t>4.</a:t>
+            </a:r>
+            <a:endParaRPr lang="pt-BR" sz="1200" dirty="0"/>
+          </a:p>
+        </p:txBody>
+      </p:sp>
+      <p:sp>
+        <p:nvSpPr>
+          <p:cNvPr id="17" name="StepTxt17"/>
+          <p:cNvSpPr/>
+          <p:nvPr/>
+        </p:nvSpPr>
+        <p:spPr>
+          <a:xfrm>
+            <a:off x="697200" y="2990000"/>
+            <a:ext cx="3660500" cy="240000"/>
+          </a:xfrm>
+          <a:prstGeom prst="rect">
+            <a:avLst/>
+          </a:prstGeom>
+          <a:noFill/>
+          <a:ln/>
+        </p:spPr>
+        <p:txBody>
+          <a:bodyPr wrap="square" lIns="45720" tIns="45720" rIns="45720" bIns="45720" rtlCol="0" anchor="t"/>
+          <a:lstStyle/>
+          <a:p>
+            <a:pPr indent="0" marL="0">
+              <a:buNone/>
+            </a:pPr>
+            <a:r>
+              <a:rPr lang="pt-BR" sz="1150" dirty="0">
+                <a:solidFill>
+                  <a:srgbClr val="1E293B"/>
+                </a:solidFill>
+                <a:latin typeface="Calibri" pitchFamily="34" charset="0"/>
+              </a:rPr>
+              <a:t>Clique em Publicar Aviso — aparece para todos imediatamente</a:t>
+            </a:r>
+            <a:endParaRPr lang="pt-BR" sz="1150" dirty="0"/>
+          </a:p>
+        </p:txBody>
+      </p:sp>
+      <p:sp>
+        <p:nvSpPr>
+          <p:cNvPr id="18" name="Col2BG"/>
+          <p:cNvSpPr/>
+          <p:nvPr/>
+        </p:nvSpPr>
+        <p:spPr>
+          <a:xfrm>
+            <a:off x="4686300" y="1000000"/>
+            <a:ext cx="4000500" cy="4023500"/>
+          </a:xfrm>
+          <a:prstGeom prst="roundRect">
+            <a:avLst>
+              <a:gd name="adj" fmla="val 4082"/>
+            </a:avLst>
+          </a:prstGeom>
+          <a:solidFill>
+            <a:srgbClr val="EFF6FF"/>
+          </a:solidFill>
+          <a:ln w="12700">
+            <a:solidFill>
+              <a:srgbClr val="EFF6FF"/>
+            </a:solidFill>
+            <a:prstDash val="solid"/>
+          </a:ln>
+        </p:spPr>
+      </p:sp>
+      <p:sp>
+        <p:nvSpPr>
+          <p:cNvPr id="19" name="Col2Title"/>
+          <p:cNvSpPr/>
+          <p:nvPr/>
+        </p:nvSpPr>
+        <p:spPr>
+          <a:xfrm>
+            <a:off x="4776300" y="1110000"/>
+            <a:ext cx="3820500" cy="330000"/>
+          </a:xfrm>
+          <a:prstGeom prst="rect">
+            <a:avLst/>
+          </a:prstGeom>
+          <a:noFill/>
+          <a:ln/>
+        </p:spPr>
+        <p:txBody>
+          <a:bodyPr wrap="square" lIns="45720" tIns="45720" rIns="45720" bIns="45720" rtlCol="0" anchor="t"/>
+          <a:lstStyle/>
+          <a:p>
+            <a:pPr indent="0" marL="0">
+              <a:buNone/>
+            </a:pPr>
+            <a:r>
+              <a:rPr lang="pt-BR" sz="1500" b="1" dirty="0">
+                <a:solidFill>
+                  <a:srgbClr val="1D4ED8"/>
+                </a:solidFill>
+                <a:latin typeface="Calibri" pitchFamily="34" charset="0"/>
+              </a:rPr>
+              <a:t>⚙️ Gerenciar no Painel Admin</a:t>
+            </a:r>
+            <a:endParaRPr lang="pt-BR" sz="1500" dirty="0"/>
+          </a:p>
+        </p:txBody>
+      </p:sp>
+      <p:sp>
+        <p:nvSpPr>
+          <p:cNvPr id="20" name="AdminPath"/>
+          <p:cNvSpPr/>
+          <p:nvPr/>
+        </p:nvSpPr>
+        <p:spPr>
+          <a:xfrm>
+            <a:off x="4776300" y="1510000"/>
+            <a:ext cx="3820500" cy="240000"/>
+          </a:xfrm>
+          <a:prstGeom prst="rect">
+            <a:avLst/>
+          </a:prstGeom>
+          <a:noFill/>
+          <a:ln/>
+        </p:spPr>
+        <p:txBody>
+          <a:bodyPr wrap="square" lIns="45720" tIns="45720" rIns="45720" bIns="45720" rtlCol="0" anchor="t"/>
+          <a:lstStyle/>
+          <a:p>
+            <a:pPr indent="0" marL="0">
+              <a:buNone/>
+            </a:pPr>
+            <a:r>
+              <a:rPr lang="pt-BR" sz="1200" b="1" dirty="0">
+                <a:solidFill>
+                  <a:srgbClr val="1E40AF"/>
+                </a:solidFill>
+                <a:latin typeface="Calibri" pitchFamily="34" charset="0"/>
+              </a:rPr>
+              <a:t>Menu Admin → aba 📢 Avisos</a:t>
+            </a:r>
+            <a:endParaRPr lang="pt-BR" sz="1200" dirty="0"/>
+          </a:p>
+        </p:txBody>
+      </p:sp>
+      <p:sp>
+        <p:nvSpPr>
+          <p:cNvPr id="21" name="ChkBG"/>
+          <p:cNvSpPr/>
+          <p:nvPr/>
+        </p:nvSpPr>
+        <p:spPr>
+          <a:xfrm>
+            <a:off x="4776300" y="1810000"/>
+            <a:ext cx="3820500" cy="440000"/>
+          </a:xfrm>
+          <a:prstGeom prst="roundRect">
+            <a:avLst>
+              <a:gd name="adj" fmla="val 4082"/>
+            </a:avLst>
+          </a:prstGeom>
+          <a:solidFill>
+            <a:srgbClr val="DBEAFE"/>
+          </a:solidFill>
+          <a:ln w="12700">
+            <a:solidFill>
+              <a:srgbClr val="DBEAFE"/>
+            </a:solidFill>
+            <a:prstDash val="solid"/>
+          </a:ln>
+        </p:spPr>
+      </p:sp>
+      <p:sp>
+        <p:nvSpPr>
+          <p:cNvPr id="22" name="ChkTitle"/>
+          <p:cNvSpPr/>
+          <p:nvPr/>
+        </p:nvSpPr>
+        <p:spPr>
+          <a:xfrm>
+            <a:off x="4836300" y="1870000"/>
+            <a:ext cx="3700500" cy="250000"/>
+          </a:xfrm>
+          <a:prstGeom prst="rect">
+            <a:avLst/>
+          </a:prstGeom>
+          <a:noFill/>
+          <a:ln/>
+        </p:spPr>
+        <p:txBody>
+          <a:bodyPr wrap="square" lIns="45720" tIns="45720" rIns="45720" bIns="45720" rtlCol="0" anchor="t"/>
+          <a:lstStyle/>
+          <a:p>
+            <a:pPr indent="0" marL="0">
+              <a:buNone/>
+            </a:pPr>
+            <a:r>
+              <a:rPr lang="pt-BR" sz="1200" b="1" dirty="0">
+                <a:solidFill>
+                  <a:srgbClr val="1E40AF"/>
+                </a:solidFill>
+                <a:latin typeface="Calibri" pitchFamily="34" charset="0"/>
+              </a:rPr>
+              <a:t>☑️ Permissao por Usuario</a:t>
+            </a:r>
+            <a:endParaRPr lang="pt-BR" sz="1200" dirty="0"/>
+          </a:p>
+        </p:txBody>
+      </p:sp>
+      <p:sp>
+        <p:nvSpPr>
+          <p:cNvPr id="23" name="ChkBody"/>
+          <p:cNvSpPr/>
+          <p:nvPr/>
+        </p:nvSpPr>
+        <p:spPr>
+          <a:xfrm>
+            <a:off x="4836300" y="2110000"/>
+            <a:ext cx="3700500" cy="190000"/>
+          </a:xfrm>
+          <a:prstGeom prst="rect">
+            <a:avLst/>
+          </a:prstGeom>
+          <a:noFill/>
+          <a:ln/>
+        </p:spPr>
+        <p:txBody>
+          <a:bodyPr wrap="square" lIns="45720" tIns="45720" rIns="45720" bIns="45720" rtlCol="0" anchor="t"/>
+          <a:lstStyle/>
+          <a:p>
+            <a:pPr indent="0" marL="0">
+              <a:buNone/>
+            </a:pPr>
+            <a:r>
+              <a:rPr lang="pt-BR" sz="1050" dirty="0">
+                <a:solidFill>
+                  <a:srgbClr val="1E3A8A"/>
+                </a:solidFill>
+                <a:latin typeface="Calibri" pitchFamily="34" charset="0"/>
+              </a:rPr>
+              <a:t>Cadastro de Usuario → checkbox "Pode publicar Avisos do Sistema"</a:t>
+            </a:r>
+            <a:endParaRPr lang="pt-BR" sz="1050" dirty="0"/>
+          </a:p>
+        </p:txBody>
+      </p:sp>
+      <p:sp>
+        <p:nvSpPr>
+          <p:cNvPr id="24" name="FeatIcon24"/>
+          <p:cNvSpPr/>
+          <p:nvPr/>
+        </p:nvSpPr>
+        <p:spPr>
+          <a:xfrm>
+            <a:off x="4776300" y="2350000"/>
+            <a:ext cx="3820500" cy="240000"/>
+          </a:xfrm>
+          <a:prstGeom prst="rect">
+            <a:avLst/>
+          </a:prstGeom>
+          <a:noFill/>
+          <a:ln/>
+        </p:spPr>
+        <p:txBody>
+          <a:bodyPr wrap="square" lIns="45720" tIns="45720" rIns="45720" bIns="45720" rtlCol="0" anchor="t"/>
+          <a:lstStyle/>
+          <a:p>
+            <a:pPr indent="0" marL="0">
+              <a:buNone/>
+            </a:pPr>
+            <a:r>
+              <a:rPr lang="pt-BR" sz="1200" b="1" dirty="0">
+                <a:solidFill>
+                  <a:srgbClr val="1D4ED8"/>
+                </a:solidFill>
+                <a:latin typeface="Calibri" pitchFamily="34" charset="0"/>
+              </a:rPr>
+              <a:t>✏️ Editar</a:t>
+            </a:r>
+            <a:endParaRPr lang="pt-BR" sz="1200" dirty="0"/>
+          </a:p>
+        </p:txBody>
+      </p:sp>
+      <p:sp>
+        <p:nvSpPr>
+          <p:cNvPr id="25" name="FeatBody25"/>
+          <p:cNvSpPr/>
+          <p:nvPr/>
+        </p:nvSpPr>
+        <p:spPr>
+          <a:xfrm>
+            <a:off x="4776300" y="2585000"/>
+            <a:ext cx="3820500" cy="200000"/>
+          </a:xfrm>
+          <a:prstGeom prst="rect">
+            <a:avLst/>
+          </a:prstGeom>
+          <a:noFill/>
+          <a:ln/>
+        </p:spPr>
+        <p:txBody>
+          <a:bodyPr wrap="square" lIns="45720" tIns="45720" rIns="45720" bIns="45720" rtlCol="0" anchor="t"/>
+          <a:lstStyle/>
+          <a:p>
+            <a:pPr indent="0" marL="0">
+              <a:buNone/>
+            </a:pPr>
+            <a:r>
+              <a:rPr lang="pt-BR" sz="1050" dirty="0">
+                <a:solidFill>
+                  <a:srgbClr val="374151"/>
+                </a:solidFill>
+                <a:latin typeface="Calibri" pitchFamily="34" charset="0"/>
+              </a:rPr>
+              <a:t>Altere titulo, mensagem ou criticidade a qualquer momento</a:t>
+            </a:r>
+            <a:endParaRPr lang="pt-BR" sz="1050" dirty="0"/>
+          </a:p>
+        </p:txBody>
+      </p:sp>
+      <p:sp>
+        <p:nvSpPr>
+          <p:cNvPr id="26" name="FeatIcon26"/>
+          <p:cNvSpPr/>
+          <p:nvPr/>
+        </p:nvSpPr>
+        <p:spPr>
+          <a:xfrm>
+            <a:off x="4776300" y="2830000"/>
+            <a:ext cx="3820500" cy="240000"/>
+          </a:xfrm>
+          <a:prstGeom prst="rect">
+            <a:avLst/>
+          </a:prstGeom>
+          <a:noFill/>
+          <a:ln/>
+        </p:spPr>
+        <p:txBody>
+          <a:bodyPr wrap="square" lIns="45720" tIns="45720" rIns="45720" bIns="45720" rtlCol="0" anchor="t"/>
+          <a:lstStyle/>
+          <a:p>
+            <a:pPr indent="0" marL="0">
+              <a:buNone/>
+            </a:pPr>
+            <a:r>
+              <a:rPr lang="pt-BR" sz="1200" b="1" dirty="0">
+                <a:solidFill>
+                  <a:srgbClr val="1D4ED8"/>
+                </a:solidFill>
+                <a:latin typeface="Calibri" pitchFamily="34" charset="0"/>
+              </a:rPr>
+              <a:t>⏸ Ativar/Desativar</a:t>
+            </a:r>
+            <a:endParaRPr lang="pt-BR" sz="1200" dirty="0"/>
+          </a:p>
+        </p:txBody>
+      </p:sp>
+      <p:sp>
+        <p:nvSpPr>
+          <p:cNvPr id="27" name="FeatBody27"/>
+          <p:cNvSpPr/>
+          <p:nvPr/>
+        </p:nvSpPr>
+        <p:spPr>
+          <a:xfrm>
+            <a:off x="4776300" y="3065000"/>
+            <a:ext cx="3820500" cy="200000"/>
+          </a:xfrm>
+          <a:prstGeom prst="rect">
+            <a:avLst/>
+          </a:prstGeom>
+          <a:noFill/>
+          <a:ln/>
+        </p:spPr>
+        <p:txBody>
+          <a:bodyPr wrap="square" lIns="45720" tIns="45720" rIns="45720" bIns="45720" rtlCol="0" anchor="t"/>
+          <a:lstStyle/>
+          <a:p>
+            <a:pPr indent="0" marL="0">
+              <a:buNone/>
+            </a:pPr>
+            <a:r>
+              <a:rPr lang="pt-BR" sz="1050" dirty="0">
+                <a:solidFill>
+                  <a:srgbClr val="374151"/>
+                </a:solidFill>
+                <a:latin typeface="Calibri" pitchFamily="34" charset="0"/>
+              </a:rPr>
+              <a:t>Pause a exibicao sem excluir o aviso</a:t>
+            </a:r>
+            <a:endParaRPr lang="pt-BR" sz="1050" dirty="0"/>
+          </a:p>
+        </p:txBody>
+      </p:sp>
+      <p:sp>
+        <p:nvSpPr>
+          <p:cNvPr id="28" name="FeatIcon28"/>
+          <p:cNvSpPr/>
+          <p:nvPr/>
+        </p:nvSpPr>
+        <p:spPr>
+          <a:xfrm>
+            <a:off x="4776300" y="3310000"/>
+            <a:ext cx="3820500" cy="240000"/>
+          </a:xfrm>
+          <a:prstGeom prst="rect">
+            <a:avLst/>
+          </a:prstGeom>
+          <a:noFill/>
+          <a:ln/>
+        </p:spPr>
+        <p:txBody>
+          <a:bodyPr wrap="square" lIns="45720" tIns="45720" rIns="45720" bIns="45720" rtlCol="0" anchor="t"/>
+          <a:lstStyle/>
+          <a:p>
+            <a:pPr indent="0" marL="0">
+              <a:buNone/>
+            </a:pPr>
+            <a:r>
+              <a:rPr lang="pt-BR" sz="1200" b="1" dirty="0">
+                <a:solidFill>
+                  <a:srgbClr val="1D4ED8"/>
+                </a:solidFill>
+                <a:latin typeface="Calibri" pitchFamily="34" charset="0"/>
+              </a:rPr>
+              <a:t>🗑 Excluir</a:t>
+            </a:r>
+            <a:endParaRPr lang="pt-BR" sz="1200" dirty="0"/>
+          </a:p>
+        </p:txBody>
+      </p:sp>
+      <p:sp>
+        <p:nvSpPr>
+          <p:cNvPr id="29" name="FeatBody29"/>
+          <p:cNvSpPr/>
+          <p:nvPr/>
+        </p:nvSpPr>
+        <p:spPr>
+          <a:xfrm>
+            <a:off x="4776300" y="3545000"/>
+            <a:ext cx="3820500" cy="200000"/>
+          </a:xfrm>
+          <a:prstGeom prst="rect">
+            <a:avLst/>
+          </a:prstGeom>
+          <a:noFill/>
+          <a:ln/>
+        </p:spPr>
+        <p:txBody>
+          <a:bodyPr wrap="square" lIns="45720" tIns="45720" rIns="45720" bIns="45720" rtlCol="0" anchor="t"/>
+          <a:lstStyle/>
+          <a:p>
+            <a:pPr indent="0" marL="0">
+              <a:buNone/>
+            </a:pPr>
+            <a:r>
+              <a:rPr lang="pt-BR" sz="1050" dirty="0">
+                <a:solidFill>
+                  <a:srgbClr val="374151"/>
+                </a:solidFill>
+                <a:latin typeface="Calibri" pitchFamily="34" charset="0"/>
+              </a:rPr>
+              <a:t>Remove permanentemente o aviso do sistema</a:t>
+            </a:r>
+            <a:endParaRPr lang="pt-BR" sz="1050" dirty="0"/>
+          </a:p>
+        </p:txBody>
+      </p:sp>
+      <p:sp>
+        <p:nvSpPr>
+          <p:cNvPr id="30" name="FeatIcon30"/>
+          <p:cNvSpPr/>
+          <p:nvPr/>
+        </p:nvSpPr>
+        <p:spPr>
+          <a:xfrm>
+            <a:off x="4776300" y="3790000"/>
+            <a:ext cx="3820500" cy="240000"/>
+          </a:xfrm>
+          <a:prstGeom prst="rect">
+            <a:avLst/>
+          </a:prstGeom>
+          <a:noFill/>
+          <a:ln/>
+        </p:spPr>
+        <p:txBody>
+          <a:bodyPr wrap="square" lIns="45720" tIns="45720" rIns="45720" bIns="45720" rtlCol="0" anchor="t"/>
+          <a:lstStyle/>
+          <a:p>
+            <a:pPr indent="0" marL="0">
+              <a:buNone/>
+            </a:pPr>
+            <a:r>
+              <a:rPr lang="pt-BR" sz="1200" b="1" dirty="0">
+                <a:solidFill>
+                  <a:srgbClr val="1D4ED8"/>
+                </a:solidFill>
+                <a:latin typeface="Calibri" pitchFamily="34" charset="0"/>
+              </a:rPr>
+              <a:t>📅 Prazo</a:t>
+            </a:r>
+            <a:endParaRPr lang="pt-BR" sz="1200" dirty="0"/>
+          </a:p>
+        </p:txBody>
+      </p:sp>
+      <p:sp>
+        <p:nvSpPr>
+          <p:cNvPr id="31" name="FeatBody31"/>
+          <p:cNvSpPr/>
+          <p:nvPr/>
+        </p:nvSpPr>
+        <p:spPr>
+          <a:xfrm>
+            <a:off x="4776300" y="4025000"/>
+            <a:ext cx="3820500" cy="200000"/>
+          </a:xfrm>
+          <a:prstGeom prst="rect">
+            <a:avLst/>
+          </a:prstGeom>
+          <a:noFill/>
+          <a:ln/>
+        </p:spPr>
+        <p:txBody>
+          <a:bodyPr wrap="square" lIns="45720" tIns="45720" rIns="45720" bIns="45720" rtlCol="0" anchor="t"/>
+          <a:lstStyle/>
+          <a:p>
+            <a:pPr indent="0" marL="0">
+              <a:buNone/>
+            </a:pPr>
+            <a:r>
+              <a:rPr lang="pt-BR" sz="1050" dirty="0">
+                <a:solidFill>
+                  <a:srgbClr val="374151"/>
+                </a:solidFill>
+                <a:latin typeface="Calibri" pitchFamily="34" charset="0"/>
+              </a:rPr>
+              <a:t>Aviso expira automaticamente na data definida</a:t>
+            </a:r>
+            <a:endParaRPr lang="pt-BR" sz="1050" dirty="0"/>
+          </a:p>
+        </p:txBody>
+      </p:sp>
+    </p:spTree>
+  </p:cSld>
+  <p:clrMapOvr>
+    <a:masterClrMapping/>
+  </p:clrMapOvr>
+</p:sld>
+</file>
+
+<file path=ppt/slides/slide39.xml><?xml version="1.0" encoding="utf-8"?>
+<p:sld xmlns:a="http://schemas.openxmlformats.org/drawingml/2006/main" xmlns:r="http://schemas.openxmlformats.org/officeDocument/2006/relationships" xmlns:p="http://schemas.openxmlformats.org/presentationml/2006/main">
+  <p:cSld name="Slide Avisos Widget">
+    <p:spTree>
+      <p:nvGrpSpPr>
+        <p:cNvPr id="1" name=""/>
+        <p:cNvGrpSpPr/>
+        <p:nvPr/>
+      </p:nvGrpSpPr>
+      <p:grpSpPr>
+        <a:xfrm>
+          <a:off x="0" y="0"/>
+          <a:ext cx="0" cy="0"/>
+          <a:chOff x="0" y="0"/>
+          <a:chExt cx="0" cy="0"/>
+        </a:xfrm>
+      </p:grpSpPr>
+      <p:sp>
+        <p:nvSpPr>
+          <p:cNvPr id="2" name="BG"/>
+          <p:cNvSpPr/>
+          <p:nvPr/>
+        </p:nvSpPr>
+        <p:spPr>
+          <a:xfrm>
+            <a:off x="0" y="0"/>
+            <a:ext cx="9144000" cy="5143500"/>
+          </a:xfrm>
+          <a:prstGeom prst="rect">
+            <a:avLst/>
+          </a:prstGeom>
+          <a:solidFill>
+            <a:srgbClr val="FFFFFF"/>
+          </a:solidFill>
+          <a:ln w="12700">
+            <a:solidFill>
+              <a:srgbClr val="FFFFFF"/>
+            </a:solidFill>
+            <a:prstDash val="solid"/>
+          </a:ln>
+        </p:spPr>
+      </p:sp>
+      <p:sp>
+        <p:nvSpPr>
+          <p:cNvPr id="3" name="ModLabel"/>
+          <p:cNvSpPr/>
+          <p:nvPr/>
+        </p:nvSpPr>
+        <p:spPr>
+          <a:xfrm>
+            <a:off x="457200" y="182880"/>
+            <a:ext cx="7315200" cy="201168"/>
+          </a:xfrm>
+          <a:prstGeom prst="rect">
+            <a:avLst/>
+          </a:prstGeom>
+          <a:noFill/>
+          <a:ln/>
+        </p:spPr>
+        <p:txBody>
+          <a:bodyPr wrap="square" lIns="45720" tIns="45720" rIns="45720" bIns="45720" rtlCol="0" anchor="t"/>
+          <a:lstStyle/>
+          <a:p>
+            <a:pPr indent="0" marL="0">
+              <a:buNone/>
+            </a:pPr>
+            <a:r>
+              <a:rPr lang="pt-BR" sz="950" b="1" dirty="0">
+                <a:solidFill>
+                  <a:srgbClr val="94A3B8"/>
+                </a:solidFill>
+                <a:latin typeface="Calibri" pitchFamily="34" charset="0"/>
+                <a:ea typeface="Calibri" pitchFamily="34" charset="-122"/>
+                <a:cs typeface="Calibri" pitchFamily="34" charset="-120"/>
+              </a:rPr>
+              <a:t>RECURSOS ESPECIAIS</a:t>
+            </a:r>
+            <a:endParaRPr lang="pt-BR" sz="950" dirty="0"/>
+          </a:p>
+        </p:txBody>
+      </p:sp>
+      <p:sp>
+        <p:nvSpPr>
+          <p:cNvPr id="4" name="Title"/>
+          <p:cNvSpPr/>
+          <p:nvPr/>
+        </p:nvSpPr>
+        <p:spPr>
+          <a:xfrm>
+            <a:off x="457200" y="384048"/>
+            <a:ext cx="8229600" cy="594360"/>
+          </a:xfrm>
+          <a:prstGeom prst="rect">
+            <a:avLst/>
+          </a:prstGeom>
+          <a:noFill/>
+          <a:ln/>
+        </p:spPr>
+        <p:txBody>
+          <a:bodyPr wrap="square" lIns="45720" tIns="45720" rIns="45720" bIns="45720" rtlCol="0" anchor="ctr"/>
+          <a:lstStyle/>
+          <a:p>
+            <a:pPr indent="0" marL="0">
+              <a:buNone/>
+            </a:pPr>
+            <a:r>
+              <a:rPr lang="pt-BR" sz="3000" b="1" dirty="0">
+                <a:solidFill>
+                  <a:srgbClr val="166534"/>
+                </a:solidFill>
+                <a:latin typeface="Cambria" pitchFamily="34" charset="0"/>
+                <a:ea typeface="Cambria" pitchFamily="34" charset="-122"/>
+                <a:cs typeface="Cambria" pitchFamily="34" charset="-120"/>
+              </a:rPr>
+              <a:t>Avisos do Sistema — Widget Flutuante</a:t>
+            </a:r>
+            <a:endParaRPr lang="pt-BR" sz="3000" dirty="0"/>
+          </a:p>
+        </p:txBody>
+      </p:sp>
+      <p:sp>
+        <p:nvSpPr>
+          <p:cNvPr id="5" name="CardBaixa"/>
+          <p:cNvSpPr/>
+          <p:nvPr/>
+        </p:nvSpPr>
+        <p:spPr>
+          <a:xfrm>
+            <a:off x="457200" y="1100000"/>
+            <a:ext cx="2643200" cy="1680000"/>
+          </a:xfrm>
+          <a:prstGeom prst="roundRect">
+            <a:avLst>
+              <a:gd name="adj" fmla="val 4082"/>
+            </a:avLst>
+          </a:prstGeom>
+          <a:solidFill>
+            <a:srgbClr val="FEF9C3"/>
+          </a:solidFill>
+          <a:ln w="12700">
+            <a:solidFill>
+              <a:srgbClr val="FEF9C3"/>
+            </a:solidFill>
+            <a:prstDash val="solid"/>
+          </a:ln>
+        </p:spPr>
+      </p:sp>
+      <p:sp>
+        <p:nvSpPr>
+          <p:cNvPr id="6" name="CardBaixaTitle"/>
+          <p:cNvSpPr/>
+          <p:nvPr/>
+        </p:nvSpPr>
+        <p:spPr>
+          <a:xfrm>
+            <a:off x="547200" y="1200000"/>
+            <a:ext cx="2463200" cy="330000"/>
+          </a:xfrm>
+          <a:prstGeom prst="rect">
+            <a:avLst/>
+          </a:prstGeom>
+          <a:noFill/>
+          <a:ln/>
+        </p:spPr>
+        <p:txBody>
+          <a:bodyPr wrap="square" lIns="45720" tIns="45720" rIns="45720" bIns="45720" rtlCol="0" anchor="t"/>
+          <a:lstStyle/>
+          <a:p>
+            <a:pPr indent="0" marL="0">
+              <a:buNone/>
+            </a:pPr>
+            <a:r>
+              <a:rPr lang="pt-BR" sz="1400" b="1" dirty="0">
+                <a:solidFill>
+                  <a:srgbClr val="CA8A04"/>
+                </a:solidFill>
+                <a:latin typeface="Calibri" pitchFamily="34" charset="0"/>
+                <a:ea typeface="Calibri" pitchFamily="34" charset="-122"/>
+                <a:cs typeface="Calibri" pitchFamily="34" charset="-120"/>
+              </a:rPr>
+              <a:t>🟡 Baixa Criticidade</a:t>
+            </a:r>
+            <a:endParaRPr lang="pt-BR" sz="1400" dirty="0"/>
+          </a:p>
+        </p:txBody>
+      </p:sp>
+      <p:sp>
+        <p:nvSpPr>
+          <p:cNvPr id="7" name="CardBaixaBody"/>
+          <p:cNvSpPr/>
+          <p:nvPr/>
+        </p:nvSpPr>
+        <p:spPr>
+          <a:xfrm>
+            <a:off x="547200" y="1560000"/>
+            <a:ext cx="2463200" cy="1100000"/>
+          </a:xfrm>
+          <a:prstGeom prst="rect">
+            <a:avLst/>
+          </a:prstGeom>
+          <a:noFill/>
+          <a:ln/>
+        </p:spPr>
+        <p:txBody>
+          <a:bodyPr wrap="square" lIns="45720" tIns="45720" rIns="45720" bIns="45720" rtlCol="0" anchor="t"/>
+          <a:lstStyle/>
+          <a:p>
+            <a:pPr indent="0" marL="0">
+              <a:buNone/>
+            </a:pPr>
+            <a:r>
+              <a:rPr lang="pt-BR" sz="1100" dirty="0">
+                <a:solidFill>
+                  <a:srgbClr val="854D0E"/>
+                </a:solidFill>
+                <a:latin typeface="Calibri" pitchFamily="34" charset="0"/>
+                <a:ea typeface="Calibri" pitchFamily="34" charset="-122"/>
+                <a:cs typeface="Calibri" pitchFamily="34" charset="-120"/>
+              </a:rPr>
+              <a:t>Avisos informativos e lembretes. Exibidos em amarelo claro. Ideal para comunicados gerais e orientacoes nao urgentes.</a:t>
+            </a:r>
+            <a:endParaRPr lang="pt-BR" sz="1100" dirty="0"/>
+          </a:p>
+        </p:txBody>
+      </p:sp>
+      <p:sp>
+        <p:nvSpPr>
+          <p:cNvPr id="8" name="CardMedia"/>
+          <p:cNvSpPr/>
+          <p:nvPr/>
+        </p:nvSpPr>
+        <p:spPr>
+          <a:xfrm>
+            <a:off x="3250400" y="1100000"/>
+            <a:ext cx="2643200" cy="1680000"/>
+          </a:xfrm>
+          <a:prstGeom prst="roundRect">
+            <a:avLst>
+              <a:gd name="adj" fmla="val 4082"/>
+            </a:avLst>
+          </a:prstGeom>
+          <a:solidFill>
+            <a:srgbClr val="FFEDD5"/>
+          </a:solidFill>
+          <a:ln w="12700">
+            <a:solidFill>
+              <a:srgbClr val="FFEDD5"/>
+            </a:solidFill>
+            <a:prstDash val="solid"/>
+          </a:ln>
+        </p:spPr>
+      </p:sp>
+      <p:sp>
+        <p:nvSpPr>
+          <p:cNvPr id="9" name="CardMediaTitle"/>
+          <p:cNvSpPr/>
+          <p:nvPr/>
+        </p:nvSpPr>
+        <p:spPr>
+          <a:xfrm>
+            <a:off x="3340400" y="1200000"/>
+            <a:ext cx="2463200" cy="330000"/>
+          </a:xfrm>
+          <a:prstGeom prst="rect">
+            <a:avLst/>
+          </a:prstGeom>
+          <a:noFill/>
+          <a:ln/>
+        </p:spPr>
+        <p:txBody>
+          <a:bodyPr wrap="square" lIns="45720" tIns="45720" rIns="45720" bIns="45720" rtlCol="0" anchor="t"/>
+          <a:lstStyle/>
+          <a:p>
+            <a:pPr indent="0" marL="0">
+              <a:buNone/>
+            </a:pPr>
+            <a:r>
+              <a:rPr lang="pt-BR" sz="1400" b="1" dirty="0">
+                <a:solidFill>
+                  <a:srgbClr val="EA580C"/>
+                </a:solidFill>
+                <a:latin typeface="Calibri" pitchFamily="34" charset="0"/>
+                <a:ea typeface="Calibri" pitchFamily="34" charset="-122"/>
+                <a:cs typeface="Calibri" pitchFamily="34" charset="-120"/>
+              </a:rPr>
+              <a:t>🟠 Media Criticidade</a:t>
+            </a:r>
+            <a:endParaRPr lang="pt-BR" sz="1400" dirty="0"/>
+          </a:p>
+        </p:txBody>
+      </p:sp>
+      <p:sp>
+        <p:nvSpPr>
+          <p:cNvPr id="10" name="CardMediaBody"/>
+          <p:cNvSpPr/>
+          <p:nvPr/>
+        </p:nvSpPr>
+        <p:spPr>
+          <a:xfrm>
+            <a:off x="3340400" y="1560000"/>
+            <a:ext cx="2463200" cy="1100000"/>
+          </a:xfrm>
+          <a:prstGeom prst="rect">
+            <a:avLst/>
+          </a:prstGeom>
+          <a:noFill/>
+          <a:ln/>
+        </p:spPr>
+        <p:txBody>
+          <a:bodyPr wrap="square" lIns="45720" tIns="45720" rIns="45720" bIns="45720" rtlCol="0" anchor="t"/>
+          <a:lstStyle/>
+          <a:p>
+            <a:pPr indent="0" marL="0">
+              <a:buNone/>
+            </a:pPr>
+            <a:r>
+              <a:rPr lang="pt-BR" sz="1100" dirty="0">
+                <a:solidFill>
+                  <a:srgbClr val="9A3412"/>
+                </a:solidFill>
+                <a:latin typeface="Calibri" pitchFamily="34" charset="0"/>
+                <a:ea typeface="Calibri" pitchFamily="34" charset="-122"/>
+                <a:cs typeface="Calibri" pitchFamily="34" charset="-120"/>
+              </a:rPr>
+              <a:t>Requer atencao. Borda laranja. Indica prazo se aproximando ou situacao que exige revisao em breve.</a:t>
+            </a:r>
+            <a:endParaRPr lang="pt-BR" sz="1100" dirty="0"/>
+          </a:p>
+        </p:txBody>
+      </p:sp>
+      <p:sp>
+        <p:nvSpPr>
+          <p:cNvPr id="11" name="CardAlta"/>
+          <p:cNvSpPr/>
+          <p:nvPr/>
+        </p:nvSpPr>
+        <p:spPr>
+          <a:xfrm>
+            <a:off x="6043600" y="1100000"/>
+            <a:ext cx="2643200" cy="1680000"/>
+          </a:xfrm>
+          <a:prstGeom prst="roundRect">
+            <a:avLst>
+              <a:gd name="adj" fmla="val 4082"/>
+            </a:avLst>
+          </a:prstGeom>
+          <a:solidFill>
+            <a:srgbClr val="FEE2E2"/>
+          </a:solidFill>
+          <a:ln w="12700">
+            <a:solidFill>
+              <a:srgbClr val="FEE2E2"/>
+            </a:solidFill>
+            <a:prstDash val="solid"/>
+          </a:ln>
+        </p:spPr>
+      </p:sp>
+      <p:sp>
+        <p:nvSpPr>
+          <p:cNvPr id="12" name="CardAltaTitle"/>
+          <p:cNvSpPr/>
+          <p:nvPr/>
+        </p:nvSpPr>
+        <p:spPr>
+          <a:xfrm>
+            <a:off x="6133600" y="1200000"/>
+            <a:ext cx="2463200" cy="330000"/>
+          </a:xfrm>
+          <a:prstGeom prst="rect">
+            <a:avLst/>
+          </a:prstGeom>
+          <a:noFill/>
+          <a:ln/>
+        </p:spPr>
+        <p:txBody>
+          <a:bodyPr wrap="square" lIns="45720" tIns="45720" rIns="45720" bIns="45720" rtlCol="0" anchor="t"/>
+          <a:lstStyle/>
+          <a:p>
+            <a:pPr indent="0" marL="0">
+              <a:buNone/>
+            </a:pPr>
+            <a:r>
+              <a:rPr lang="pt-BR" sz="1400" b="1" dirty="0">
+                <a:solidFill>
+                  <a:srgbClr val="DC2626"/>
+                </a:solidFill>
+                <a:latin typeface="Calibri" pitchFamily="34" charset="0"/>
+                <a:ea typeface="Calibri" pitchFamily="34" charset="-122"/>
+                <a:cs typeface="Calibri" pitchFamily="34" charset="-120"/>
+              </a:rPr>
+              <a:t>🔴 Alta Criticidade</a:t>
+            </a:r>
+            <a:endParaRPr lang="pt-BR" sz="1400" dirty="0"/>
+          </a:p>
+        </p:txBody>
+      </p:sp>
+      <p:sp>
+        <p:nvSpPr>
+          <p:cNvPr id="13" name="CardAltaBody"/>
+          <p:cNvSpPr/>
+          <p:nvPr/>
+        </p:nvSpPr>
+        <p:spPr>
+          <a:xfrm>
+            <a:off x="6133600" y="1560000"/>
+            <a:ext cx="2463200" cy="1100000"/>
+          </a:xfrm>
+          <a:prstGeom prst="rect">
+            <a:avLst/>
+          </a:prstGeom>
+          <a:noFill/>
+          <a:ln/>
+        </p:spPr>
+        <p:txBody>
+          <a:bodyPr wrap="square" lIns="45720" tIns="45720" rIns="45720" bIns="45720" rtlCol="0" anchor="t"/>
+          <a:lstStyle/>
+          <a:p>
+            <a:pPr indent="0" marL="0">
+              <a:buNone/>
+            </a:pPr>
+            <a:r>
+              <a:rPr lang="pt-BR" sz="1100" dirty="0">
+                <a:solidFill>
+                  <a:srgbClr val="991B1B"/>
+                </a:solidFill>
+                <a:latin typeface="Calibri" pitchFamily="34" charset="0"/>
+                <a:ea typeface="Calibri" pitchFamily="34" charset="-122"/>
+                <a:cs typeface="Calibri" pitchFamily="34" charset="-120"/>
+              </a:rPr>
+              <a:t>Acao imediata necessaria. Widget pulsa em vermelho na tela. Maxima visibilidade para o usuario.</a:t>
+            </a:r>
+            <a:endParaRPr lang="pt-BR" sz="1100" dirty="0"/>
+          </a:p>
+        </p:txBody>
+      </p:sp>
+      <p:sp>
+        <p:nvSpPr>
+          <p:cNvPr id="14" name="CardUso"/>
+          <p:cNvSpPr/>
+          <p:nvPr/>
+        </p:nvSpPr>
+        <p:spPr>
+          <a:xfrm>
+            <a:off x="457200" y="2940000"/>
+            <a:ext cx="4039800" cy="2103500"/>
+          </a:xfrm>
+          <a:prstGeom prst="roundRect">
+            <a:avLst>
+              <a:gd name="adj" fmla="val 4082"/>
+            </a:avLst>
+          </a:prstGeom>
+          <a:solidFill>
+            <a:srgbClr val="F0FDF4"/>
+          </a:solidFill>
+          <a:ln w="12700">
+            <a:solidFill>
+              <a:srgbClr val="F0FDF4"/>
+            </a:solidFill>
+            <a:prstDash val="solid"/>
+          </a:ln>
+        </p:spPr>
+      </p:sp>
+      <p:sp>
+        <p:nvSpPr>
+          <p:cNvPr id="15" name="CardUsoTitle"/>
+          <p:cNvSpPr/>
+          <p:nvPr/>
+        </p:nvSpPr>
+        <p:spPr>
+          <a:xfrm>
+            <a:off x="547200" y="3040000"/>
+            <a:ext cx="3859800" cy="330000"/>
+          </a:xfrm>
+          <a:prstGeom prst="rect">
+            <a:avLst/>
+          </a:prstGeom>
+          <a:noFill/>
+          <a:ln/>
+        </p:spPr>
+        <p:txBody>
+          <a:bodyPr wrap="square" lIns="45720" tIns="45720" rIns="45720" bIns="45720" rtlCol="0" anchor="t"/>
+          <a:lstStyle/>
+          <a:p>
+            <a:pPr indent="0" marL="0">
+              <a:buNone/>
+            </a:pPr>
+            <a:r>
+              <a:rPr lang="pt-BR" sz="1400" b="1" dirty="0">
+                <a:solidFill>
+                  <a:srgbClr val="166534"/>
+                </a:solidFill>
+                <a:latin typeface="Calibri" pitchFamily="34" charset="0"/>
+                <a:ea typeface="Calibri" pitchFamily="34" charset="-122"/>
+                <a:cs typeface="Calibri" pitchFamily="34" charset="-120"/>
+              </a:rPr>
+              <a:t>📌 Arrastar e Minimizar</a:t>
+            </a:r>
+            <a:endParaRPr lang="pt-BR" sz="1400" dirty="0"/>
+          </a:p>
+        </p:txBody>
+      </p:sp>
+      <p:sp>
+        <p:nvSpPr>
+          <p:cNvPr id="16" name="CardUsoBody"/>
+          <p:cNvSpPr/>
+          <p:nvPr/>
+        </p:nvSpPr>
+        <p:spPr>
+          <a:xfrm>
+            <a:off x="547200" y="3390000"/>
+            <a:ext cx="3859800" cy="1553500"/>
+          </a:xfrm>
+          <a:prstGeom prst="rect">
+            <a:avLst/>
+          </a:prstGeom>
+          <a:noFill/>
+          <a:ln/>
+        </p:spPr>
+        <p:txBody>
+          <a:bodyPr wrap="square" lIns="45720" tIns="45720" rIns="45720" bIns="45720" rtlCol="0" anchor="t"/>
+          <a:lstStyle/>
+          <a:p>
+            <a:pPr indent="0" marL="0">
+              <a:buNone/>
+            </a:pPr>
+            <a:r>
+              <a:rPr lang="pt-BR" sz="1100" dirty="0">
+                <a:solidFill>
+                  <a:srgbClr val="1E293B"/>
+                </a:solidFill>
+                <a:latin typeface="Calibri" pitchFamily="34" charset="0"/>
+                <a:ea typeface="Calibri" pitchFamily="34" charset="-122"/>
+                <a:cs typeface="Calibri" pitchFamily="34" charset="-120"/>
+              </a:rPr>
+              <a:t>O widget flutua em qualquer tela. Arraste pelo cabecalho para reposicionar. Clique em — para minimizar como icone 📌 com contador de avisos ativos.</a:t>
+            </a:r>
+            <a:endParaRPr lang="pt-BR" sz="1100" dirty="0"/>
+          </a:p>
+        </p:txBody>
+      </p:sp>
+      <p:sp>
+        <p:nvSpPr>
+          <p:cNvPr id="17" name="CardOrigem"/>
+          <p:cNvSpPr/>
+          <p:nvPr/>
+        </p:nvSpPr>
+        <p:spPr>
+          <a:xfrm>
+            <a:off x="4647000" y="2940000"/>
+            <a:ext cx="4039800" cy="2103500"/>
+          </a:xfrm>
+          <a:prstGeom prst="roundRect">
+            <a:avLst>
+              <a:gd name="adj" fmla="val 4082"/>
+            </a:avLst>
+          </a:prstGeom>
+          <a:solidFill>
+            <a:srgbClr val="FFF7ED"/>
+          </a:solidFill>
+          <a:ln w="12700">
+            <a:solidFill>
+              <a:srgbClr val="FFF7ED"/>
+            </a:solidFill>
+            <a:prstDash val="solid"/>
+          </a:ln>
+        </p:spPr>
+      </p:sp>
+      <p:sp>
+        <p:nvSpPr>
+          <p:cNvPr id="18" name="CardOrigemTitle"/>
+          <p:cNvSpPr/>
+          <p:nvPr/>
+        </p:nvSpPr>
+        <p:spPr>
+          <a:xfrm>
+            <a:off x="4737000" y="3040000"/>
+            <a:ext cx="3859800" cy="330000"/>
+          </a:xfrm>
+          <a:prstGeom prst="rect">
+            <a:avLst/>
+          </a:prstGeom>
+          <a:noFill/>
+          <a:ln/>
+        </p:spPr>
+        <p:txBody>
+          <a:bodyPr wrap="square" lIns="45720" tIns="45720" rIns="45720" bIns="45720" rtlCol="0" anchor="t"/>
+          <a:lstStyle/>
+          <a:p>
+            <a:pPr indent="0" marL="0">
+              <a:buNone/>
+            </a:pPr>
+            <a:r>
+              <a:rPr lang="pt-BR" sz="1400" b="1" dirty="0">
+                <a:solidFill>
+                  <a:srgbClr val="C2410C"/>
+                </a:solidFill>
+                <a:latin typeface="Calibri" pitchFamily="34" charset="0"/>
+                <a:ea typeface="Calibri" pitchFamily="34" charset="-122"/>
+                <a:cs typeface="Calibri" pitchFamily="34" charset="-120"/>
+              </a:rPr>
+              <a:t>📢 Origem dos Avisos</a:t>
+            </a:r>
+            <a:endParaRPr lang="pt-BR" sz="1400" dirty="0"/>
+          </a:p>
+        </p:txBody>
+      </p:sp>
+      <p:sp>
+        <p:nvSpPr>
+          <p:cNvPr id="19" name="CardOrigemBody"/>
+          <p:cNvSpPr/>
+          <p:nvPr/>
+        </p:nvSpPr>
+        <p:spPr>
+          <a:xfrm>
+            <a:off x="4737000" y="3390000"/>
+            <a:ext cx="3859800" cy="1553500"/>
+          </a:xfrm>
+          <a:prstGeom prst="rect">
+            <a:avLst/>
+          </a:prstGeom>
+          <a:noFill/>
+          <a:ln/>
+        </p:spPr>
+        <p:txBody>
+          <a:bodyPr wrap="square" lIns="45720" tIns="45720" rIns="45720" bIns="45720" rtlCol="0" anchor="t"/>
+          <a:lstStyle/>
+          <a:p>
+            <a:pPr indent="0" marL="0">
+              <a:buNone/>
+            </a:pPr>
+            <a:r>
+              <a:rPr lang="pt-BR" sz="1100" dirty="0">
+                <a:solidFill>
+                  <a:srgbClr val="1E293B"/>
+                </a:solidFill>
+                <a:latin typeface="Calibri" pitchFamily="34" charset="0"/>
+                <a:ea typeface="Calibri" pitchFamily="34" charset="-122"/>
+                <a:cs typeface="Calibri" pitchFamily="34" charset="-120"/>
+              </a:rPr>
+              <a:t>Admin 👮 — comunicados operacionais e alertas do sistema. Diretoria 🏢 — mensagens estrategicas e diretrizes da empresa.</a:t>
+            </a:r>
+            <a:endParaRPr lang="pt-BR" sz="1100" dirty="0"/>
+          </a:p>
+        </p:txBody>
+      </p:sp>
+    </p:spTree>
+  </p:cSld>
+  <p:clrMapOvr>
+    <a:masterClrMapping/>
+  </p:clrMapOvr>
+</p:sld>
+</file>
+
 <file path=ppt/slides/slide4.xml><?xml version="1.0" encoding="utf-8"?>
 <p:sld xmlns:a="http://schemas.openxmlformats.org/drawingml/2006/main" xmlns:r="http://schemas.openxmlformats.org/officeDocument/2006/relationships" xmlns:p="http://schemas.openxmlformats.org/presentationml/2006/main">
   <p:cSld name="Slide 4">

</xml_diff>

<commit_message>
docs: atualiza Manual e apresentacao com mudancas desde julho
Manual Word: reescreve status de Compras + capitulos 10.3-10.5 (Mesa de
Cotacoes, alcadas/departamento, conferencia tecnica/faturamento);
12.4 (responsaveis/apoios livres); 14.1 (Fretes); nota de OS veicular
no Fiscal (16); tabela e explicacao completa do fluxo de manutencao
veicular reformulado (18.2); 24.7 (departamentos/alcadas de compras);
link direto de mencoes (29.2); novo capitulo 32 (Aba Financeiro);
sumario atualizado com os capitulos 29-32. PDF regenerado a partir
do Word atualizado.

PPTX: 6 novos slides (40-45) cobrindo SAC veicular reformulado
(fluxo + CQ/Fiscal/entrega), Mesa de Cotacoes/aprovacoes, conferencia
tecnica/faturamento, Fretes e responsaveis/apoios livres -- inseridos
antes do slide de encerramento.

Co-Authored-By: Claude Sonnet 5 <noreply@anthropic.com>
</commit_message>
<xml_diff>
--- a/ACN_Sinal_Verde_Treinamento.pptx
+++ b/ACN_Sinal_Verde_Treinamento.pptx
@@ -43,6 +43,12 @@
     <p:sldId id="293" r:id="rId44"/>
     <p:sldId id="292" r:id="rId43"/>
     <p:sldId id="291" r:id="rId42"/>
+    <p:sldId id="295" r:id="rId46"/>
+    <p:sldId id="296" r:id="rId47"/>
+    <p:sldId id="297" r:id="rId48"/>
+    <p:sldId id="298" r:id="rId49"/>
+    <p:sldId id="299" r:id="rId50"/>
+    <p:sldId id="300" r:id="rId51"/>
     <p:sldId id="287" r:id="rId33"/>
   </p:sldIdLst>
   <p:notesMasterIdLst>
@@ -28390,6 +28396,3035 @@
 </p:sld>
 </file>
 
+<file path=ppt/slides/slide40.xml><?xml version="1.0" encoding="utf-8"?>
+<p:sld xmlns:a="http://schemas.openxmlformats.org/drawingml/2006/main" xmlns:r="http://schemas.openxmlformats.org/officeDocument/2006/relationships" xmlns:p="http://schemas.openxmlformats.org/presentationml/2006/main">
+  <p:cSld name="Slide 40">
+    <p:spTree>
+      <p:nvGrpSpPr>
+        <p:cNvPr id="1" name=""/>
+        <p:cNvGrpSpPr/>
+        <p:nvPr/>
+      </p:nvGrpSpPr>
+      <p:grpSpPr>
+        <a:xfrm>
+          <a:off x="0" y="0"/>
+          <a:ext cx="0" cy="0"/>
+          <a:chOff x="0" y="0"/>
+          <a:chExt cx="0" cy="0"/>
+        </a:xfrm>
+      </p:grpSpPr>
+      <p:sp>
+        <p:nvSpPr>
+          <p:cNvPr id="2" name="BG"/>
+          <p:cNvSpPr/>
+          <p:nvPr/>
+        </p:nvSpPr>
+        <p:spPr>
+          <a:xfrm>
+            <a:off x="0" y="0"/>
+            <a:ext cx="9144000" cy="5143500"/>
+          </a:xfrm>
+          <a:prstGeom prst="rect">
+            <a:avLst/>
+          </a:prstGeom>
+          <a:solidFill>
+            <a:srgbClr val="FFFFFF"/>
+          </a:solidFill>
+          <a:ln w="12700">
+            <a:solidFill>
+              <a:srgbClr val="FFFFFF"/>
+            </a:solidFill>
+            <a:prstDash val="solid"/>
+          </a:ln>
+        </p:spPr>
+      </p:sp>
+      <p:sp>
+        <p:nvSpPr>
+          <p:cNvPr id="3" name="ModLabel"/>
+          <p:cNvSpPr/>
+          <p:nvPr/>
+        </p:nvSpPr>
+        <p:spPr>
+          <a:xfrm>
+            <a:off x="457200" y="182880"/>
+            <a:ext cx="7315200" cy="201168"/>
+          </a:xfrm>
+          <a:prstGeom prst="rect">
+            <a:avLst/>
+          </a:prstGeom>
+          <a:noFill/>
+          <a:ln/>
+        </p:spPr>
+        <p:txBody>
+          <a:bodyPr wrap="square" lIns="45720" tIns="45720" rIns="45720" bIns="45720" rtlCol="0" anchor="t"/>
+          <a:lstStyle/>
+          <a:p>
+            <a:pPr indent="0" marL="0">
+              <a:buNone/>
+            </a:pPr>
+            <a:r>
+              <a:rPr lang="pt-BR" sz="950" b="1" dirty="0">
+                <a:solidFill>
+                  <a:srgbClr val="94A3B8"/>
+                </a:solidFill>
+                <a:latin typeface="Calibri" pitchFamily="34" charset="0"/>
+              </a:rPr>
+              <a:t>MÓDULO SAC</a:t>
+            </a:r>
+            <a:endParaRPr lang="pt-BR" sz="950" dirty="0"/>
+          </a:p>
+        </p:txBody>
+      </p:sp>
+      <p:sp>
+        <p:nvSpPr>
+          <p:cNvPr id="4" name="Title"/>
+          <p:cNvSpPr/>
+          <p:nvPr/>
+        </p:nvSpPr>
+        <p:spPr>
+          <a:xfrm>
+            <a:off x="457200" y="384048"/>
+            <a:ext cx="8229600" cy="480000"/>
+          </a:xfrm>
+          <a:prstGeom prst="rect">
+            <a:avLst/>
+          </a:prstGeom>
+          <a:noFill/>
+          <a:ln/>
+        </p:spPr>
+        <p:txBody>
+          <a:bodyPr wrap="square" lIns="45720" tIns="45720" rIns="45720" bIns="45720" rtlCol="0" anchor="ctr"/>
+          <a:lstStyle/>
+          <a:p>
+            <a:pPr indent="0" marL="0">
+              <a:buNone/>
+            </a:pPr>
+            <a:r>
+              <a:rPr lang="pt-BR" sz="2600" b="1" dirty="0">
+                <a:solidFill>
+                  <a:srgbClr val="166534"/>
+                </a:solidFill>
+                <a:latin typeface="Calibri" pitchFamily="34" charset="0"/>
+              </a:rPr>
+              <a:t>SAC Veicular — Fluxo Reformulado</a:t>
+            </a:r>
+            <a:endParaRPr lang="pt-BR" sz="2600" dirty="0"/>
+          </a:p>
+        </p:txBody>
+      </p:sp>
+      <p:sp>
+        <p:nvSpPr>
+          <p:cNvPr id="5" name="ColBG5"/>
+          <p:cNvSpPr/>
+          <p:nvPr/>
+        </p:nvSpPr>
+        <p:spPr>
+          <a:xfrm>
+            <a:off x="457200" y="1000000"/>
+            <a:ext cx="4000500" cy="4023500"/>
+          </a:xfrm>
+          <a:prstGeom prst="roundRect">
+            <a:avLst>
+              <a:gd name="adj" fmla="val 4082"/>
+            </a:avLst>
+          </a:prstGeom>
+          <a:solidFill>
+            <a:srgbClr val="F0FDF4"/>
+          </a:solidFill>
+          <a:ln w="12700">
+            <a:solidFill>
+              <a:srgbClr val="F0FDF4"/>
+            </a:solidFill>
+            <a:prstDash val="solid"/>
+          </a:ln>
+        </p:spPr>
+      </p:sp>
+      <p:sp>
+        <p:nvSpPr>
+          <p:cNvPr id="6" name="ColTitle5"/>
+          <p:cNvSpPr/>
+          <p:nvPr/>
+        </p:nvSpPr>
+        <p:spPr>
+          <a:xfrm>
+            <a:off x="547200" y="1110000"/>
+            <a:ext cx="3820500" cy="330000"/>
+          </a:xfrm>
+          <a:prstGeom prst="rect">
+            <a:avLst/>
+          </a:prstGeom>
+          <a:noFill/>
+          <a:ln/>
+        </p:spPr>
+        <p:txBody>
+          <a:bodyPr wrap="square" lIns="45720" tIns="45720" rIns="45720" bIns="45720" rtlCol="0" anchor="t"/>
+          <a:lstStyle/>
+          <a:p>
+            <a:pPr indent="0" marL="0">
+              <a:buNone/>
+            </a:pPr>
+            <a:r>
+              <a:rPr lang="pt-BR" sz="1500" b="1" dirty="0">
+                <a:solidFill>
+                  <a:srgbClr val="166534"/>
+                </a:solidFill>
+                <a:latin typeface="Calibri" pitchFamily="34" charset="0"/>
+              </a:rPr>
+              <a:t>📍 Presencial vs 📡 Remota</a:t>
+            </a:r>
+            <a:endParaRPr lang="pt-BR" sz="1500" dirty="0"/>
+          </a:p>
+        </p:txBody>
+      </p:sp>
+      <p:sp>
+        <p:nvSpPr>
+          <p:cNvPr id="7" name="Bullet7"/>
+          <p:cNvSpPr/>
+          <p:nvPr/>
+        </p:nvSpPr>
+        <p:spPr>
+          <a:xfrm>
+            <a:off x="547200" y="1520000"/>
+            <a:ext cx="3820500" cy="420000"/>
+          </a:xfrm>
+          <a:prstGeom prst="rect">
+            <a:avLst/>
+          </a:prstGeom>
+          <a:noFill/>
+          <a:ln/>
+        </p:spPr>
+        <p:txBody>
+          <a:bodyPr wrap="square" lIns="45720" tIns="45720" rIns="45720" bIns="45720" rtlCol="0" anchor="t"/>
+          <a:lstStyle/>
+          <a:p>
+            <a:pPr indent="0" marL="0">
+              <a:buNone/>
+            </a:pPr>
+            <a:r>
+              <a:rPr lang="pt-BR" sz="1050" dirty="0">
+                <a:solidFill>
+                  <a:srgbClr val="1E293B"/>
+                </a:solidFill>
+                <a:latin typeface="Calibri" pitchFamily="34" charset="0"/>
+              </a:rPr>
+              <a:t>Presencial: veículo vai até a ACN. Orçamento só depois da chegada (🚗 Chegou → Verificação e Orçamento).</a:t>
+            </a:r>
+            <a:endParaRPr lang="pt-BR" sz="1050" dirty="0"/>
+          </a:p>
+        </p:txBody>
+      </p:sp>
+      <p:sp>
+        <p:nvSpPr>
+          <p:cNvPr id="8" name="Bullet8"/>
+          <p:cNvSpPr/>
+          <p:nvPr/>
+        </p:nvSpPr>
+        <p:spPr>
+          <a:xfrm>
+            <a:off x="547200" y="1980000"/>
+            <a:ext cx="3820500" cy="420000"/>
+          </a:xfrm>
+          <a:prstGeom prst="rect">
+            <a:avLst/>
+          </a:prstGeom>
+          <a:noFill/>
+          <a:ln/>
+        </p:spPr>
+        <p:txBody>
+          <a:bodyPr wrap="square" lIns="45720" tIns="45720" rIns="45720" bIns="45720" rtlCol="0" anchor="t"/>
+          <a:lstStyle/>
+          <a:p>
+            <a:pPr indent="0" marL="0">
+              <a:buNone/>
+            </a:pPr>
+            <a:r>
+              <a:rPr lang="pt-BR" sz="1050" dirty="0">
+                <a:solidFill>
+                  <a:srgbClr val="1E293B"/>
+                </a:solidFill>
+                <a:latin typeface="Calibri" pitchFamily="34" charset="0"/>
+              </a:rPr>
+              <a:t>Remota: cotação já fechada antes de agendar — pula direto pra Aguardando Início.</a:t>
+            </a:r>
+            <a:endParaRPr lang="pt-BR" sz="1050" dirty="0"/>
+          </a:p>
+        </p:txBody>
+      </p:sp>
+      <p:sp>
+        <p:nvSpPr>
+          <p:cNvPr id="9" name="Bullet9"/>
+          <p:cNvSpPr/>
+          <p:nvPr/>
+        </p:nvSpPr>
+        <p:spPr>
+          <a:xfrm>
+            <a:off x="547200" y="2440000"/>
+            <a:ext cx="3820500" cy="420000"/>
+          </a:xfrm>
+          <a:prstGeom prst="rect">
+            <a:avLst/>
+          </a:prstGeom>
+          <a:noFill/>
+          <a:ln/>
+        </p:spPr>
+        <p:txBody>
+          <a:bodyPr wrap="square" lIns="45720" tIns="45720" rIns="45720" bIns="45720" rtlCol="0" anchor="t"/>
+          <a:lstStyle/>
+          <a:p>
+            <a:pPr indent="0" marL="0">
+              <a:buNone/>
+            </a:pPr>
+            <a:r>
+              <a:rPr lang="pt-BR" sz="1050" dirty="0">
+                <a:solidFill>
+                  <a:srgbClr val="1E293B"/>
+                </a:solidFill>
+                <a:latin typeface="Calibri" pitchFamily="34" charset="0"/>
+              </a:rPr>
+              <a:t>Os dois caminhos se unem em Aguardando Início.</a:t>
+            </a:r>
+            <a:endParaRPr lang="pt-BR" sz="1050" dirty="0"/>
+          </a:p>
+        </p:txBody>
+      </p:sp>
+      <p:sp>
+        <p:nvSpPr>
+          <p:cNvPr id="10" name="Bullet10"/>
+          <p:cNvSpPr/>
+          <p:nvPr/>
+        </p:nvSpPr>
+        <p:spPr>
+          <a:xfrm>
+            <a:off x="547200" y="2900000"/>
+            <a:ext cx="3820500" cy="420000"/>
+          </a:xfrm>
+          <a:prstGeom prst="rect">
+            <a:avLst/>
+          </a:prstGeom>
+          <a:noFill/>
+          <a:ln/>
+        </p:spPr>
+        <p:txBody>
+          <a:bodyPr wrap="square" lIns="45720" tIns="45720" rIns="45720" bIns="45720" rtlCol="0" anchor="t"/>
+          <a:lstStyle/>
+          <a:p>
+            <a:pPr indent="0" marL="0">
+              <a:buNone/>
+            </a:pPr>
+            <a:r>
+              <a:rPr lang="pt-BR" sz="1050" dirty="0">
+                <a:solidFill>
+                  <a:srgbClr val="1E293B"/>
+                </a:solidFill>
+                <a:latin typeface="Calibri" pitchFamily="34" charset="0"/>
+              </a:rPr>
+              <a:t>Adaptação atribui o técnico (▶️ Iniciar) pra começar a execução.</a:t>
+            </a:r>
+            <a:endParaRPr lang="pt-BR" sz="1050" dirty="0"/>
+          </a:p>
+        </p:txBody>
+      </p:sp>
+      <p:sp>
+        <p:nvSpPr>
+          <p:cNvPr id="11" name="ColBG11"/>
+          <p:cNvSpPr/>
+          <p:nvPr/>
+        </p:nvSpPr>
+        <p:spPr>
+          <a:xfrm>
+            <a:off x="4686300" y="1000000"/>
+            <a:ext cx="4000500" cy="4023500"/>
+          </a:xfrm>
+          <a:prstGeom prst="roundRect">
+            <a:avLst>
+              <a:gd name="adj" fmla="val 4082"/>
+            </a:avLst>
+          </a:prstGeom>
+          <a:solidFill>
+            <a:srgbClr val="EFF6FF"/>
+          </a:solidFill>
+          <a:ln w="12700">
+            <a:solidFill>
+              <a:srgbClr val="EFF6FF"/>
+            </a:solidFill>
+            <a:prstDash val="solid"/>
+          </a:ln>
+        </p:spPr>
+      </p:sp>
+      <p:sp>
+        <p:nvSpPr>
+          <p:cNvPr id="12" name="ColTitle11"/>
+          <p:cNvSpPr/>
+          <p:nvPr/>
+        </p:nvSpPr>
+        <p:spPr>
+          <a:xfrm>
+            <a:off x="4776300" y="1110000"/>
+            <a:ext cx="3820500" cy="330000"/>
+          </a:xfrm>
+          <a:prstGeom prst="rect">
+            <a:avLst/>
+          </a:prstGeom>
+          <a:noFill/>
+          <a:ln/>
+        </p:spPr>
+        <p:txBody>
+          <a:bodyPr wrap="square" lIns="45720" tIns="45720" rIns="45720" bIns="45720" rtlCol="0" anchor="t"/>
+          <a:lstStyle/>
+          <a:p>
+            <a:pPr indent="0" marL="0">
+              <a:buNone/>
+            </a:pPr>
+            <a:r>
+              <a:rPr lang="pt-BR" sz="1500" b="1" dirty="0">
+                <a:solidFill>
+                  <a:srgbClr val="1D4ED8"/>
+                </a:solidFill>
+                <a:latin typeface="Calibri" pitchFamily="34" charset="0"/>
+              </a:rPr>
+              <a:t>🔁 Revisão de Orçamento</a:t>
+            </a:r>
+            <a:endParaRPr lang="pt-BR" sz="1500" dirty="0"/>
+          </a:p>
+        </p:txBody>
+      </p:sp>
+      <p:sp>
+        <p:nvSpPr>
+          <p:cNvPr id="13" name="Bullet13"/>
+          <p:cNvSpPr/>
+          <p:nvPr/>
+        </p:nvSpPr>
+        <p:spPr>
+          <a:xfrm>
+            <a:off x="4776300" y="1520000"/>
+            <a:ext cx="3820500" cy="420000"/>
+          </a:xfrm>
+          <a:prstGeom prst="rect">
+            <a:avLst/>
+          </a:prstGeom>
+          <a:noFill/>
+          <a:ln/>
+        </p:spPr>
+        <p:txBody>
+          <a:bodyPr wrap="square" lIns="45720" tIns="45720" rIns="45720" bIns="45720" rtlCol="0" anchor="t"/>
+          <a:lstStyle/>
+          <a:p>
+            <a:pPr indent="0" marL="0">
+              <a:buNone/>
+            </a:pPr>
+            <a:r>
+              <a:rPr lang="pt-BR" sz="1050" dirty="0">
+                <a:solidFill>
+                  <a:srgbClr val="1E293B"/>
+                </a:solidFill>
+                <a:latin typeface="Calibri" pitchFamily="34" charset="0"/>
+              </a:rPr>
+              <a:t>Ao concluir, o sistema compara os itens usados com o valor aprovado.</a:t>
+            </a:r>
+            <a:endParaRPr lang="pt-BR" sz="1050" dirty="0"/>
+          </a:p>
+        </p:txBody>
+      </p:sp>
+      <p:sp>
+        <p:nvSpPr>
+          <p:cNvPr id="14" name="Bullet14"/>
+          <p:cNvSpPr/>
+          <p:nvPr/>
+        </p:nvSpPr>
+        <p:spPr>
+          <a:xfrm>
+            <a:off x="4776300" y="1980000"/>
+            <a:ext cx="3820500" cy="420000"/>
+          </a:xfrm>
+          <a:prstGeom prst="rect">
+            <a:avLst/>
+          </a:prstGeom>
+          <a:noFill/>
+          <a:ln/>
+        </p:spPr>
+        <p:txBody>
+          <a:bodyPr wrap="square" lIns="45720" tIns="45720" rIns="45720" bIns="45720" rtlCol="0" anchor="t"/>
+          <a:lstStyle/>
+          <a:p>
+            <a:pPr indent="0" marL="0">
+              <a:buNone/>
+            </a:pPr>
+            <a:r>
+              <a:rPr lang="pt-BR" sz="1050" dirty="0">
+                <a:solidFill>
+                  <a:srgbClr val="1E293B"/>
+                </a:solidFill>
+                <a:latin typeface="Calibri" pitchFamily="34" charset="0"/>
+              </a:rPr>
+              <a:t>Bateu → segue direto pro Checklist de Qualidade.</a:t>
+            </a:r>
+            <a:endParaRPr lang="pt-BR" sz="1050" dirty="0"/>
+          </a:p>
+        </p:txBody>
+      </p:sp>
+      <p:sp>
+        <p:nvSpPr>
+          <p:cNvPr id="15" name="Bullet15"/>
+          <p:cNvSpPr/>
+          <p:nvPr/>
+        </p:nvSpPr>
+        <p:spPr>
+          <a:xfrm>
+            <a:off x="4776300" y="2440000"/>
+            <a:ext cx="3820500" cy="420000"/>
+          </a:xfrm>
+          <a:prstGeom prst="rect">
+            <a:avLst/>
+          </a:prstGeom>
+          <a:noFill/>
+          <a:ln/>
+        </p:spPr>
+        <p:txBody>
+          <a:bodyPr wrap="square" lIns="45720" tIns="45720" rIns="45720" bIns="45720" rtlCol="0" anchor="t"/>
+          <a:lstStyle/>
+          <a:p>
+            <a:pPr indent="0" marL="0">
+              <a:buNone/>
+            </a:pPr>
+            <a:r>
+              <a:rPr lang="pt-BR" sz="1050" dirty="0">
+                <a:solidFill>
+                  <a:srgbClr val="1E293B"/>
+                </a:solidFill>
+                <a:latin typeface="Calibri" pitchFamily="34" charset="0"/>
+              </a:rPr>
+              <a:t>Não bateu → OS fica parada e o SAC recebe um alerta pra negociar com o cliente.</a:t>
+            </a:r>
+            <a:endParaRPr lang="pt-BR" sz="1050" dirty="0"/>
+          </a:p>
+        </p:txBody>
+      </p:sp>
+      <p:sp>
+        <p:nvSpPr>
+          <p:cNvPr id="16" name="Bullet16"/>
+          <p:cNvSpPr/>
+          <p:nvPr/>
+        </p:nvSpPr>
+        <p:spPr>
+          <a:xfrm>
+            <a:off x="4776300" y="2900000"/>
+            <a:ext cx="3820500" cy="420000"/>
+          </a:xfrm>
+          <a:prstGeom prst="rect">
+            <a:avLst/>
+          </a:prstGeom>
+          <a:noFill/>
+          <a:ln/>
+        </p:spPr>
+        <p:txBody>
+          <a:bodyPr wrap="square" lIns="45720" tIns="45720" rIns="45720" bIns="45720" rtlCol="0" anchor="t"/>
+          <a:lstStyle/>
+          <a:p>
+            <a:pPr indent="0" marL="0">
+              <a:buNone/>
+            </a:pPr>
+            <a:r>
+              <a:rPr lang="pt-BR" sz="1050" dirty="0">
+                <a:solidFill>
+                  <a:srgbClr val="1E293B"/>
+                </a:solidFill>
+                <a:latin typeface="Calibri" pitchFamily="34" charset="0"/>
+              </a:rPr>
+              <a:t>Botão 🔁 Resolver Revisão libera a Adaptação pra concluir de novo.</a:t>
+            </a:r>
+            <a:endParaRPr lang="pt-BR" sz="1050" dirty="0"/>
+          </a:p>
+        </p:txBody>
+      </p:sp>
+    </p:spTree>
+  </p:cSld>
+  <p:clrMapOvr>
+    <a:masterClrMapping/>
+  </p:clrMapOvr>
+</p:sld>
+</file>
+
+<file path=ppt/slides/slide41.xml><?xml version="1.0" encoding="utf-8"?>
+<p:sld xmlns:a="http://schemas.openxmlformats.org/drawingml/2006/main" xmlns:r="http://schemas.openxmlformats.org/officeDocument/2006/relationships" xmlns:p="http://schemas.openxmlformats.org/presentationml/2006/main">
+  <p:cSld name="Slide 41">
+    <p:spTree>
+      <p:nvGrpSpPr>
+        <p:cNvPr id="1" name=""/>
+        <p:cNvGrpSpPr/>
+        <p:nvPr/>
+      </p:nvGrpSpPr>
+      <p:grpSpPr>
+        <a:xfrm>
+          <a:off x="0" y="0"/>
+          <a:ext cx="0" cy="0"/>
+          <a:chOff x="0" y="0"/>
+          <a:chExt cx="0" cy="0"/>
+        </a:xfrm>
+      </p:grpSpPr>
+      <p:sp>
+        <p:nvSpPr>
+          <p:cNvPr id="2" name="BG"/>
+          <p:cNvSpPr/>
+          <p:nvPr/>
+        </p:nvSpPr>
+        <p:spPr>
+          <a:xfrm>
+            <a:off x="0" y="0"/>
+            <a:ext cx="9144000" cy="5143500"/>
+          </a:xfrm>
+          <a:prstGeom prst="rect">
+            <a:avLst/>
+          </a:prstGeom>
+          <a:solidFill>
+            <a:srgbClr val="FFFFFF"/>
+          </a:solidFill>
+          <a:ln w="12700">
+            <a:solidFill>
+              <a:srgbClr val="FFFFFF"/>
+            </a:solidFill>
+            <a:prstDash val="solid"/>
+          </a:ln>
+        </p:spPr>
+      </p:sp>
+      <p:sp>
+        <p:nvSpPr>
+          <p:cNvPr id="3" name="ModLabel"/>
+          <p:cNvSpPr/>
+          <p:nvPr/>
+        </p:nvSpPr>
+        <p:spPr>
+          <a:xfrm>
+            <a:off x="457200" y="182880"/>
+            <a:ext cx="7315200" cy="201168"/>
+          </a:xfrm>
+          <a:prstGeom prst="rect">
+            <a:avLst/>
+          </a:prstGeom>
+          <a:noFill/>
+          <a:ln/>
+        </p:spPr>
+        <p:txBody>
+          <a:bodyPr wrap="square" lIns="45720" tIns="45720" rIns="45720" bIns="45720" rtlCol="0" anchor="t"/>
+          <a:lstStyle/>
+          <a:p>
+            <a:pPr indent="0" marL="0">
+              <a:buNone/>
+            </a:pPr>
+            <a:r>
+              <a:rPr lang="pt-BR" sz="950" b="1" dirty="0">
+                <a:solidFill>
+                  <a:srgbClr val="94A3B8"/>
+                </a:solidFill>
+                <a:latin typeface="Calibri" pitchFamily="34" charset="0"/>
+              </a:rPr>
+              <a:t>MÓDULO SAC</a:t>
+            </a:r>
+            <a:endParaRPr lang="pt-BR" sz="950" dirty="0"/>
+          </a:p>
+        </p:txBody>
+      </p:sp>
+      <p:sp>
+        <p:nvSpPr>
+          <p:cNvPr id="4" name="Title"/>
+          <p:cNvSpPr/>
+          <p:nvPr/>
+        </p:nvSpPr>
+        <p:spPr>
+          <a:xfrm>
+            <a:off x="457200" y="384048"/>
+            <a:ext cx="8229600" cy="480000"/>
+          </a:xfrm>
+          <a:prstGeom prst="rect">
+            <a:avLst/>
+          </a:prstGeom>
+          <a:noFill/>
+          <a:ln/>
+        </p:spPr>
+        <p:txBody>
+          <a:bodyPr wrap="square" lIns="45720" tIns="45720" rIns="45720" bIns="45720" rtlCol="0" anchor="ctr"/>
+          <a:lstStyle/>
+          <a:p>
+            <a:pPr indent="0" marL="0">
+              <a:buNone/>
+            </a:pPr>
+            <a:r>
+              <a:rPr lang="pt-BR" sz="2600" b="1" dirty="0">
+                <a:solidFill>
+                  <a:srgbClr val="166534"/>
+                </a:solidFill>
+                <a:latin typeface="Calibri" pitchFamily="34" charset="0"/>
+              </a:rPr>
+              <a:t>SAC Veicular — CQ, Fiscal e Entrega</a:t>
+            </a:r>
+            <a:endParaRPr lang="pt-BR" sz="2600" dirty="0"/>
+          </a:p>
+        </p:txBody>
+      </p:sp>
+      <p:sp>
+        <p:nvSpPr>
+          <p:cNvPr id="5" name="ColBG5"/>
+          <p:cNvSpPr/>
+          <p:nvPr/>
+        </p:nvSpPr>
+        <p:spPr>
+          <a:xfrm>
+            <a:off x="457200" y="1000000"/>
+            <a:ext cx="4000500" cy="4023500"/>
+          </a:xfrm>
+          <a:prstGeom prst="roundRect">
+            <a:avLst>
+              <a:gd name="adj" fmla="val 4082"/>
+            </a:avLst>
+          </a:prstGeom>
+          <a:solidFill>
+            <a:srgbClr val="F0FDF4"/>
+          </a:solidFill>
+          <a:ln w="12700">
+            <a:solidFill>
+              <a:srgbClr val="F0FDF4"/>
+            </a:solidFill>
+            <a:prstDash val="solid"/>
+          </a:ln>
+        </p:spPr>
+      </p:sp>
+      <p:sp>
+        <p:nvSpPr>
+          <p:cNvPr id="6" name="ColTitle5"/>
+          <p:cNvSpPr/>
+          <p:nvPr/>
+        </p:nvSpPr>
+        <p:spPr>
+          <a:xfrm>
+            <a:off x="547200" y="1110000"/>
+            <a:ext cx="3820500" cy="330000"/>
+          </a:xfrm>
+          <a:prstGeom prst="rect">
+            <a:avLst/>
+          </a:prstGeom>
+          <a:noFill/>
+          <a:ln/>
+        </p:spPr>
+        <p:txBody>
+          <a:bodyPr wrap="square" lIns="45720" tIns="45720" rIns="45720" bIns="45720" rtlCol="0" anchor="t"/>
+          <a:lstStyle/>
+          <a:p>
+            <a:pPr indent="0" marL="0">
+              <a:buNone/>
+            </a:pPr>
+            <a:r>
+              <a:rPr lang="pt-BR" sz="1500" b="1" dirty="0">
+                <a:solidFill>
+                  <a:srgbClr val="166534"/>
+                </a:solidFill>
+                <a:latin typeface="Calibri" pitchFamily="34" charset="0"/>
+              </a:rPr>
+              <a:t>✅ Checklist de Qualidade</a:t>
+            </a:r>
+            <a:endParaRPr lang="pt-BR" sz="1500" dirty="0"/>
+          </a:p>
+        </p:txBody>
+      </p:sp>
+      <p:sp>
+        <p:nvSpPr>
+          <p:cNvPr id="7" name="Bullet7"/>
+          <p:cNvSpPr/>
+          <p:nvPr/>
+        </p:nvSpPr>
+        <p:spPr>
+          <a:xfrm>
+            <a:off x="547200" y="1520000"/>
+            <a:ext cx="3820500" cy="420000"/>
+          </a:xfrm>
+          <a:prstGeom prst="rect">
+            <a:avLst/>
+          </a:prstGeom>
+          <a:noFill/>
+          <a:ln/>
+        </p:spPr>
+        <p:txBody>
+          <a:bodyPr wrap="square" lIns="45720" tIns="45720" rIns="45720" bIns="45720" rtlCol="0" anchor="t"/>
+          <a:lstStyle/>
+          <a:p>
+            <a:pPr indent="0" marL="0">
+              <a:buNone/>
+            </a:pPr>
+            <a:r>
+              <a:rPr lang="pt-BR" sz="1050" dirty="0">
+                <a:solidFill>
+                  <a:srgbClr val="1E293B"/>
+                </a:solidFill>
+                <a:latin typeface="Calibri" pitchFamily="34" charset="0"/>
+              </a:rPr>
+              <a:t>OSs em Aguardando CQ entram na fila de CQ &amp; Histórico, numa seção própria.</a:t>
+            </a:r>
+            <a:endParaRPr lang="pt-BR" sz="1050" dirty="0"/>
+          </a:p>
+        </p:txBody>
+      </p:sp>
+      <p:sp>
+        <p:nvSpPr>
+          <p:cNvPr id="8" name="Bullet8"/>
+          <p:cNvSpPr/>
+          <p:nvPr/>
+        </p:nvSpPr>
+        <p:spPr>
+          <a:xfrm>
+            <a:off x="547200" y="1980000"/>
+            <a:ext cx="3820500" cy="420000"/>
+          </a:xfrm>
+          <a:prstGeom prst="rect">
+            <a:avLst/>
+          </a:prstGeom>
+          <a:noFill/>
+          <a:ln/>
+        </p:spPr>
+        <p:txBody>
+          <a:bodyPr wrap="square" lIns="45720" tIns="45720" rIns="45720" bIns="45720" rtlCol="0" anchor="t"/>
+          <a:lstStyle/>
+          <a:p>
+            <a:pPr indent="0" marL="0">
+              <a:buNone/>
+            </a:pPr>
+            <a:r>
+              <a:rPr lang="pt-BR" sz="1050" dirty="0">
+                <a:solidFill>
+                  <a:srgbClr val="1E293B"/>
+                </a:solidFill>
+                <a:latin typeface="Calibri" pitchFamily="34" charset="0"/>
+              </a:rPr>
+              <a:t>Mesmo checklist e assinatura digital usados para as OPLs.</a:t>
+            </a:r>
+            <a:endParaRPr lang="pt-BR" sz="1050" dirty="0"/>
+          </a:p>
+        </p:txBody>
+      </p:sp>
+      <p:sp>
+        <p:nvSpPr>
+          <p:cNvPr id="9" name="Bullet9"/>
+          <p:cNvSpPr/>
+          <p:nvPr/>
+        </p:nvSpPr>
+        <p:spPr>
+          <a:xfrm>
+            <a:off x="547200" y="2440000"/>
+            <a:ext cx="3820500" cy="420000"/>
+          </a:xfrm>
+          <a:prstGeom prst="rect">
+            <a:avLst/>
+          </a:prstGeom>
+          <a:noFill/>
+          <a:ln/>
+        </p:spPr>
+        <p:txBody>
+          <a:bodyPr wrap="square" lIns="45720" tIns="45720" rIns="45720" bIns="45720" rtlCol="0" anchor="t"/>
+          <a:lstStyle/>
+          <a:p>
+            <a:pPr indent="0" marL="0">
+              <a:buNone/>
+            </a:pPr>
+            <a:r>
+              <a:rPr lang="pt-BR" sz="1050" dirty="0">
+                <a:solidFill>
+                  <a:srgbClr val="1E293B"/>
+                </a:solidFill>
+                <a:latin typeface="Calibri" pitchFamily="34" charset="0"/>
+              </a:rPr>
+              <a:t>Reprovada → volta para Em Execução.</a:t>
+            </a:r>
+            <a:endParaRPr lang="pt-BR" sz="1050" dirty="0"/>
+          </a:p>
+        </p:txBody>
+      </p:sp>
+      <p:sp>
+        <p:nvSpPr>
+          <p:cNvPr id="10" name="ColBG10"/>
+          <p:cNvSpPr/>
+          <p:nvPr/>
+        </p:nvSpPr>
+        <p:spPr>
+          <a:xfrm>
+            <a:off x="4686300" y="1000000"/>
+            <a:ext cx="4000500" cy="4023500"/>
+          </a:xfrm>
+          <a:prstGeom prst="roundRect">
+            <a:avLst>
+              <a:gd name="adj" fmla="val 4082"/>
+            </a:avLst>
+          </a:prstGeom>
+          <a:solidFill>
+            <a:srgbClr val="EFF6FF"/>
+          </a:solidFill>
+          <a:ln w="12700">
+            <a:solidFill>
+              <a:srgbClr val="EFF6FF"/>
+            </a:solidFill>
+            <a:prstDash val="solid"/>
+          </a:ln>
+        </p:spPr>
+      </p:sp>
+      <p:sp>
+        <p:nvSpPr>
+          <p:cNvPr id="11" name="ColTitle10"/>
+          <p:cNvSpPr/>
+          <p:nvPr/>
+        </p:nvSpPr>
+        <p:spPr>
+          <a:xfrm>
+            <a:off x="4776300" y="1110000"/>
+            <a:ext cx="3820500" cy="330000"/>
+          </a:xfrm>
+          <a:prstGeom prst="rect">
+            <a:avLst/>
+          </a:prstGeom>
+          <a:noFill/>
+          <a:ln/>
+        </p:spPr>
+        <p:txBody>
+          <a:bodyPr wrap="square" lIns="45720" tIns="45720" rIns="45720" bIns="45720" rtlCol="0" anchor="t"/>
+          <a:lstStyle/>
+          <a:p>
+            <a:pPr indent="0" marL="0">
+              <a:buNone/>
+            </a:pPr>
+            <a:r>
+              <a:rPr lang="pt-BR" sz="1500" b="1" dirty="0">
+                <a:solidFill>
+                  <a:srgbClr val="1D4ED8"/>
+                </a:solidFill>
+                <a:latin typeface="Calibri" pitchFamily="34" charset="0"/>
+              </a:rPr>
+              <a:t>📤 Fiscal e Entrega</a:t>
+            </a:r>
+            <a:endParaRPr lang="pt-BR" sz="1500" dirty="0"/>
+          </a:p>
+        </p:txBody>
+      </p:sp>
+      <p:sp>
+        <p:nvSpPr>
+          <p:cNvPr id="12" name="Bullet12"/>
+          <p:cNvSpPr/>
+          <p:nvPr/>
+        </p:nvSpPr>
+        <p:spPr>
+          <a:xfrm>
+            <a:off x="4776300" y="1520000"/>
+            <a:ext cx="3820500" cy="420000"/>
+          </a:xfrm>
+          <a:prstGeom prst="rect">
+            <a:avLst/>
+          </a:prstGeom>
+          <a:noFill/>
+          <a:ln/>
+        </p:spPr>
+        <p:txBody>
+          <a:bodyPr wrap="square" lIns="45720" tIns="45720" rIns="45720" bIns="45720" rtlCol="0" anchor="t"/>
+          <a:lstStyle/>
+          <a:p>
+            <a:pPr indent="0" marL="0">
+              <a:buNone/>
+            </a:pPr>
+            <a:r>
+              <a:rPr lang="pt-BR" sz="1050" dirty="0">
+                <a:solidFill>
+                  <a:srgbClr val="1E293B"/>
+                </a:solidFill>
+                <a:latin typeface="Calibri" pitchFamily="34" charset="0"/>
+              </a:rPr>
+              <a:t>SAC informa o nº de série de cada item instalado antes de enviar ao Fiscal.</a:t>
+            </a:r>
+            <a:endParaRPr lang="pt-BR" sz="1050" dirty="0"/>
+          </a:p>
+        </p:txBody>
+      </p:sp>
+      <p:sp>
+        <p:nvSpPr>
+          <p:cNvPr id="13" name="Bullet13"/>
+          <p:cNvSpPr/>
+          <p:nvPr/>
+        </p:nvSpPr>
+        <p:spPr>
+          <a:xfrm>
+            <a:off x="4776300" y="1980000"/>
+            <a:ext cx="3820500" cy="420000"/>
+          </a:xfrm>
+          <a:prstGeom prst="rect">
+            <a:avLst/>
+          </a:prstGeom>
+          <a:noFill/>
+          <a:ln/>
+        </p:spPr>
+        <p:txBody>
+          <a:bodyPr wrap="square" lIns="45720" tIns="45720" rIns="45720" bIns="45720" rtlCol="0" anchor="t"/>
+          <a:lstStyle/>
+          <a:p>
+            <a:pPr indent="0" marL="0">
+              <a:buNone/>
+            </a:pPr>
+            <a:r>
+              <a:rPr lang="pt-BR" sz="1050" dirty="0">
+                <a:solidFill>
+                  <a:srgbClr val="1E293B"/>
+                </a:solidFill>
+                <a:latin typeface="Calibri" pitchFamily="34" charset="0"/>
+              </a:rPr>
+              <a:t>Fiscal emite a NF numa seção própria da aba Fiscal, igual às OPLs.</a:t>
+            </a:r>
+            <a:endParaRPr lang="pt-BR" sz="1050" dirty="0"/>
+          </a:p>
+        </p:txBody>
+      </p:sp>
+      <p:sp>
+        <p:nvSpPr>
+          <p:cNvPr id="14" name="Bullet14"/>
+          <p:cNvSpPr/>
+          <p:nvPr/>
+        </p:nvSpPr>
+        <p:spPr>
+          <a:xfrm>
+            <a:off x="4776300" y="2440000"/>
+            <a:ext cx="3820500" cy="420000"/>
+          </a:xfrm>
+          <a:prstGeom prst="rect">
+            <a:avLst/>
+          </a:prstGeom>
+          <a:noFill/>
+          <a:ln/>
+        </p:spPr>
+        <p:txBody>
+          <a:bodyPr wrap="square" lIns="45720" tIns="45720" rIns="45720" bIns="45720" rtlCol="0" anchor="t"/>
+          <a:lstStyle/>
+          <a:p>
+            <a:pPr indent="0" marL="0">
+              <a:buNone/>
+            </a:pPr>
+            <a:r>
+              <a:rPr lang="pt-BR" sz="1050" dirty="0">
+                <a:solidFill>
+                  <a:srgbClr val="1E293B"/>
+                </a:solidFill>
+                <a:latin typeface="Calibri" pitchFamily="34" charset="0"/>
+              </a:rPr>
+              <a:t>Com a NF emitida, o botão 🚚 Entrega libera no SAC.</a:t>
+            </a:r>
+            <a:endParaRPr lang="pt-BR" sz="1050" dirty="0"/>
+          </a:p>
+        </p:txBody>
+      </p:sp>
+      <p:sp>
+        <p:nvSpPr>
+          <p:cNvPr id="15" name="Bullet15"/>
+          <p:cNvSpPr/>
+          <p:nvPr/>
+        </p:nvSpPr>
+        <p:spPr>
+          <a:xfrm>
+            <a:off x="4776300" y="2900000"/>
+            <a:ext cx="3820500" cy="420000"/>
+          </a:xfrm>
+          <a:prstGeom prst="rect">
+            <a:avLst/>
+          </a:prstGeom>
+          <a:noFill/>
+          <a:ln/>
+        </p:spPr>
+        <p:txBody>
+          <a:bodyPr wrap="square" lIns="45720" tIns="45720" rIns="45720" bIns="45720" rtlCol="0" anchor="t"/>
+          <a:lstStyle/>
+          <a:p>
+            <a:pPr indent="0" marL="0">
+              <a:buNone/>
+            </a:pPr>
+            <a:r>
+              <a:rPr lang="pt-BR" sz="1050" dirty="0">
+                <a:solidFill>
+                  <a:srgbClr val="1E293B"/>
+                </a:solidFill>
+                <a:latin typeface="Calibri" pitchFamily="34" charset="0"/>
+              </a:rPr>
+              <a:t>Novos status: Aguardando Envio Fiscal → Aguardando Emissão NF → Faturada → Entregue.</a:t>
+            </a:r>
+            <a:endParaRPr lang="pt-BR" sz="1050" dirty="0"/>
+          </a:p>
+        </p:txBody>
+      </p:sp>
+    </p:spTree>
+  </p:cSld>
+  <p:clrMapOvr>
+    <a:masterClrMapping/>
+  </p:clrMapOvr>
+</p:sld>
+</file>
+
+<file path=ppt/slides/slide42.xml><?xml version="1.0" encoding="utf-8"?>
+<p:sld xmlns:a="http://schemas.openxmlformats.org/drawingml/2006/main" xmlns:r="http://schemas.openxmlformats.org/officeDocument/2006/relationships" xmlns:p="http://schemas.openxmlformats.org/presentationml/2006/main">
+  <p:cSld name="Slide 42">
+    <p:spTree>
+      <p:nvGrpSpPr>
+        <p:cNvPr id="1" name=""/>
+        <p:cNvGrpSpPr/>
+        <p:nvPr/>
+      </p:nvGrpSpPr>
+      <p:grpSpPr>
+        <a:xfrm>
+          <a:off x="0" y="0"/>
+          <a:ext cx="0" cy="0"/>
+          <a:chOff x="0" y="0"/>
+          <a:chExt cx="0" cy="0"/>
+        </a:xfrm>
+      </p:grpSpPr>
+      <p:sp>
+        <p:nvSpPr>
+          <p:cNvPr id="2" name="BG"/>
+          <p:cNvSpPr/>
+          <p:nvPr/>
+        </p:nvSpPr>
+        <p:spPr>
+          <a:xfrm>
+            <a:off x="0" y="0"/>
+            <a:ext cx="9144000" cy="5143500"/>
+          </a:xfrm>
+          <a:prstGeom prst="rect">
+            <a:avLst/>
+          </a:prstGeom>
+          <a:solidFill>
+            <a:srgbClr val="FFFFFF"/>
+          </a:solidFill>
+          <a:ln w="12700">
+            <a:solidFill>
+              <a:srgbClr val="FFFFFF"/>
+            </a:solidFill>
+            <a:prstDash val="solid"/>
+          </a:ln>
+        </p:spPr>
+      </p:sp>
+      <p:sp>
+        <p:nvSpPr>
+          <p:cNvPr id="3" name="ModLabel"/>
+          <p:cNvSpPr/>
+          <p:nvPr/>
+        </p:nvSpPr>
+        <p:spPr>
+          <a:xfrm>
+            <a:off x="457200" y="182880"/>
+            <a:ext cx="7315200" cy="201168"/>
+          </a:xfrm>
+          <a:prstGeom prst="rect">
+            <a:avLst/>
+          </a:prstGeom>
+          <a:noFill/>
+          <a:ln/>
+        </p:spPr>
+        <p:txBody>
+          <a:bodyPr wrap="square" lIns="45720" tIns="45720" rIns="45720" bIns="45720" rtlCol="0" anchor="t"/>
+          <a:lstStyle/>
+          <a:p>
+            <a:pPr indent="0" marL="0">
+              <a:buNone/>
+            </a:pPr>
+            <a:r>
+              <a:rPr lang="pt-BR" sz="950" b="1" dirty="0">
+                <a:solidFill>
+                  <a:srgbClr val="94A3B8"/>
+                </a:solidFill>
+                <a:latin typeface="Calibri" pitchFamily="34" charset="0"/>
+              </a:rPr>
+              <a:t>MÓDULO COMPRAS</a:t>
+            </a:r>
+            <a:endParaRPr lang="pt-BR" sz="950" dirty="0"/>
+          </a:p>
+        </p:txBody>
+      </p:sp>
+      <p:sp>
+        <p:nvSpPr>
+          <p:cNvPr id="4" name="Title"/>
+          <p:cNvSpPr/>
+          <p:nvPr/>
+        </p:nvSpPr>
+        <p:spPr>
+          <a:xfrm>
+            <a:off x="457200" y="384048"/>
+            <a:ext cx="8229600" cy="480000"/>
+          </a:xfrm>
+          <a:prstGeom prst="rect">
+            <a:avLst/>
+          </a:prstGeom>
+          <a:noFill/>
+          <a:ln/>
+        </p:spPr>
+        <p:txBody>
+          <a:bodyPr wrap="square" lIns="45720" tIns="45720" rIns="45720" bIns="45720" rtlCol="0" anchor="ctr"/>
+          <a:lstStyle/>
+          <a:p>
+            <a:pPr indent="0" marL="0">
+              <a:buNone/>
+            </a:pPr>
+            <a:r>
+              <a:rPr lang="pt-BR" sz="2600" b="1" dirty="0">
+                <a:solidFill>
+                  <a:srgbClr val="166534"/>
+                </a:solidFill>
+                <a:latin typeface="Calibri" pitchFamily="34" charset="0"/>
+              </a:rPr>
+              <a:t>Compras — Mesa de Cotações e Aprovações</a:t>
+            </a:r>
+            <a:endParaRPr lang="pt-BR" sz="2600" dirty="0"/>
+          </a:p>
+        </p:txBody>
+      </p:sp>
+      <p:sp>
+        <p:nvSpPr>
+          <p:cNvPr id="5" name="ColBG5"/>
+          <p:cNvSpPr/>
+          <p:nvPr/>
+        </p:nvSpPr>
+        <p:spPr>
+          <a:xfrm>
+            <a:off x="457200" y="1000000"/>
+            <a:ext cx="4000500" cy="4023500"/>
+          </a:xfrm>
+          <a:prstGeom prst="roundRect">
+            <a:avLst>
+              <a:gd name="adj" fmla="val 4082"/>
+            </a:avLst>
+          </a:prstGeom>
+          <a:solidFill>
+            <a:srgbClr val="F0FDF4"/>
+          </a:solidFill>
+          <a:ln w="12700">
+            <a:solidFill>
+              <a:srgbClr val="F0FDF4"/>
+            </a:solidFill>
+            <a:prstDash val="solid"/>
+          </a:ln>
+        </p:spPr>
+      </p:sp>
+      <p:sp>
+        <p:nvSpPr>
+          <p:cNvPr id="6" name="ColTitle5"/>
+          <p:cNvSpPr/>
+          <p:nvPr/>
+        </p:nvSpPr>
+        <p:spPr>
+          <a:xfrm>
+            <a:off x="547200" y="1110000"/>
+            <a:ext cx="3820500" cy="330000"/>
+          </a:xfrm>
+          <a:prstGeom prst="rect">
+            <a:avLst/>
+          </a:prstGeom>
+          <a:noFill/>
+          <a:ln/>
+        </p:spPr>
+        <p:txBody>
+          <a:bodyPr wrap="square" lIns="45720" tIns="45720" rIns="45720" bIns="45720" rtlCol="0" anchor="t"/>
+          <a:lstStyle/>
+          <a:p>
+            <a:pPr indent="0" marL="0">
+              <a:buNone/>
+            </a:pPr>
+            <a:r>
+              <a:rPr lang="pt-BR" sz="1500" b="1" dirty="0">
+                <a:solidFill>
+                  <a:srgbClr val="166534"/>
+                </a:solidFill>
+                <a:latin typeface="Calibri" pitchFamily="34" charset="0"/>
+              </a:rPr>
+              <a:t>🏷️ Mesa de Cotações</a:t>
+            </a:r>
+            <a:endParaRPr lang="pt-BR" sz="1500" dirty="0"/>
+          </a:p>
+        </p:txBody>
+      </p:sp>
+      <p:sp>
+        <p:nvSpPr>
+          <p:cNvPr id="7" name="Bullet7"/>
+          <p:cNvSpPr/>
+          <p:nvPr/>
+        </p:nvSpPr>
+        <p:spPr>
+          <a:xfrm>
+            <a:off x="547200" y="1520000"/>
+            <a:ext cx="3820500" cy="420000"/>
+          </a:xfrm>
+          <a:prstGeom prst="rect">
+            <a:avLst/>
+          </a:prstGeom>
+          <a:noFill/>
+          <a:ln/>
+        </p:spPr>
+        <p:txBody>
+          <a:bodyPr wrap="square" lIns="45720" tIns="45720" rIns="45720" bIns="45720" rtlCol="0" anchor="t"/>
+          <a:lstStyle/>
+          <a:p>
+            <a:pPr indent="0" marL="0">
+              <a:buNone/>
+            </a:pPr>
+            <a:r>
+              <a:rPr lang="pt-BR" sz="1050" dirty="0">
+                <a:solidFill>
+                  <a:srgbClr val="1E293B"/>
+                </a:solidFill>
+                <a:latin typeface="Calibri" pitchFamily="34" charset="0"/>
+              </a:rPr>
+              <a:t>Mínimo de 3 cotações de fornecedores pra fechar uma compra.</a:t>
+            </a:r>
+            <a:endParaRPr lang="pt-BR" sz="1050" dirty="0"/>
+          </a:p>
+        </p:txBody>
+      </p:sp>
+      <p:sp>
+        <p:nvSpPr>
+          <p:cNvPr id="8" name="Bullet8"/>
+          <p:cNvSpPr/>
+          <p:nvPr/>
+        </p:nvSpPr>
+        <p:spPr>
+          <a:xfrm>
+            <a:off x="547200" y="1980000"/>
+            <a:ext cx="3820500" cy="420000"/>
+          </a:xfrm>
+          <a:prstGeom prst="rect">
+            <a:avLst/>
+          </a:prstGeom>
+          <a:noFill/>
+          <a:ln/>
+        </p:spPr>
+        <p:txBody>
+          <a:bodyPr wrap="square" lIns="45720" tIns="45720" rIns="45720" bIns="45720" rtlCol="0" anchor="t"/>
+          <a:lstStyle/>
+          <a:p>
+            <a:pPr indent="0" marL="0">
+              <a:buNone/>
+            </a:pPr>
+            <a:r>
+              <a:rPr lang="pt-BR" sz="1050" dirty="0">
+                <a:solidFill>
+                  <a:srgbClr val="1E293B"/>
+                </a:solidFill>
+                <a:latin typeface="Calibri" pitchFamily="34" charset="0"/>
+              </a:rPr>
+              <a:t>Cada cotação tem sua própria ✏️ Área Livre pra anotações e prints.</a:t>
+            </a:r>
+            <a:endParaRPr lang="pt-BR" sz="1050" dirty="0"/>
+          </a:p>
+        </p:txBody>
+      </p:sp>
+      <p:sp>
+        <p:nvSpPr>
+          <p:cNvPr id="9" name="Bullet9"/>
+          <p:cNvSpPr/>
+          <p:nvPr/>
+        </p:nvSpPr>
+        <p:spPr>
+          <a:xfrm>
+            <a:off x="547200" y="2440000"/>
+            <a:ext cx="3820500" cy="420000"/>
+          </a:xfrm>
+          <a:prstGeom prst="rect">
+            <a:avLst/>
+          </a:prstGeom>
+          <a:noFill/>
+          <a:ln/>
+        </p:spPr>
+        <p:txBody>
+          <a:bodyPr wrap="square" lIns="45720" tIns="45720" rIns="45720" bIns="45720" rtlCol="0" anchor="t"/>
+          <a:lstStyle/>
+          <a:p>
+            <a:pPr indent="0" marL="0">
+              <a:buNone/>
+            </a:pPr>
+            <a:r>
+              <a:rPr lang="pt-BR" sz="1050" dirty="0">
+                <a:solidFill>
+                  <a:srgbClr val="1E293B"/>
+                </a:solidFill>
+                <a:latin typeface="Calibri" pitchFamily="34" charset="0"/>
+              </a:rPr>
+              <a:t>✅ Aprovar esta cotação como vencedora pede a sua senha de login.</a:t>
+            </a:r>
+            <a:endParaRPr lang="pt-BR" sz="1050" dirty="0"/>
+          </a:p>
+        </p:txBody>
+      </p:sp>
+      <p:sp>
+        <p:nvSpPr>
+          <p:cNvPr id="10" name="ColBG10"/>
+          <p:cNvSpPr/>
+          <p:nvPr/>
+        </p:nvSpPr>
+        <p:spPr>
+          <a:xfrm>
+            <a:off x="4686300" y="1000000"/>
+            <a:ext cx="4000500" cy="4023500"/>
+          </a:xfrm>
+          <a:prstGeom prst="roundRect">
+            <a:avLst>
+              <a:gd name="adj" fmla="val 4082"/>
+            </a:avLst>
+          </a:prstGeom>
+          <a:solidFill>
+            <a:srgbClr val="EFF6FF"/>
+          </a:solidFill>
+          <a:ln w="12700">
+            <a:solidFill>
+              <a:srgbClr val="EFF6FF"/>
+            </a:solidFill>
+            <a:prstDash val="solid"/>
+          </a:ln>
+        </p:spPr>
+      </p:sp>
+      <p:sp>
+        <p:nvSpPr>
+          <p:cNvPr id="11" name="ColTitle10"/>
+          <p:cNvSpPr/>
+          <p:nvPr/>
+        </p:nvSpPr>
+        <p:spPr>
+          <a:xfrm>
+            <a:off x="4776300" y="1110000"/>
+            <a:ext cx="3820500" cy="330000"/>
+          </a:xfrm>
+          <a:prstGeom prst="rect">
+            <a:avLst/>
+          </a:prstGeom>
+          <a:noFill/>
+          <a:ln/>
+        </p:spPr>
+        <p:txBody>
+          <a:bodyPr wrap="square" lIns="45720" tIns="45720" rIns="45720" bIns="45720" rtlCol="0" anchor="t"/>
+          <a:lstStyle/>
+          <a:p>
+            <a:pPr indent="0" marL="0">
+              <a:buNone/>
+            </a:pPr>
+            <a:r>
+              <a:rPr lang="pt-BR" sz="1500" b="1" dirty="0">
+                <a:solidFill>
+                  <a:srgbClr val="1D4ED8"/>
+                </a:solidFill>
+                <a:latin typeface="Calibri" pitchFamily="34" charset="0"/>
+              </a:rPr>
+              <a:t>🔒 Alçadas e Departamento</a:t>
+            </a:r>
+            <a:endParaRPr lang="pt-BR" sz="1500" dirty="0"/>
+          </a:p>
+        </p:txBody>
+      </p:sp>
+      <p:sp>
+        <p:nvSpPr>
+          <p:cNvPr id="12" name="Bullet12"/>
+          <p:cNvSpPr/>
+          <p:nvPr/>
+        </p:nvSpPr>
+        <p:spPr>
+          <a:xfrm>
+            <a:off x="4776300" y="1520000"/>
+            <a:ext cx="3820500" cy="420000"/>
+          </a:xfrm>
+          <a:prstGeom prst="rect">
+            <a:avLst/>
+          </a:prstGeom>
+          <a:noFill/>
+          <a:ln/>
+        </p:spPr>
+        <p:txBody>
+          <a:bodyPr wrap="square" lIns="45720" tIns="45720" rIns="45720" bIns="45720" rtlCol="0" anchor="t"/>
+          <a:lstStyle/>
+          <a:p>
+            <a:pPr indent="0" marL="0">
+              <a:buNone/>
+            </a:pPr>
+            <a:r>
+              <a:rPr lang="pt-BR" sz="1050" dirty="0">
+                <a:solidFill>
+                  <a:srgbClr val="1E293B"/>
+                </a:solidFill>
+                <a:latin typeface="Calibri" pitchFamily="34" charset="0"/>
+              </a:rPr>
+              <a:t>Alçada por valor: definida em Admin, por faixa e perfil aprovador.</a:t>
+            </a:r>
+            <a:endParaRPr lang="pt-BR" sz="1050" dirty="0"/>
+          </a:p>
+        </p:txBody>
+      </p:sp>
+      <p:sp>
+        <p:nvSpPr>
+          <p:cNvPr id="13" name="Bullet13"/>
+          <p:cNvSpPr/>
+          <p:nvPr/>
+        </p:nvSpPr>
+        <p:spPr>
+          <a:xfrm>
+            <a:off x="4776300" y="1980000"/>
+            <a:ext cx="3820500" cy="420000"/>
+          </a:xfrm>
+          <a:prstGeom prst="rect">
+            <a:avLst/>
+          </a:prstGeom>
+          <a:noFill/>
+          <a:ln/>
+        </p:spPr>
+        <p:txBody>
+          <a:bodyPr wrap="square" lIns="45720" tIns="45720" rIns="45720" bIns="45720" rtlCol="0" anchor="t"/>
+          <a:lstStyle/>
+          <a:p>
+            <a:pPr indent="0" marL="0">
+              <a:buNone/>
+            </a:pPr>
+            <a:r>
+              <a:rPr lang="pt-BR" sz="1050" dirty="0">
+                <a:solidFill>
+                  <a:srgbClr val="1E293B"/>
+                </a:solidFill>
+                <a:latin typeface="Calibri" pitchFamily="34" charset="0"/>
+              </a:rPr>
+              <a:t>🏢 Departamento: o gestor do departamento vinculado também precisa aprovar.</a:t>
+            </a:r>
+            <a:endParaRPr lang="pt-BR" sz="1050" dirty="0"/>
+          </a:p>
+        </p:txBody>
+      </p:sp>
+      <p:sp>
+        <p:nvSpPr>
+          <p:cNvPr id="14" name="Bullet14"/>
+          <p:cNvSpPr/>
+          <p:nvPr/>
+        </p:nvSpPr>
+        <p:spPr>
+          <a:xfrm>
+            <a:off x="4776300" y="2440000"/>
+            <a:ext cx="3820500" cy="420000"/>
+          </a:xfrm>
+          <a:prstGeom prst="rect">
+            <a:avLst/>
+          </a:prstGeom>
+          <a:noFill/>
+          <a:ln/>
+        </p:spPr>
+        <p:txBody>
+          <a:bodyPr wrap="square" lIns="45720" tIns="45720" rIns="45720" bIns="45720" rtlCol="0" anchor="t"/>
+          <a:lstStyle/>
+          <a:p>
+            <a:pPr indent="0" marL="0">
+              <a:buNone/>
+            </a:pPr>
+            <a:r>
+              <a:rPr lang="pt-BR" sz="1050" dirty="0">
+                <a:solidFill>
+                  <a:srgbClr val="1E293B"/>
+                </a:solidFill>
+                <a:latin typeface="Calibri" pitchFamily="34" charset="0"/>
+              </a:rPr>
+              <a:t>Enquanto pendente, o pedido fica em Aguardando Aprovação.</a:t>
+            </a:r>
+            <a:endParaRPr lang="pt-BR" sz="1050" dirty="0"/>
+          </a:p>
+        </p:txBody>
+      </p:sp>
+      <p:sp>
+        <p:nvSpPr>
+          <p:cNvPr id="15" name="Bullet15"/>
+          <p:cNvSpPr/>
+          <p:nvPr/>
+        </p:nvSpPr>
+        <p:spPr>
+          <a:xfrm>
+            <a:off x="4776300" y="2900000"/>
+            <a:ext cx="3820500" cy="420000"/>
+          </a:xfrm>
+          <a:prstGeom prst="rect">
+            <a:avLst/>
+          </a:prstGeom>
+          <a:noFill/>
+          <a:ln/>
+        </p:spPr>
+        <p:txBody>
+          <a:bodyPr wrap="square" lIns="45720" tIns="45720" rIns="45720" bIns="45720" rtlCol="0" anchor="t"/>
+          <a:lstStyle/>
+          <a:p>
+            <a:pPr indent="0" marL="0">
+              <a:buNone/>
+            </a:pPr>
+            <a:r>
+              <a:rPr lang="pt-BR" sz="1050" dirty="0">
+                <a:solidFill>
+                  <a:srgbClr val="1E293B"/>
+                </a:solidFill>
+                <a:latin typeface="Calibri" pitchFamily="34" charset="0"/>
+              </a:rPr>
+              <a:t>A Ordem de Compra (OC) é gerada automaticamente ao fechar.</a:t>
+            </a:r>
+            <a:endParaRPr lang="pt-BR" sz="1050" dirty="0"/>
+          </a:p>
+        </p:txBody>
+      </p:sp>
+    </p:spTree>
+  </p:cSld>
+  <p:clrMapOvr>
+    <a:masterClrMapping/>
+  </p:clrMapOvr>
+</p:sld>
+</file>
+
+<file path=ppt/slides/slide43.xml><?xml version="1.0" encoding="utf-8"?>
+<p:sld xmlns:a="http://schemas.openxmlformats.org/drawingml/2006/main" xmlns:r="http://schemas.openxmlformats.org/officeDocument/2006/relationships" xmlns:p="http://schemas.openxmlformats.org/presentationml/2006/main">
+  <p:cSld name="Slide 43">
+    <p:spTree>
+      <p:nvGrpSpPr>
+        <p:cNvPr id="1" name=""/>
+        <p:cNvGrpSpPr/>
+        <p:nvPr/>
+      </p:nvGrpSpPr>
+      <p:grpSpPr>
+        <a:xfrm>
+          <a:off x="0" y="0"/>
+          <a:ext cx="0" cy="0"/>
+          <a:chOff x="0" y="0"/>
+          <a:chExt cx="0" cy="0"/>
+        </a:xfrm>
+      </p:grpSpPr>
+      <p:sp>
+        <p:nvSpPr>
+          <p:cNvPr id="2" name="BG"/>
+          <p:cNvSpPr/>
+          <p:nvPr/>
+        </p:nvSpPr>
+        <p:spPr>
+          <a:xfrm>
+            <a:off x="0" y="0"/>
+            <a:ext cx="9144000" cy="5143500"/>
+          </a:xfrm>
+          <a:prstGeom prst="rect">
+            <a:avLst/>
+          </a:prstGeom>
+          <a:solidFill>
+            <a:srgbClr val="FFFFFF"/>
+          </a:solidFill>
+          <a:ln w="12700">
+            <a:solidFill>
+              <a:srgbClr val="FFFFFF"/>
+            </a:solidFill>
+            <a:prstDash val="solid"/>
+          </a:ln>
+        </p:spPr>
+      </p:sp>
+      <p:sp>
+        <p:nvSpPr>
+          <p:cNvPr id="3" name="ModLabel"/>
+          <p:cNvSpPr/>
+          <p:nvPr/>
+        </p:nvSpPr>
+        <p:spPr>
+          <a:xfrm>
+            <a:off x="457200" y="182880"/>
+            <a:ext cx="7315200" cy="201168"/>
+          </a:xfrm>
+          <a:prstGeom prst="rect">
+            <a:avLst/>
+          </a:prstGeom>
+          <a:noFill/>
+          <a:ln/>
+        </p:spPr>
+        <p:txBody>
+          <a:bodyPr wrap="square" lIns="45720" tIns="45720" rIns="45720" bIns="45720" rtlCol="0" anchor="t"/>
+          <a:lstStyle/>
+          <a:p>
+            <a:pPr indent="0" marL="0">
+              <a:buNone/>
+            </a:pPr>
+            <a:r>
+              <a:rPr lang="pt-BR" sz="950" b="1" dirty="0">
+                <a:solidFill>
+                  <a:srgbClr val="94A3B8"/>
+                </a:solidFill>
+                <a:latin typeface="Calibri" pitchFamily="34" charset="0"/>
+              </a:rPr>
+              <a:t>MÓDULO COMPRAS</a:t>
+            </a:r>
+            <a:endParaRPr lang="pt-BR" sz="950" dirty="0"/>
+          </a:p>
+        </p:txBody>
+      </p:sp>
+      <p:sp>
+        <p:nvSpPr>
+          <p:cNvPr id="4" name="Title"/>
+          <p:cNvSpPr/>
+          <p:nvPr/>
+        </p:nvSpPr>
+        <p:spPr>
+          <a:xfrm>
+            <a:off x="457200" y="384048"/>
+            <a:ext cx="8229600" cy="480000"/>
+          </a:xfrm>
+          <a:prstGeom prst="rect">
+            <a:avLst/>
+          </a:prstGeom>
+          <a:noFill/>
+          <a:ln/>
+        </p:spPr>
+        <p:txBody>
+          <a:bodyPr wrap="square" lIns="45720" tIns="45720" rIns="45720" bIns="45720" rtlCol="0" anchor="ctr"/>
+          <a:lstStyle/>
+          <a:p>
+            <a:pPr indent="0" marL="0">
+              <a:buNone/>
+            </a:pPr>
+            <a:r>
+              <a:rPr lang="pt-BR" sz="2600" b="1" dirty="0">
+                <a:solidFill>
+                  <a:srgbClr val="166534"/>
+                </a:solidFill>
+                <a:latin typeface="Calibri" pitchFamily="34" charset="0"/>
+              </a:rPr>
+              <a:t>Compras — Conferência Técnica e Faturamento</a:t>
+            </a:r>
+            <a:endParaRPr lang="pt-BR" sz="2600" dirty="0"/>
+          </a:p>
+        </p:txBody>
+      </p:sp>
+      <p:sp>
+        <p:nvSpPr>
+          <p:cNvPr id="5" name="ColBG5"/>
+          <p:cNvSpPr/>
+          <p:nvPr/>
+        </p:nvSpPr>
+        <p:spPr>
+          <a:xfrm>
+            <a:off x="457200" y="1000000"/>
+            <a:ext cx="4000500" cy="4023500"/>
+          </a:xfrm>
+          <a:prstGeom prst="roundRect">
+            <a:avLst>
+              <a:gd name="adj" fmla="val 4082"/>
+            </a:avLst>
+          </a:prstGeom>
+          <a:solidFill>
+            <a:srgbClr val="F0FDF4"/>
+          </a:solidFill>
+          <a:ln w="12700">
+            <a:solidFill>
+              <a:srgbClr val="F0FDF4"/>
+            </a:solidFill>
+            <a:prstDash val="solid"/>
+          </a:ln>
+        </p:spPr>
+      </p:sp>
+      <p:sp>
+        <p:nvSpPr>
+          <p:cNvPr id="6" name="ColTitle5"/>
+          <p:cNvSpPr/>
+          <p:nvPr/>
+        </p:nvSpPr>
+        <p:spPr>
+          <a:xfrm>
+            <a:off x="547200" y="1110000"/>
+            <a:ext cx="3820500" cy="330000"/>
+          </a:xfrm>
+          <a:prstGeom prst="rect">
+            <a:avLst/>
+          </a:prstGeom>
+          <a:noFill/>
+          <a:ln/>
+        </p:spPr>
+        <p:txBody>
+          <a:bodyPr wrap="square" lIns="45720" tIns="45720" rIns="45720" bIns="45720" rtlCol="0" anchor="t"/>
+          <a:lstStyle/>
+          <a:p>
+            <a:pPr indent="0" marL="0">
+              <a:buNone/>
+            </a:pPr>
+            <a:r>
+              <a:rPr lang="pt-BR" sz="1500" b="1" dirty="0">
+                <a:solidFill>
+                  <a:srgbClr val="166534"/>
+                </a:solidFill>
+                <a:latin typeface="Calibri" pitchFamily="34" charset="0"/>
+              </a:rPr>
+              <a:t>📦 Conferência Técnica</a:t>
+            </a:r>
+            <a:endParaRPr lang="pt-BR" sz="1500" dirty="0"/>
+          </a:p>
+        </p:txBody>
+      </p:sp>
+      <p:sp>
+        <p:nvSpPr>
+          <p:cNvPr id="7" name="Bullet7"/>
+          <p:cNvSpPr/>
+          <p:nvPr/>
+        </p:nvSpPr>
+        <p:spPr>
+          <a:xfrm>
+            <a:off x="547200" y="1520000"/>
+            <a:ext cx="3820500" cy="420000"/>
+          </a:xfrm>
+          <a:prstGeom prst="rect">
+            <a:avLst/>
+          </a:prstGeom>
+          <a:noFill/>
+          <a:ln/>
+        </p:spPr>
+        <p:txBody>
+          <a:bodyPr wrap="square" lIns="45720" tIns="45720" rIns="45720" bIns="45720" rtlCol="0" anchor="t"/>
+          <a:lstStyle/>
+          <a:p>
+            <a:pPr indent="0" marL="0">
+              <a:buNone/>
+            </a:pPr>
+            <a:r>
+              <a:rPr lang="pt-BR" sz="1050" dirty="0">
+                <a:solidFill>
+                  <a:srgbClr val="1E293B"/>
+                </a:solidFill>
+                <a:latin typeface="Calibri" pitchFamily="34" charset="0"/>
+              </a:rPr>
+              <a:t>Depois de Comprado, o material segue pra conferência na Logística.</a:t>
+            </a:r>
+            <a:endParaRPr lang="pt-BR" sz="1050" dirty="0"/>
+          </a:p>
+        </p:txBody>
+      </p:sp>
+      <p:sp>
+        <p:nvSpPr>
+          <p:cNvPr id="8" name="Bullet8"/>
+          <p:cNvSpPr/>
+          <p:nvPr/>
+        </p:nvSpPr>
+        <p:spPr>
+          <a:xfrm>
+            <a:off x="547200" y="1980000"/>
+            <a:ext cx="3820500" cy="420000"/>
+          </a:xfrm>
+          <a:prstGeom prst="rect">
+            <a:avLst/>
+          </a:prstGeom>
+          <a:noFill/>
+          <a:ln/>
+        </p:spPr>
+        <p:txBody>
+          <a:bodyPr wrap="square" lIns="45720" tIns="45720" rIns="45720" bIns="45720" rtlCol="0" anchor="t"/>
+          <a:lstStyle/>
+          <a:p>
+            <a:pPr indent="0" marL="0">
+              <a:buNone/>
+            </a:pPr>
+            <a:r>
+              <a:rPr lang="pt-BR" sz="1050" dirty="0">
+                <a:solidFill>
+                  <a:srgbClr val="1E293B"/>
+                </a:solidFill>
+                <a:latin typeface="Calibri" pitchFamily="34" charset="0"/>
+              </a:rPr>
+              <a:t>Logística confere seriais, volume e a NF do fornecedor.</a:t>
+            </a:r>
+            <a:endParaRPr lang="pt-BR" sz="1050" dirty="0"/>
+          </a:p>
+        </p:txBody>
+      </p:sp>
+      <p:sp>
+        <p:nvSpPr>
+          <p:cNvPr id="9" name="Bullet9"/>
+          <p:cNvSpPr/>
+          <p:nvPr/>
+        </p:nvSpPr>
+        <p:spPr>
+          <a:xfrm>
+            <a:off x="547200" y="2440000"/>
+            <a:ext cx="3820500" cy="420000"/>
+          </a:xfrm>
+          <a:prstGeom prst="rect">
+            <a:avLst/>
+          </a:prstGeom>
+          <a:noFill/>
+          <a:ln/>
+        </p:spPr>
+        <p:txBody>
+          <a:bodyPr wrap="square" lIns="45720" tIns="45720" rIns="45720" bIns="45720" rtlCol="0" anchor="t"/>
+          <a:lstStyle/>
+          <a:p>
+            <a:pPr indent="0" marL="0">
+              <a:buNone/>
+            </a:pPr>
+            <a:r>
+              <a:rPr lang="pt-BR" sz="1050" dirty="0">
+                <a:solidFill>
+                  <a:srgbClr val="1E293B"/>
+                </a:solidFill>
+                <a:latin typeface="Calibri" pitchFamily="34" charset="0"/>
+              </a:rPr>
+              <a:t>Só aí a compra vira Concluído e libera o pagamento.</a:t>
+            </a:r>
+            <a:endParaRPr lang="pt-BR" sz="1050" dirty="0"/>
+          </a:p>
+        </p:txBody>
+      </p:sp>
+      <p:sp>
+        <p:nvSpPr>
+          <p:cNvPr id="10" name="ColBG10"/>
+          <p:cNvSpPr/>
+          <p:nvPr/>
+        </p:nvSpPr>
+        <p:spPr>
+          <a:xfrm>
+            <a:off x="4686300" y="1000000"/>
+            <a:ext cx="4000500" cy="4023500"/>
+          </a:xfrm>
+          <a:prstGeom prst="roundRect">
+            <a:avLst>
+              <a:gd name="adj" fmla="val 4082"/>
+            </a:avLst>
+          </a:prstGeom>
+          <a:solidFill>
+            <a:srgbClr val="EFF6FF"/>
+          </a:solidFill>
+          <a:ln w="12700">
+            <a:solidFill>
+              <a:srgbClr val="EFF6FF"/>
+            </a:solidFill>
+            <a:prstDash val="solid"/>
+          </a:ln>
+        </p:spPr>
+      </p:sp>
+      <p:sp>
+        <p:nvSpPr>
+          <p:cNvPr id="11" name="ColTitle10"/>
+          <p:cNvSpPr/>
+          <p:nvPr/>
+        </p:nvSpPr>
+        <p:spPr>
+          <a:xfrm>
+            <a:off x="4776300" y="1110000"/>
+            <a:ext cx="3820500" cy="330000"/>
+          </a:xfrm>
+          <a:prstGeom prst="rect">
+            <a:avLst/>
+          </a:prstGeom>
+          <a:noFill/>
+          <a:ln/>
+        </p:spPr>
+        <p:txBody>
+          <a:bodyPr wrap="square" lIns="45720" tIns="45720" rIns="45720" bIns="45720" rtlCol="0" anchor="t"/>
+          <a:lstStyle/>
+          <a:p>
+            <a:pPr indent="0" marL="0">
+              <a:buNone/>
+            </a:pPr>
+            <a:r>
+              <a:rPr lang="pt-BR" sz="1500" b="1" dirty="0">
+                <a:solidFill>
+                  <a:srgbClr val="1D4ED8"/>
+                </a:solidFill>
+                <a:latin typeface="Calibri" pitchFamily="34" charset="0"/>
+              </a:rPr>
+              <a:t>💰 Faturamento (aba Financeiro)</a:t>
+            </a:r>
+            <a:endParaRPr lang="pt-BR" sz="1500" dirty="0"/>
+          </a:p>
+        </p:txBody>
+      </p:sp>
+      <p:sp>
+        <p:nvSpPr>
+          <p:cNvPr id="12" name="Bullet12"/>
+          <p:cNvSpPr/>
+          <p:nvPr/>
+        </p:nvSpPr>
+        <p:spPr>
+          <a:xfrm>
+            <a:off x="4776300" y="1520000"/>
+            <a:ext cx="3820500" cy="420000"/>
+          </a:xfrm>
+          <a:prstGeom prst="rect">
+            <a:avLst/>
+          </a:prstGeom>
+          <a:noFill/>
+          <a:ln/>
+        </p:spPr>
+        <p:txBody>
+          <a:bodyPr wrap="square" lIns="45720" tIns="45720" rIns="45720" bIns="45720" rtlCol="0" anchor="t"/>
+          <a:lstStyle/>
+          <a:p>
+            <a:pPr indent="0" marL="0">
+              <a:buNone/>
+            </a:pPr>
+            <a:r>
+              <a:rPr lang="pt-BR" sz="1050" dirty="0">
+                <a:solidFill>
+                  <a:srgbClr val="1E293B"/>
+                </a:solidFill>
+                <a:latin typeface="Calibri" pitchFamily="34" charset="0"/>
+              </a:rPr>
+              <a:t>Painel 📑 Faturamento de Compras lista as compras aguardando pagamento.</a:t>
+            </a:r>
+            <a:endParaRPr lang="pt-BR" sz="1050" dirty="0"/>
+          </a:p>
+        </p:txBody>
+      </p:sp>
+      <p:sp>
+        <p:nvSpPr>
+          <p:cNvPr id="13" name="Bullet13"/>
+          <p:cNvSpPr/>
+          <p:nvPr/>
+        </p:nvSpPr>
+        <p:spPr>
+          <a:xfrm>
+            <a:off x="4776300" y="1980000"/>
+            <a:ext cx="3820500" cy="420000"/>
+          </a:xfrm>
+          <a:prstGeom prst="rect">
+            <a:avLst/>
+          </a:prstGeom>
+          <a:noFill/>
+          <a:ln/>
+        </p:spPr>
+        <p:txBody>
+          <a:bodyPr wrap="square" lIns="45720" tIns="45720" rIns="45720" bIns="45720" rtlCol="0" anchor="t"/>
+          <a:lstStyle/>
+          <a:p>
+            <a:pPr indent="0" marL="0">
+              <a:buNone/>
+            </a:pPr>
+            <a:r>
+              <a:rPr lang="pt-BR" sz="1050" dirty="0">
+                <a:solidFill>
+                  <a:srgbClr val="1E293B"/>
+                </a:solidFill>
+                <a:latin typeface="Calibri" pitchFamily="34" charset="0"/>
+              </a:rPr>
+              <a:t>Informe o Nº NF do fornecedor e anexe o arquivo.</a:t>
+            </a:r>
+            <a:endParaRPr lang="pt-BR" sz="1050" dirty="0"/>
+          </a:p>
+        </p:txBody>
+      </p:sp>
+      <p:sp>
+        <p:nvSpPr>
+          <p:cNvPr id="14" name="Bullet14"/>
+          <p:cNvSpPr/>
+          <p:nvPr/>
+        </p:nvSpPr>
+        <p:spPr>
+          <a:xfrm>
+            <a:off x="4776300" y="2440000"/>
+            <a:ext cx="3820500" cy="420000"/>
+          </a:xfrm>
+          <a:prstGeom prst="rect">
+            <a:avLst/>
+          </a:prstGeom>
+          <a:noFill/>
+          <a:ln/>
+        </p:spPr>
+        <p:txBody>
+          <a:bodyPr wrap="square" lIns="45720" tIns="45720" rIns="45720" bIns="45720" rtlCol="0" anchor="t"/>
+          <a:lstStyle/>
+          <a:p>
+            <a:pPr indent="0" marL="0">
+              <a:buNone/>
+            </a:pPr>
+            <a:r>
+              <a:rPr lang="pt-BR" sz="1050" dirty="0">
+                <a:solidFill>
+                  <a:srgbClr val="1E293B"/>
+                </a:solidFill>
+                <a:latin typeface="Calibri" pitchFamily="34" charset="0"/>
+              </a:rPr>
+              <a:t>Clique em 💰 Pago pra concluir o ciclo.</a:t>
+            </a:r>
+            <a:endParaRPr lang="pt-BR" sz="1050" dirty="0"/>
+          </a:p>
+        </p:txBody>
+      </p:sp>
+      <p:sp>
+        <p:nvSpPr>
+          <p:cNvPr id="15" name="Bullet15"/>
+          <p:cNvSpPr/>
+          <p:nvPr/>
+        </p:nvSpPr>
+        <p:spPr>
+          <a:xfrm>
+            <a:off x="4776300" y="2900000"/>
+            <a:ext cx="3820500" cy="420000"/>
+          </a:xfrm>
+          <a:prstGeom prst="rect">
+            <a:avLst/>
+          </a:prstGeom>
+          <a:noFill/>
+          <a:ln/>
+        </p:spPr>
+        <p:txBody>
+          <a:bodyPr wrap="square" lIns="45720" tIns="45720" rIns="45720" bIns="45720" rtlCol="0" anchor="t"/>
+          <a:lstStyle/>
+          <a:p>
+            <a:pPr indent="0" marL="0">
+              <a:buNone/>
+            </a:pPr>
+            <a:r>
+              <a:rPr lang="pt-BR" sz="1050" dirty="0">
+                <a:solidFill>
+                  <a:srgbClr val="1E293B"/>
+                </a:solidFill>
+                <a:latin typeface="Calibri" pitchFamily="34" charset="0"/>
+              </a:rPr>
+              <a:t>Status: 🔒 Aguardando recebimento → 🔓 Liberado → ✅ Pago.</a:t>
+            </a:r>
+            <a:endParaRPr lang="pt-BR" sz="1050" dirty="0"/>
+          </a:p>
+        </p:txBody>
+      </p:sp>
+    </p:spTree>
+  </p:cSld>
+  <p:clrMapOvr>
+    <a:masterClrMapping/>
+  </p:clrMapOvr>
+</p:sld>
+</file>
+
+<file path=ppt/slides/slide44.xml><?xml version="1.0" encoding="utf-8"?>
+<p:sld xmlns:a="http://schemas.openxmlformats.org/drawingml/2006/main" xmlns:r="http://schemas.openxmlformats.org/officeDocument/2006/relationships" xmlns:p="http://schemas.openxmlformats.org/presentationml/2006/main">
+  <p:cSld name="Slide 44">
+    <p:spTree>
+      <p:nvGrpSpPr>
+        <p:cNvPr id="1" name=""/>
+        <p:cNvGrpSpPr/>
+        <p:nvPr/>
+      </p:nvGrpSpPr>
+      <p:grpSpPr>
+        <a:xfrm>
+          <a:off x="0" y="0"/>
+          <a:ext cx="0" cy="0"/>
+          <a:chOff x="0" y="0"/>
+          <a:chExt cx="0" cy="0"/>
+        </a:xfrm>
+      </p:grpSpPr>
+      <p:sp>
+        <p:nvSpPr>
+          <p:cNvPr id="2" name="BG"/>
+          <p:cNvSpPr/>
+          <p:nvPr/>
+        </p:nvSpPr>
+        <p:spPr>
+          <a:xfrm>
+            <a:off x="0" y="0"/>
+            <a:ext cx="9144000" cy="5143500"/>
+          </a:xfrm>
+          <a:prstGeom prst="rect">
+            <a:avLst/>
+          </a:prstGeom>
+          <a:solidFill>
+            <a:srgbClr val="FFFFFF"/>
+          </a:solidFill>
+          <a:ln w="12700">
+            <a:solidFill>
+              <a:srgbClr val="FFFFFF"/>
+            </a:solidFill>
+            <a:prstDash val="solid"/>
+          </a:ln>
+        </p:spPr>
+      </p:sp>
+      <p:sp>
+        <p:nvSpPr>
+          <p:cNvPr id="3" name="ModLabel"/>
+          <p:cNvSpPr/>
+          <p:nvPr/>
+        </p:nvSpPr>
+        <p:spPr>
+          <a:xfrm>
+            <a:off x="457200" y="182880"/>
+            <a:ext cx="7315200" cy="201168"/>
+          </a:xfrm>
+          <a:prstGeom prst="rect">
+            <a:avLst/>
+          </a:prstGeom>
+          <a:noFill/>
+          <a:ln/>
+        </p:spPr>
+        <p:txBody>
+          <a:bodyPr wrap="square" lIns="45720" tIns="45720" rIns="45720" bIns="45720" rtlCol="0" anchor="t"/>
+          <a:lstStyle/>
+          <a:p>
+            <a:pPr indent="0" marL="0">
+              <a:buNone/>
+            </a:pPr>
+            <a:r>
+              <a:rPr lang="pt-BR" sz="950" b="1" dirty="0">
+                <a:solidFill>
+                  <a:srgbClr val="94A3B8"/>
+                </a:solidFill>
+                <a:latin typeface="Calibri" pitchFamily="34" charset="0"/>
+              </a:rPr>
+              <a:t>MÓDULO LOGÍSTICA</a:t>
+            </a:r>
+            <a:endParaRPr lang="pt-BR" sz="950" dirty="0"/>
+          </a:p>
+        </p:txBody>
+      </p:sp>
+      <p:sp>
+        <p:nvSpPr>
+          <p:cNvPr id="4" name="Title"/>
+          <p:cNvSpPr/>
+          <p:nvPr/>
+        </p:nvSpPr>
+        <p:spPr>
+          <a:xfrm>
+            <a:off x="457200" y="384048"/>
+            <a:ext cx="8229600" cy="480000"/>
+          </a:xfrm>
+          <a:prstGeom prst="rect">
+            <a:avLst/>
+          </a:prstGeom>
+          <a:noFill/>
+          <a:ln/>
+        </p:spPr>
+        <p:txBody>
+          <a:bodyPr wrap="square" lIns="45720" tIns="45720" rIns="45720" bIns="45720" rtlCol="0" anchor="ctr"/>
+          <a:lstStyle/>
+          <a:p>
+            <a:pPr indent="0" marL="0">
+              <a:buNone/>
+            </a:pPr>
+            <a:r>
+              <a:rPr lang="pt-BR" sz="2600" b="1" dirty="0">
+                <a:solidFill>
+                  <a:srgbClr val="166534"/>
+                </a:solidFill>
+                <a:latin typeface="Calibri" pitchFamily="34" charset="0"/>
+              </a:rPr>
+              <a:t>Logística — Fretes</a:t>
+            </a:r>
+            <a:endParaRPr lang="pt-BR" sz="2600" dirty="0"/>
+          </a:p>
+        </p:txBody>
+      </p:sp>
+      <p:sp>
+        <p:nvSpPr>
+          <p:cNvPr id="5" name="ColBG5"/>
+          <p:cNvSpPr/>
+          <p:nvPr/>
+        </p:nvSpPr>
+        <p:spPr>
+          <a:xfrm>
+            <a:off x="457200" y="1000000"/>
+            <a:ext cx="4000500" cy="4023500"/>
+          </a:xfrm>
+          <a:prstGeom prst="roundRect">
+            <a:avLst>
+              <a:gd name="adj" fmla="val 4082"/>
+            </a:avLst>
+          </a:prstGeom>
+          <a:solidFill>
+            <a:srgbClr val="F0FDF4"/>
+          </a:solidFill>
+          <a:ln w="12700">
+            <a:solidFill>
+              <a:srgbClr val="F0FDF4"/>
+            </a:solidFill>
+            <a:prstDash val="solid"/>
+          </a:ln>
+        </p:spPr>
+      </p:sp>
+      <p:sp>
+        <p:nvSpPr>
+          <p:cNvPr id="6" name="ColTitle5"/>
+          <p:cNvSpPr/>
+          <p:nvPr/>
+        </p:nvSpPr>
+        <p:spPr>
+          <a:xfrm>
+            <a:off x="547200" y="1110000"/>
+            <a:ext cx="3820500" cy="330000"/>
+          </a:xfrm>
+          <a:prstGeom prst="rect">
+            <a:avLst/>
+          </a:prstGeom>
+          <a:noFill/>
+          <a:ln/>
+        </p:spPr>
+        <p:txBody>
+          <a:bodyPr wrap="square" lIns="45720" tIns="45720" rIns="45720" bIns="45720" rtlCol="0" anchor="t"/>
+          <a:lstStyle/>
+          <a:p>
+            <a:pPr indent="0" marL="0">
+              <a:buNone/>
+            </a:pPr>
+            <a:r>
+              <a:rPr lang="pt-BR" sz="1500" b="1" dirty="0">
+                <a:solidFill>
+                  <a:srgbClr val="166534"/>
+                </a:solidFill>
+                <a:latin typeface="Calibri" pitchFamily="34" charset="0"/>
+              </a:rPr>
+              <a:t>🚚 Cotação de Transportadoras</a:t>
+            </a:r>
+            <a:endParaRPr lang="pt-BR" sz="1500" dirty="0"/>
+          </a:p>
+        </p:txBody>
+      </p:sp>
+      <p:sp>
+        <p:nvSpPr>
+          <p:cNvPr id="7" name="Bullet7"/>
+          <p:cNvSpPr/>
+          <p:nvPr/>
+        </p:nvSpPr>
+        <p:spPr>
+          <a:xfrm>
+            <a:off x="547200" y="1520000"/>
+            <a:ext cx="3820500" cy="420000"/>
+          </a:xfrm>
+          <a:prstGeom prst="rect">
+            <a:avLst/>
+          </a:prstGeom>
+          <a:noFill/>
+          <a:ln/>
+        </p:spPr>
+        <p:txBody>
+          <a:bodyPr wrap="square" lIns="45720" tIns="45720" rIns="45720" bIns="45720" rtlCol="0" anchor="t"/>
+          <a:lstStyle/>
+          <a:p>
+            <a:pPr indent="0" marL="0">
+              <a:buNone/>
+            </a:pPr>
+            <a:r>
+              <a:rPr lang="pt-BR" sz="1050" dirty="0">
+                <a:solidFill>
+                  <a:srgbClr val="1E293B"/>
+                </a:solidFill>
+                <a:latin typeface="Calibri" pitchFamily="34" charset="0"/>
+              </a:rPr>
+              <a:t>Sub-aba 🚚 Fretes, pra materiais chegando (📥) ou saindo (📤) da ACN.</a:t>
+            </a:r>
+            <a:endParaRPr lang="pt-BR" sz="1050" dirty="0"/>
+          </a:p>
+        </p:txBody>
+      </p:sp>
+      <p:sp>
+        <p:nvSpPr>
+          <p:cNvPr id="8" name="Bullet8"/>
+          <p:cNvSpPr/>
+          <p:nvPr/>
+        </p:nvSpPr>
+        <p:spPr>
+          <a:xfrm>
+            <a:off x="547200" y="1980000"/>
+            <a:ext cx="3820500" cy="420000"/>
+          </a:xfrm>
+          <a:prstGeom prst="rect">
+            <a:avLst/>
+          </a:prstGeom>
+          <a:noFill/>
+          <a:ln/>
+        </p:spPr>
+        <p:txBody>
+          <a:bodyPr wrap="square" lIns="45720" tIns="45720" rIns="45720" bIns="45720" rtlCol="0" anchor="t"/>
+          <a:lstStyle/>
+          <a:p>
+            <a:pPr indent="0" marL="0">
+              <a:buNone/>
+            </a:pPr>
+            <a:r>
+              <a:rPr lang="pt-BR" sz="1050" dirty="0">
+                <a:solidFill>
+                  <a:srgbClr val="1E293B"/>
+                </a:solidFill>
+                <a:latin typeface="Calibri" pitchFamily="34" charset="0"/>
+              </a:rPr>
+              <a:t>Mesmo padrão de Compras: mínimo de 3 cotações.</a:t>
+            </a:r>
+            <a:endParaRPr lang="pt-BR" sz="1050" dirty="0"/>
+          </a:p>
+        </p:txBody>
+      </p:sp>
+      <p:sp>
+        <p:nvSpPr>
+          <p:cNvPr id="9" name="Bullet9"/>
+          <p:cNvSpPr/>
+          <p:nvPr/>
+        </p:nvSpPr>
+        <p:spPr>
+          <a:xfrm>
+            <a:off x="547200" y="2440000"/>
+            <a:ext cx="3820500" cy="420000"/>
+          </a:xfrm>
+          <a:prstGeom prst="rect">
+            <a:avLst/>
+          </a:prstGeom>
+          <a:noFill/>
+          <a:ln/>
+        </p:spPr>
+        <p:txBody>
+          <a:bodyPr wrap="square" lIns="45720" tIns="45720" rIns="45720" bIns="45720" rtlCol="0" anchor="t"/>
+          <a:lstStyle/>
+          <a:p>
+            <a:pPr indent="0" marL="0">
+              <a:buNone/>
+            </a:pPr>
+            <a:r>
+              <a:rPr lang="pt-BR" sz="1050" dirty="0">
+                <a:solidFill>
+                  <a:srgbClr val="1E293B"/>
+                </a:solidFill>
+                <a:latin typeface="Calibri" pitchFamily="34" charset="0"/>
+              </a:rPr>
+              <a:t>Escolha a vencedora, justifique e confirme — o frete vai pra Em Trânsito.</a:t>
+            </a:r>
+            <a:endParaRPr lang="pt-BR" sz="1050" dirty="0"/>
+          </a:p>
+        </p:txBody>
+      </p:sp>
+      <p:sp>
+        <p:nvSpPr>
+          <p:cNvPr id="10" name="ColBG10"/>
+          <p:cNvSpPr/>
+          <p:nvPr/>
+        </p:nvSpPr>
+        <p:spPr>
+          <a:xfrm>
+            <a:off x="4686300" y="1000000"/>
+            <a:ext cx="4000500" cy="4023500"/>
+          </a:xfrm>
+          <a:prstGeom prst="roundRect">
+            <a:avLst>
+              <a:gd name="adj" fmla="val 4082"/>
+            </a:avLst>
+          </a:prstGeom>
+          <a:solidFill>
+            <a:srgbClr val="EFF6FF"/>
+          </a:solidFill>
+          <a:ln w="12700">
+            <a:solidFill>
+              <a:srgbClr val="EFF6FF"/>
+            </a:solidFill>
+            <a:prstDash val="solid"/>
+          </a:ln>
+        </p:spPr>
+      </p:sp>
+      <p:sp>
+        <p:nvSpPr>
+          <p:cNvPr id="11" name="ColTitle10"/>
+          <p:cNvSpPr/>
+          <p:nvPr/>
+        </p:nvSpPr>
+        <p:spPr>
+          <a:xfrm>
+            <a:off x="4776300" y="1110000"/>
+            <a:ext cx="3820500" cy="330000"/>
+          </a:xfrm>
+          <a:prstGeom prst="rect">
+            <a:avLst/>
+          </a:prstGeom>
+          <a:noFill/>
+          <a:ln/>
+        </p:spPr>
+        <p:txBody>
+          <a:bodyPr wrap="square" lIns="45720" tIns="45720" rIns="45720" bIns="45720" rtlCol="0" anchor="t"/>
+          <a:lstStyle/>
+          <a:p>
+            <a:pPr indent="0" marL="0">
+              <a:buNone/>
+            </a:pPr>
+            <a:r>
+              <a:rPr lang="pt-BR" sz="1500" b="1" dirty="0">
+                <a:solidFill>
+                  <a:srgbClr val="1D4ED8"/>
+                </a:solidFill>
+                <a:latin typeface="Calibri" pitchFamily="34" charset="0"/>
+              </a:rPr>
+              <a:t>📎 Entrega e Cancelamento</a:t>
+            </a:r>
+            <a:endParaRPr lang="pt-BR" sz="1500" dirty="0"/>
+          </a:p>
+        </p:txBody>
+      </p:sp>
+      <p:sp>
+        <p:nvSpPr>
+          <p:cNvPr id="12" name="Bullet12"/>
+          <p:cNvSpPr/>
+          <p:nvPr/>
+        </p:nvSpPr>
+        <p:spPr>
+          <a:xfrm>
+            <a:off x="4776300" y="1520000"/>
+            <a:ext cx="3820500" cy="420000"/>
+          </a:xfrm>
+          <a:prstGeom prst="rect">
+            <a:avLst/>
+          </a:prstGeom>
+          <a:noFill/>
+          <a:ln/>
+        </p:spPr>
+        <p:txBody>
+          <a:bodyPr wrap="square" lIns="45720" tIns="45720" rIns="45720" bIns="45720" rtlCol="0" anchor="t"/>
+          <a:lstStyle/>
+          <a:p>
+            <a:pPr indent="0" marL="0">
+              <a:buNone/>
+            </a:pPr>
+            <a:r>
+              <a:rPr lang="pt-BR" sz="1050" dirty="0">
+                <a:solidFill>
+                  <a:srgbClr val="1E293B"/>
+                </a:solidFill>
+                <a:latin typeface="Calibri" pitchFamily="34" charset="0"/>
+              </a:rPr>
+              <a:t>Canhoto (comprovante de entrega) é obrigatório pra marcar como Entregue.</a:t>
+            </a:r>
+            <a:endParaRPr lang="pt-BR" sz="1050" dirty="0"/>
+          </a:p>
+        </p:txBody>
+      </p:sp>
+      <p:sp>
+        <p:nvSpPr>
+          <p:cNvPr id="13" name="Bullet13"/>
+          <p:cNvSpPr/>
+          <p:nvPr/>
+        </p:nvSpPr>
+        <p:spPr>
+          <a:xfrm>
+            <a:off x="4776300" y="1980000"/>
+            <a:ext cx="3820500" cy="420000"/>
+          </a:xfrm>
+          <a:prstGeom prst="rect">
+            <a:avLst/>
+          </a:prstGeom>
+          <a:noFill/>
+          <a:ln/>
+        </p:spPr>
+        <p:txBody>
+          <a:bodyPr wrap="square" lIns="45720" tIns="45720" rIns="45720" bIns="45720" rtlCol="0" anchor="t"/>
+          <a:lstStyle/>
+          <a:p>
+            <a:pPr indent="0" marL="0">
+              <a:buNone/>
+            </a:pPr>
+            <a:r>
+              <a:rPr lang="pt-BR" sz="1050" dirty="0">
+                <a:solidFill>
+                  <a:srgbClr val="1E293B"/>
+                </a:solidFill>
+                <a:latin typeface="Calibri" pitchFamily="34" charset="0"/>
+              </a:rPr>
+              <a:t>O botão só libera depois que um arquivo é anexado.</a:t>
+            </a:r>
+            <a:endParaRPr lang="pt-BR" sz="1050" dirty="0"/>
+          </a:p>
+        </p:txBody>
+      </p:sp>
+      <p:sp>
+        <p:nvSpPr>
+          <p:cNvPr id="14" name="Bullet14"/>
+          <p:cNvSpPr/>
+          <p:nvPr/>
+        </p:nvSpPr>
+        <p:spPr>
+          <a:xfrm>
+            <a:off x="4776300" y="2440000"/>
+            <a:ext cx="3820500" cy="420000"/>
+          </a:xfrm>
+          <a:prstGeom prst="rect">
+            <a:avLst/>
+          </a:prstGeom>
+          <a:noFill/>
+          <a:ln/>
+        </p:spPr>
+        <p:txBody>
+          <a:bodyPr wrap="square" lIns="45720" tIns="45720" rIns="45720" bIns="45720" rtlCol="0" anchor="t"/>
+          <a:lstStyle/>
+          <a:p>
+            <a:pPr indent="0" marL="0">
+              <a:buNone/>
+            </a:pPr>
+            <a:r>
+              <a:rPr lang="pt-BR" sz="1050" dirty="0">
+                <a:solidFill>
+                  <a:srgbClr val="1E293B"/>
+                </a:solidFill>
+                <a:latin typeface="Calibri" pitchFamily="34" charset="0"/>
+              </a:rPr>
+              <a:t>✕ Cancelar disponível em Cotação ou Em Trânsito, com motivo.</a:t>
+            </a:r>
+            <a:endParaRPr lang="pt-BR" sz="1050" dirty="0"/>
+          </a:p>
+        </p:txBody>
+      </p:sp>
+    </p:spTree>
+  </p:cSld>
+  <p:clrMapOvr>
+    <a:masterClrMapping/>
+  </p:clrMapOvr>
+</p:sld>
+</file>
+
+<file path=ppt/slides/slide45.xml><?xml version="1.0" encoding="utf-8"?>
+<p:sld xmlns:a="http://schemas.openxmlformats.org/drawingml/2006/main" xmlns:r="http://schemas.openxmlformats.org/officeDocument/2006/relationships" xmlns:p="http://schemas.openxmlformats.org/presentationml/2006/main">
+  <p:cSld name="Slide 45">
+    <p:spTree>
+      <p:nvGrpSpPr>
+        <p:cNvPr id="1" name=""/>
+        <p:cNvGrpSpPr/>
+        <p:nvPr/>
+      </p:nvGrpSpPr>
+      <p:grpSpPr>
+        <a:xfrm>
+          <a:off x="0" y="0"/>
+          <a:ext cx="0" cy="0"/>
+          <a:chOff x="0" y="0"/>
+          <a:chExt cx="0" cy="0"/>
+        </a:xfrm>
+      </p:grpSpPr>
+      <p:sp>
+        <p:nvSpPr>
+          <p:cNvPr id="2" name="BG"/>
+          <p:cNvSpPr/>
+          <p:nvPr/>
+        </p:nvSpPr>
+        <p:spPr>
+          <a:xfrm>
+            <a:off x="0" y="0"/>
+            <a:ext cx="9144000" cy="5143500"/>
+          </a:xfrm>
+          <a:prstGeom prst="rect">
+            <a:avLst/>
+          </a:prstGeom>
+          <a:solidFill>
+            <a:srgbClr val="FFFFFF"/>
+          </a:solidFill>
+          <a:ln w="12700">
+            <a:solidFill>
+              <a:srgbClr val="FFFFFF"/>
+            </a:solidFill>
+            <a:prstDash val="solid"/>
+          </a:ln>
+        </p:spPr>
+      </p:sp>
+      <p:sp>
+        <p:nvSpPr>
+          <p:cNvPr id="3" name="ModLabel"/>
+          <p:cNvSpPr/>
+          <p:nvPr/>
+        </p:nvSpPr>
+        <p:spPr>
+          <a:xfrm>
+            <a:off x="457200" y="182880"/>
+            <a:ext cx="7315200" cy="201168"/>
+          </a:xfrm>
+          <a:prstGeom prst="rect">
+            <a:avLst/>
+          </a:prstGeom>
+          <a:noFill/>
+          <a:ln/>
+        </p:spPr>
+        <p:txBody>
+          <a:bodyPr wrap="square" lIns="45720" tIns="45720" rIns="45720" bIns="45720" rtlCol="0" anchor="t"/>
+          <a:lstStyle/>
+          <a:p>
+            <a:pPr indent="0" marL="0">
+              <a:buNone/>
+            </a:pPr>
+            <a:r>
+              <a:rPr lang="pt-BR" sz="950" b="1" dirty="0">
+                <a:solidFill>
+                  <a:srgbClr val="94A3B8"/>
+                </a:solidFill>
+                <a:latin typeface="Calibri" pitchFamily="34" charset="0"/>
+              </a:rPr>
+              <a:t>MÓDULO PRODUÇÃO</a:t>
+            </a:r>
+            <a:endParaRPr lang="pt-BR" sz="950" dirty="0"/>
+          </a:p>
+        </p:txBody>
+      </p:sp>
+      <p:sp>
+        <p:nvSpPr>
+          <p:cNvPr id="4" name="Title"/>
+          <p:cNvSpPr/>
+          <p:nvPr/>
+        </p:nvSpPr>
+        <p:spPr>
+          <a:xfrm>
+            <a:off x="457200" y="384048"/>
+            <a:ext cx="8229600" cy="480000"/>
+          </a:xfrm>
+          <a:prstGeom prst="rect">
+            <a:avLst/>
+          </a:prstGeom>
+          <a:noFill/>
+          <a:ln/>
+        </p:spPr>
+        <p:txBody>
+          <a:bodyPr wrap="square" lIns="45720" tIns="45720" rIns="45720" bIns="45720" rtlCol="0" anchor="ctr"/>
+          <a:lstStyle/>
+          <a:p>
+            <a:pPr indent="0" marL="0">
+              <a:buNone/>
+            </a:pPr>
+            <a:r>
+              <a:rPr lang="pt-BR" sz="2600" b="1" dirty="0">
+                <a:solidFill>
+                  <a:srgbClr val="166534"/>
+                </a:solidFill>
+                <a:latin typeface="Calibri" pitchFamily="34" charset="0"/>
+              </a:rPr>
+              <a:t>Produção — Responsáveis e Apoios Livres</a:t>
+            </a:r>
+            <a:endParaRPr lang="pt-BR" sz="2600" dirty="0"/>
+          </a:p>
+        </p:txBody>
+      </p:sp>
+      <p:sp>
+        <p:nvSpPr>
+          <p:cNvPr id="5" name="ColBG5"/>
+          <p:cNvSpPr/>
+          <p:nvPr/>
+        </p:nvSpPr>
+        <p:spPr>
+          <a:xfrm>
+            <a:off x="457200" y="1000000"/>
+            <a:ext cx="4000500" cy="4023500"/>
+          </a:xfrm>
+          <a:prstGeom prst="roundRect">
+            <a:avLst>
+              <a:gd name="adj" fmla="val 4082"/>
+            </a:avLst>
+          </a:prstGeom>
+          <a:solidFill>
+            <a:srgbClr val="F0FDF4"/>
+          </a:solidFill>
+          <a:ln w="12700">
+            <a:solidFill>
+              <a:srgbClr val="F0FDF4"/>
+            </a:solidFill>
+            <a:prstDash val="solid"/>
+          </a:ln>
+        </p:spPr>
+      </p:sp>
+      <p:sp>
+        <p:nvSpPr>
+          <p:cNvPr id="6" name="ColTitle5"/>
+          <p:cNvSpPr/>
+          <p:nvPr/>
+        </p:nvSpPr>
+        <p:spPr>
+          <a:xfrm>
+            <a:off x="547200" y="1110000"/>
+            <a:ext cx="3820500" cy="330000"/>
+          </a:xfrm>
+          <a:prstGeom prst="rect">
+            <a:avLst/>
+          </a:prstGeom>
+          <a:noFill/>
+          <a:ln/>
+        </p:spPr>
+        <p:txBody>
+          <a:bodyPr wrap="square" lIns="45720" tIns="45720" rIns="45720" bIns="45720" rtlCol="0" anchor="t"/>
+          <a:lstStyle/>
+          <a:p>
+            <a:pPr indent="0" marL="0">
+              <a:buNone/>
+            </a:pPr>
+            <a:r>
+              <a:rPr lang="pt-BR" sz="1500" b="1" dirty="0">
+                <a:solidFill>
+                  <a:srgbClr val="166534"/>
+                </a:solidFill>
+                <a:latin typeface="Calibri" pitchFamily="34" charset="0"/>
+              </a:rPr>
+              <a:t>👥 Ajuste Livre da Equipe</a:t>
+            </a:r>
+            <a:endParaRPr lang="pt-BR" sz="1500" dirty="0"/>
+          </a:p>
+        </p:txBody>
+      </p:sp>
+      <p:sp>
+        <p:nvSpPr>
+          <p:cNvPr id="7" name="Bullet7"/>
+          <p:cNvSpPr/>
+          <p:nvPr/>
+        </p:nvSpPr>
+        <p:spPr>
+          <a:xfrm>
+            <a:off x="547200" y="1520000"/>
+            <a:ext cx="3820500" cy="420000"/>
+          </a:xfrm>
+          <a:prstGeom prst="rect">
+            <a:avLst/>
+          </a:prstGeom>
+          <a:noFill/>
+          <a:ln/>
+        </p:spPr>
+        <p:txBody>
+          <a:bodyPr wrap="square" lIns="45720" tIns="45720" rIns="45720" bIns="45720" rtlCol="0" anchor="t"/>
+          <a:lstStyle/>
+          <a:p>
+            <a:pPr indent="0" marL="0">
+              <a:buNone/>
+            </a:pPr>
+            <a:r>
+              <a:rPr lang="pt-BR" sz="1050" dirty="0">
+                <a:solidFill>
+                  <a:srgbClr val="1E293B"/>
+                </a:solidFill>
+                <a:latin typeface="Calibri" pitchFamily="34" charset="0"/>
+              </a:rPr>
+              <a:t>Depois de iniciada, clique em 👥 EQUIPE na OP ou OS pra ajustar quem está trabalhando.</a:t>
+            </a:r>
+            <a:endParaRPr lang="pt-BR" sz="1050" dirty="0"/>
+          </a:p>
+        </p:txBody>
+      </p:sp>
+      <p:sp>
+        <p:nvSpPr>
+          <p:cNvPr id="8" name="Bullet8"/>
+          <p:cNvSpPr/>
+          <p:nvPr/>
+        </p:nvSpPr>
+        <p:spPr>
+          <a:xfrm>
+            <a:off x="547200" y="1980000"/>
+            <a:ext cx="3820500" cy="420000"/>
+          </a:xfrm>
+          <a:prstGeom prst="rect">
+            <a:avLst/>
+          </a:prstGeom>
+          <a:noFill/>
+          <a:ln/>
+        </p:spPr>
+        <p:txBody>
+          <a:bodyPr wrap="square" lIns="45720" tIns="45720" rIns="45720" bIns="45720" rtlCol="0" anchor="t"/>
+          <a:lstStyle/>
+          <a:p>
+            <a:pPr indent="0" marL="0">
+              <a:buNone/>
+            </a:pPr>
+            <a:r>
+              <a:rPr lang="pt-BR" sz="1050" dirty="0">
+                <a:solidFill>
+                  <a:srgbClr val="1E293B"/>
+                </a:solidFill>
+                <a:latin typeface="Calibri" pitchFamily="34" charset="0"/>
+              </a:rPr>
+              <a:t>Diferente do cadastro fixo de Equipes — aqui vale só pra aquela OP/OS.</a:t>
+            </a:r>
+            <a:endParaRPr lang="pt-BR" sz="1050" dirty="0"/>
+          </a:p>
+        </p:txBody>
+      </p:sp>
+      <p:sp>
+        <p:nvSpPr>
+          <p:cNvPr id="9" name="Bullet9"/>
+          <p:cNvSpPr/>
+          <p:nvPr/>
+        </p:nvSpPr>
+        <p:spPr>
+          <a:xfrm>
+            <a:off x="547200" y="2440000"/>
+            <a:ext cx="3820500" cy="420000"/>
+          </a:xfrm>
+          <a:prstGeom prst="rect">
+            <a:avLst/>
+          </a:prstGeom>
+          <a:noFill/>
+          <a:ln/>
+        </p:spPr>
+        <p:txBody>
+          <a:bodyPr wrap="square" lIns="45720" tIns="45720" rIns="45720" bIns="45720" rtlCol="0" anchor="t"/>
+          <a:lstStyle/>
+          <a:p>
+            <a:pPr indent="0" marL="0">
+              <a:buNone/>
+            </a:pPr>
+            <a:r>
+              <a:rPr lang="pt-BR" sz="1050" dirty="0">
+                <a:solidFill>
+                  <a:srgbClr val="1E293B"/>
+                </a:solidFill>
+                <a:latin typeface="Calibri" pitchFamily="34" charset="0"/>
+              </a:rPr>
+              <a:t>Adicione ou remova membros a qualquer momento com + Add / 🗑️.</a:t>
+            </a:r>
+            <a:endParaRPr lang="pt-BR" sz="1050" dirty="0"/>
+          </a:p>
+        </p:txBody>
+      </p:sp>
+      <p:sp>
+        <p:nvSpPr>
+          <p:cNvPr id="10" name="ColBG10"/>
+          <p:cNvSpPr/>
+          <p:nvPr/>
+        </p:nvSpPr>
+        <p:spPr>
+          <a:xfrm>
+            <a:off x="4686300" y="1000000"/>
+            <a:ext cx="4000500" cy="4023500"/>
+          </a:xfrm>
+          <a:prstGeom prst="roundRect">
+            <a:avLst>
+              <a:gd name="adj" fmla="val 4082"/>
+            </a:avLst>
+          </a:prstGeom>
+          <a:solidFill>
+            <a:srgbClr val="EFF6FF"/>
+          </a:solidFill>
+          <a:ln w="12700">
+            <a:solidFill>
+              <a:srgbClr val="EFF6FF"/>
+            </a:solidFill>
+            <a:prstDash val="solid"/>
+          </a:ln>
+        </p:spPr>
+      </p:sp>
+      <p:sp>
+        <p:nvSpPr>
+          <p:cNvPr id="11" name="ColTitle10"/>
+          <p:cNvSpPr/>
+          <p:nvPr/>
+        </p:nvSpPr>
+        <p:spPr>
+          <a:xfrm>
+            <a:off x="4776300" y="1110000"/>
+            <a:ext cx="3820500" cy="330000"/>
+          </a:xfrm>
+          <a:prstGeom prst="rect">
+            <a:avLst/>
+          </a:prstGeom>
+          <a:noFill/>
+          <a:ln/>
+        </p:spPr>
+        <p:txBody>
+          <a:bodyPr wrap="square" lIns="45720" tIns="45720" rIns="45720" bIns="45720" rtlCol="0" anchor="t"/>
+          <a:lstStyle/>
+          <a:p>
+            <a:pPr indent="0" marL="0">
+              <a:buNone/>
+            </a:pPr>
+            <a:r>
+              <a:rPr lang="pt-BR" sz="1500" b="1" dirty="0">
+                <a:solidFill>
+                  <a:srgbClr val="1D4ED8"/>
+                </a:solidFill>
+                <a:latin typeface="Calibri" pitchFamily="34" charset="0"/>
+              </a:rPr>
+              <a:t>💰 Comissão</a:t>
+            </a:r>
+            <a:endParaRPr lang="pt-BR" sz="1500" dirty="0"/>
+          </a:p>
+        </p:txBody>
+      </p:sp>
+      <p:sp>
+        <p:nvSpPr>
+          <p:cNvPr id="12" name="Bullet12"/>
+          <p:cNvSpPr/>
+          <p:nvPr/>
+        </p:nvSpPr>
+        <p:spPr>
+          <a:xfrm>
+            <a:off x="4776300" y="1520000"/>
+            <a:ext cx="3820500" cy="420000"/>
+          </a:xfrm>
+          <a:prstGeom prst="rect">
+            <a:avLst/>
+          </a:prstGeom>
+          <a:noFill/>
+          <a:ln/>
+        </p:spPr>
+        <p:txBody>
+          <a:bodyPr wrap="square" lIns="45720" tIns="45720" rIns="45720" bIns="45720" rtlCol="0" anchor="t"/>
+          <a:lstStyle/>
+          <a:p>
+            <a:pPr indent="0" marL="0">
+              <a:buNone/>
+            </a:pPr>
+            <a:r>
+              <a:rPr lang="pt-BR" sz="1050" dirty="0">
+                <a:solidFill>
+                  <a:srgbClr val="1E293B"/>
+                </a:solidFill>
+                <a:latin typeface="Calibri" pitchFamily="34" charset="0"/>
+              </a:rPr>
+              <a:t>Responsáveis: comissão pelo próprio percentual configurado no RH.</a:t>
+            </a:r>
+            <a:endParaRPr lang="pt-BR" sz="1050" dirty="0"/>
+          </a:p>
+        </p:txBody>
+      </p:sp>
+      <p:sp>
+        <p:nvSpPr>
+          <p:cNvPr id="13" name="Bullet13"/>
+          <p:cNvSpPr/>
+          <p:nvPr/>
+        </p:nvSpPr>
+        <p:spPr>
+          <a:xfrm>
+            <a:off x="4776300" y="1980000"/>
+            <a:ext cx="3820500" cy="420000"/>
+          </a:xfrm>
+          <a:prstGeom prst="rect">
+            <a:avLst/>
+          </a:prstGeom>
+          <a:noFill/>
+          <a:ln/>
+        </p:spPr>
+        <p:txBody>
+          <a:bodyPr wrap="square" lIns="45720" tIns="45720" rIns="45720" bIns="45720" rtlCol="0" anchor="t"/>
+          <a:lstStyle/>
+          <a:p>
+            <a:pPr indent="0" marL="0">
+              <a:buNone/>
+            </a:pPr>
+            <a:r>
+              <a:rPr lang="pt-BR" sz="1050" dirty="0">
+                <a:solidFill>
+                  <a:srgbClr val="1E293B"/>
+                </a:solidFill>
+                <a:latin typeface="Calibri" pitchFamily="34" charset="0"/>
+              </a:rPr>
+              <a:t>Apoios: adicional fixo de 0,1% do valor de mão de obra da OP/OS.</a:t>
+            </a:r>
+            <a:endParaRPr lang="pt-BR" sz="1050" dirty="0"/>
+          </a:p>
+        </p:txBody>
+      </p:sp>
+      <p:sp>
+        <p:nvSpPr>
+          <p:cNvPr id="14" name="Bullet14"/>
+          <p:cNvSpPr/>
+          <p:nvPr/>
+        </p:nvSpPr>
+        <p:spPr>
+          <a:xfrm>
+            <a:off x="4776300" y="2440000"/>
+            <a:ext cx="3820500" cy="420000"/>
+          </a:xfrm>
+          <a:prstGeom prst="rect">
+            <a:avLst/>
+          </a:prstGeom>
+          <a:noFill/>
+          <a:ln/>
+        </p:spPr>
+        <p:txBody>
+          <a:bodyPr wrap="square" lIns="45720" tIns="45720" rIns="45720" bIns="45720" rtlCol="0" anchor="t"/>
+          <a:lstStyle/>
+          <a:p>
+            <a:pPr indent="0" marL="0">
+              <a:buNone/>
+            </a:pPr>
+            <a:r>
+              <a:rPr lang="pt-BR" sz="1050" dirty="0">
+                <a:solidFill>
+                  <a:srgbClr val="1E293B"/>
+                </a:solidFill>
+                <a:latin typeface="Calibri" pitchFamily="34" charset="0"/>
+              </a:rPr>
+              <a:t>O apoio recebe isso além do que os responsáveis já recebem.</a:t>
+            </a:r>
+            <a:endParaRPr lang="pt-BR" sz="1050" dirty="0"/>
+          </a:p>
+        </p:txBody>
+      </p:sp>
+    </p:spTree>
+  </p:cSld>
+  <p:clrMapOvr>
+    <a:masterClrMapping/>
+  </p:clrMapOvr>
+</p:sld>
+</file>
+
 <file path=ppt/slides/slide5.xml><?xml version="1.0" encoding="utf-8"?>
 <p:sld xmlns:a="http://schemas.openxmlformats.org/drawingml/2006/main" xmlns:r="http://schemas.openxmlformats.org/officeDocument/2006/relationships" xmlns:p="http://schemas.openxmlformats.org/presentationml/2006/main">
   <p:cSld name="Slide 5">

</xml_diff>

<commit_message>
docs: adiciona modulos faltantes no Mapa dos Modulos (slide 3)
Faltavam Marketing, Financeiro, Relatorios e Admin no slide de visao
geral -- renomeia a caixa "RH / Admin" para so "RH" e adiciona uma
5a linha com os 4 modulos que faltavam. Atualiza tambem a contagem
"20 modulos" para "24 modulos" no slide 2.

Co-Authored-By: Claude Sonnet 5 <noreply@anthropic.com>
</commit_message>
<xml_diff>
--- a/ACN_Sinal_Verde_Treinamento.pptx
+++ b/ACN_Sinal_Verde_Treinamento.pptx
@@ -9984,7 +9984,7 @@
                 <a:ea typeface="Calibri" pitchFamily="34" charset="-122"/>
                 <a:cs typeface="Calibri" pitchFamily="34" charset="-120"/>
               </a:rPr>
-              <a:t>20 módulos  •  32 funcionalidades  •  Disponível 24h via browser</a:t>
+              <a:t>24 módulos  •  32 funcionalidades  •  Disponível 24h via browser</a:t>
             </a:r>
             <a:endParaRPr lang="en-US" sz="1000" dirty="0"/>
           </a:p>
@@ -20368,7 +20368,271 @@
                 <a:ea typeface="Calibri" pitchFamily="34" charset="-122"/>
                 <a:cs typeface="Calibri" pitchFamily="34" charset="-120"/>
               </a:rPr>
-              <a:t>RH / Admin</a:t>
+              <a:t>RH</a:t>
+            </a:r>
+            <a:endParaRPr lang="en-US" sz="1150" dirty="0"/>
+          </a:p>
+        </p:txBody>
+      </p:sp>
+      <p:sp>
+        <p:nvSpPr>
+          <p:cNvPr id="46" name="Shape 46"/>
+          <p:cNvSpPr/>
+          <p:nvPr/>
+        </p:nvSpPr>
+        <p:spPr>
+          <a:xfrm>
+            <a:off x="338328" y="3621024"/>
+            <a:ext cx="1645920" cy="512064"/>
+          </a:xfrm>
+          <a:prstGeom prst="roundRect">
+            <a:avLst>
+              <a:gd name="adj" fmla="val 8929"/>
+            </a:avLst>
+          </a:prstGeom>
+          <a:solidFill>
+            <a:srgbClr val="0D9488"/>
+          </a:solidFill>
+          <a:ln w="12700">
+            <a:solidFill>
+              <a:srgbClr val="0D9488"/>
+            </a:solidFill>
+            <a:prstDash val="solid"/>
+          </a:ln>
+        </p:spPr>
+      </p:sp>
+      <p:sp>
+        <p:nvSpPr>
+          <p:cNvPr id="47" name="Text 47"/>
+          <p:cNvSpPr/>
+          <p:nvPr/>
+        </p:nvSpPr>
+        <p:spPr>
+          <a:xfrm>
+            <a:off x="402336" y="3621024"/>
+            <a:ext cx="1517904" cy="512064"/>
+          </a:xfrm>
+          <a:prstGeom prst="rect">
+            <a:avLst/>
+          </a:prstGeom>
+          <a:noFill/>
+          <a:ln/>
+        </p:spPr>
+        <p:txBody>
+          <a:bodyPr wrap="square" lIns="0" tIns="0" rIns="0" bIns="0" rtlCol="0" anchor="ctr"/>
+          <a:lstStyle/>
+          <a:p>
+            <a:pPr algn="ctr" indent="0" marL="0">
+              <a:buNone/>
+            </a:pPr>
+            <a:r>
+              <a:rPr lang="en-US" sz="1150" b="1" dirty="0">
+                <a:solidFill>
+                  <a:srgbClr val="FFFFFF"/>
+                </a:solidFill>
+                <a:latin typeface="Calibri" pitchFamily="34" charset="0"/>
+                <a:ea typeface="Calibri" pitchFamily="34" charset="-122"/>
+                <a:cs typeface="Calibri" pitchFamily="34" charset="-120"/>
+              </a:rPr>
+              <a:t>Marketing</a:t>
+            </a:r>
+            <a:endParaRPr lang="en-US" sz="1150" dirty="0"/>
+          </a:p>
+        </p:txBody>
+      </p:sp>
+      <p:sp>
+        <p:nvSpPr>
+          <p:cNvPr id="48" name="Shape 48"/>
+          <p:cNvSpPr/>
+          <p:nvPr/>
+        </p:nvSpPr>
+        <p:spPr>
+          <a:xfrm>
+            <a:off x="2039112" y="3621024"/>
+            <a:ext cx="1645920" cy="512064"/>
+          </a:xfrm>
+          <a:prstGeom prst="roundRect">
+            <a:avLst>
+              <a:gd name="adj" fmla="val 8929"/>
+            </a:avLst>
+          </a:prstGeom>
+          <a:solidFill>
+            <a:srgbClr val="0D9488"/>
+          </a:solidFill>
+          <a:ln w="12700">
+            <a:solidFill>
+              <a:srgbClr val="0D9488"/>
+            </a:solidFill>
+            <a:prstDash val="solid"/>
+          </a:ln>
+        </p:spPr>
+      </p:sp>
+      <p:sp>
+        <p:nvSpPr>
+          <p:cNvPr id="49" name="Text 49"/>
+          <p:cNvSpPr/>
+          <p:nvPr/>
+        </p:nvSpPr>
+        <p:spPr>
+          <a:xfrm>
+            <a:off x="2103120" y="3621024"/>
+            <a:ext cx="1517904" cy="512064"/>
+          </a:xfrm>
+          <a:prstGeom prst="rect">
+            <a:avLst/>
+          </a:prstGeom>
+          <a:noFill/>
+          <a:ln/>
+        </p:spPr>
+        <p:txBody>
+          <a:bodyPr wrap="square" lIns="0" tIns="0" rIns="0" bIns="0" rtlCol="0" anchor="ctr"/>
+          <a:lstStyle/>
+          <a:p>
+            <a:pPr algn="ctr" indent="0" marL="0">
+              <a:buNone/>
+            </a:pPr>
+            <a:r>
+              <a:rPr lang="en-US" sz="1150" b="1" dirty="0">
+                <a:solidFill>
+                  <a:srgbClr val="FFFFFF"/>
+                </a:solidFill>
+                <a:latin typeface="Calibri" pitchFamily="34" charset="0"/>
+                <a:ea typeface="Calibri" pitchFamily="34" charset="-122"/>
+                <a:cs typeface="Calibri" pitchFamily="34" charset="-120"/>
+              </a:rPr>
+              <a:t>Financeiro</a:t>
+            </a:r>
+            <a:endParaRPr lang="en-US" sz="1150" dirty="0"/>
+          </a:p>
+        </p:txBody>
+      </p:sp>
+      <p:sp>
+        <p:nvSpPr>
+          <p:cNvPr id="50" name="Shape 50"/>
+          <p:cNvSpPr/>
+          <p:nvPr/>
+        </p:nvSpPr>
+        <p:spPr>
+          <a:xfrm>
+            <a:off x="3739896" y="3621024"/>
+            <a:ext cx="1645920" cy="512064"/>
+          </a:xfrm>
+          <a:prstGeom prst="roundRect">
+            <a:avLst>
+              <a:gd name="adj" fmla="val 8929"/>
+            </a:avLst>
+          </a:prstGeom>
+          <a:solidFill>
+            <a:srgbClr val="0D9488"/>
+          </a:solidFill>
+          <a:ln w="12700">
+            <a:solidFill>
+              <a:srgbClr val="0D9488"/>
+            </a:solidFill>
+            <a:prstDash val="solid"/>
+          </a:ln>
+        </p:spPr>
+      </p:sp>
+      <p:sp>
+        <p:nvSpPr>
+          <p:cNvPr id="51" name="Text 51"/>
+          <p:cNvSpPr/>
+          <p:nvPr/>
+        </p:nvSpPr>
+        <p:spPr>
+          <a:xfrm>
+            <a:off x="3803904" y="3621024"/>
+            <a:ext cx="1517904" cy="512064"/>
+          </a:xfrm>
+          <a:prstGeom prst="rect">
+            <a:avLst/>
+          </a:prstGeom>
+          <a:noFill/>
+          <a:ln/>
+        </p:spPr>
+        <p:txBody>
+          <a:bodyPr wrap="square" lIns="0" tIns="0" rIns="0" bIns="0" rtlCol="0" anchor="ctr"/>
+          <a:lstStyle/>
+          <a:p>
+            <a:pPr algn="ctr" indent="0" marL="0">
+              <a:buNone/>
+            </a:pPr>
+            <a:r>
+              <a:rPr lang="en-US" sz="1150" b="1" dirty="0">
+                <a:solidFill>
+                  <a:srgbClr val="FFFFFF"/>
+                </a:solidFill>
+                <a:latin typeface="Calibri" pitchFamily="34" charset="0"/>
+                <a:ea typeface="Calibri" pitchFamily="34" charset="-122"/>
+                <a:cs typeface="Calibri" pitchFamily="34" charset="-120"/>
+              </a:rPr>
+              <a:t>Relatórios</a:t>
+            </a:r>
+            <a:endParaRPr lang="en-US" sz="1150" dirty="0"/>
+          </a:p>
+        </p:txBody>
+      </p:sp>
+      <p:sp>
+        <p:nvSpPr>
+          <p:cNvPr id="52" name="Shape 52"/>
+          <p:cNvSpPr/>
+          <p:nvPr/>
+        </p:nvSpPr>
+        <p:spPr>
+          <a:xfrm>
+            <a:off x="5440680" y="3621024"/>
+            <a:ext cx="1645920" cy="512064"/>
+          </a:xfrm>
+          <a:prstGeom prst="roundRect">
+            <a:avLst>
+              <a:gd name="adj" fmla="val 8929"/>
+            </a:avLst>
+          </a:prstGeom>
+          <a:solidFill>
+            <a:srgbClr val="0D9488"/>
+          </a:solidFill>
+          <a:ln w="12700">
+            <a:solidFill>
+              <a:srgbClr val="0D9488"/>
+            </a:solidFill>
+            <a:prstDash val="solid"/>
+          </a:ln>
+        </p:spPr>
+      </p:sp>
+      <p:sp>
+        <p:nvSpPr>
+          <p:cNvPr id="53" name="Text 53"/>
+          <p:cNvSpPr/>
+          <p:nvPr/>
+        </p:nvSpPr>
+        <p:spPr>
+          <a:xfrm>
+            <a:off x="5504688" y="3621024"/>
+            <a:ext cx="1517904" cy="512064"/>
+          </a:xfrm>
+          <a:prstGeom prst="rect">
+            <a:avLst/>
+          </a:prstGeom>
+          <a:noFill/>
+          <a:ln/>
+        </p:spPr>
+        <p:txBody>
+          <a:bodyPr wrap="square" lIns="0" tIns="0" rIns="0" bIns="0" rtlCol="0" anchor="ctr"/>
+          <a:lstStyle/>
+          <a:p>
+            <a:pPr algn="ctr" indent="0" marL="0">
+              <a:buNone/>
+            </a:pPr>
+            <a:r>
+              <a:rPr lang="en-US" sz="1150" b="1" dirty="0">
+                <a:solidFill>
+                  <a:srgbClr val="FFFFFF"/>
+                </a:solidFill>
+                <a:latin typeface="Calibri" pitchFamily="34" charset="0"/>
+                <a:ea typeface="Calibri" pitchFamily="34" charset="-122"/>
+                <a:cs typeface="Calibri" pitchFamily="34" charset="-120"/>
+              </a:rPr>
+              <a:t>Admin</a:t>
             </a:r>
             <a:endParaRPr lang="en-US" sz="1150" dirty="0"/>
           </a:p>

</xml_diff>

<commit_message>
docs: documenta backfill de auxiliares de comissão; atualiza manual e apresentação de treinamento
- sql/migrations.sql: documenta (rastreabilidade) o backfill de
  responsaveis_producao (papel=apoio) feito em 2026-08-30 ligando cada
  head-liner ao seu auxiliar confirmado (Tiago-Celio, Junior-Natan
  Espindola, Jonatan-Ronald); nenhuma alteração de schema/dado nova,
  só documentação.
- Manual_ACN_Sinal_Verde.docx: novas seções de horário comercial/pausa
  (Engenharia e Produção), Centro de Custo hierárquico, Comissões de
  Técnicos, permissão RH restrita + Ver como, capítulo de Chat
  reescrito, formatação rica em campos de texto, capítulo novo de
  Formação de Preços (versionamento/senha/histórico).
- ACN_Sinal_Verde_Treinamento.pptx: 3 slides novos (Comissões de
  Técnicos, Horário Comercial/Pausa, Formação de Preços) + slide do
  Chat atualizado.

Co-Authored-By: Claude Sonnet 5 <noreply@anthropic.com>
</commit_message>
<xml_diff>
--- a/ACN_Sinal_Verde_Treinamento.pptx
+++ b/ACN_Sinal_Verde_Treinamento.pptx
@@ -39,6 +39,8 @@
     <p:sldId id="285" r:id="rId31"/>
     <p:sldId id="286" r:id="rId32"/>
     <p:sldId id="290" r:id="rId41"/>
+    <p:sldId id="301" r:id="rId52"/>
+    <p:sldId id="302" r:id="rId53"/>
     <p:sldId id="294" r:id="rId45"/>
     <p:sldId id="293" r:id="rId44"/>
     <p:sldId id="292" r:id="rId43"/>
@@ -49,6 +51,7 @@
     <p:sldId id="298" r:id="rId49"/>
     <p:sldId id="299" r:id="rId50"/>
     <p:sldId id="300" r:id="rId51"/>
+    <p:sldId id="303" r:id="rId54"/>
     <p:sldId id="287" r:id="rId33"/>
   </p:sldIdLst>
   <p:notesMasterIdLst>
@@ -23385,7 +23388,7 @@
                 <a:ea typeface="Calibri" pitchFamily="34" charset="-122"/>
                 <a:cs typeface="Calibri" pitchFamily="34" charset="-120"/>
               </a:rPr>
-              <a:t>Canais globais: Geral, Produção, Comercial e outros.</a:t>
+              <a:t>Conversas diretas e Grupos — criados pelo próprio usuário, sem canais fixos.</a:t>
             </a:r>
             <a:endParaRPr lang="pt-BR" sz="1150" dirty="0"/>
           </a:p>
@@ -23406,7 +23409,7 @@
                 <a:ea typeface="Calibri" pitchFamily="34" charset="-122"/>
                 <a:cs typeface="Calibri" pitchFamily="34" charset="-120"/>
               </a:rPr>
-              <a:t>Mensagens diretas (DMs): privadas entre dois usuários.</a:t>
+              <a:t>Não lidas aparecem em negrito na lista, como no WhatsApp.</a:t>
             </a:r>
             <a:endParaRPr lang="pt-BR" sz="1150" dirty="0"/>
           </a:p>
@@ -23427,7 +23430,7 @@
                 <a:ea typeface="Calibri" pitchFamily="34" charset="-122"/>
                 <a:cs typeface="Calibri" pitchFamily="34" charset="-120"/>
               </a:rPr>
-              <a:t>DMs: apenas conversas com mensagens não lidas aparecem na lista.</a:t>
+              <a:t>Formatação: negrito, itálico, sublinhado e tachado nas mensagens.</a:t>
             </a:r>
             <a:endParaRPr lang="pt-BR" sz="1150" dirty="0"/>
           </a:p>
@@ -23448,7 +23451,7 @@
                 <a:ea typeface="Calibri" pitchFamily="34" charset="-122"/>
                 <a:cs typeface="Calibri" pitchFamily="34" charset="-120"/>
               </a:rPr>
-              <a:t>Mensagens consecutivas do mesmo usuário são agrupadas visualmente.</a:t>
+              <a:t>Anexos e 🔗 Compartilhar Processo — abre direto o registro (OP, CRM, Licitação...).</a:t>
             </a:r>
             <a:endParaRPr lang="pt-BR" sz="1150" dirty="0"/>
           </a:p>
@@ -31686,6 +31689,1296 @@
   <p:clrMapOvr>
     <a:masterClrMapping/>
   </p:clrMapOvr>
+</p:sld>
+</file>
+
+<file path=ppt/slides/slide46.xml><?xml version="1.0" encoding="utf-8"?>
+<p:sld xmlns:a="http://schemas.openxmlformats.org/drawingml/2006/main" xmlns:r="http://schemas.openxmlformats.org/officeDocument/2006/relationships" xmlns:p="http://schemas.openxmlformats.org/presentationml/2006/main">
+  <p:cSld name="Slide 46">
+    <p:spTree>
+      <p:nvGrpSpPr>
+        <p:cNvPr id="1" name=""/>
+        <p:cNvGrpSpPr/>
+        <p:nvPr/>
+      </p:nvGrpSpPr>
+      <p:grpSpPr>
+        <a:xfrm>
+          <a:off x="0" y="0"/>
+          <a:ext cx="0" cy="0"/>
+          <a:chOff x="0" y="0"/>
+          <a:chExt cx="0" cy="0"/>
+        </a:xfrm>
+      </p:grpSpPr>
+      <p:sp>
+        <p:nvSpPr>
+          <p:cNvPr id="2" name="BG"/>
+          <p:cNvSpPr/>
+          <p:nvPr/>
+        </p:nvSpPr>
+        <p:spPr>
+          <a:xfrm>
+            <a:off x="0" y="0"/>
+            <a:ext cx="9144000" cy="5143500"/>
+          </a:xfrm>
+          <a:prstGeom prst="rect">
+            <a:avLst/>
+          </a:prstGeom>
+          <a:noFill/>
+          <a:ln w="12700">
+            <a:solidFill>
+              <a:srgbClr val="FFFFFF"/>
+            </a:solidFill>
+            <a:prstDash val="solid"/>
+          </a:ln>
+        </p:spPr>
+      </p:sp>
+      <p:sp>
+        <p:nvSpPr>
+          <p:cNvPr id="3" name="Module"/>
+          <p:cNvSpPr/>
+          <p:nvPr/>
+        </p:nvSpPr>
+        <p:spPr>
+          <a:xfrm>
+            <a:off x="457200" y="182880"/>
+            <a:ext cx="7315200" cy="201168"/>
+          </a:xfrm>
+          <a:prstGeom prst="rect">
+            <a:avLst/>
+          </a:prstGeom>
+          <a:noFill/>
+          <a:ln/>
+        </p:spPr>
+        <p:txBody>
+          <a:bodyPr wrap="square" lIns="0" tIns="0" rIns="0" bIns="0" rtlCol="0" anchor="ctr"/>
+          <a:lstStyle/>
+          <a:p>
+            <a:pPr indent="0" marL="0">
+              <a:buNone/>
+            </a:pPr>
+            <a:r>
+              <a:rPr lang="pt-BR" sz="950" b="1" kern="0" dirty="0">
+                <a:solidFill>
+                  <a:srgbClr val="94A3B8"/>
+                </a:solidFill>
+                <a:latin typeface="Calibri" pitchFamily="34" charset="0"/>
+                <a:ea typeface="Calibri" pitchFamily="34" charset="-122"/>
+                <a:cs typeface="Calibri" pitchFamily="34" charset="-120"/>
+              </a:rPr>
+              <a:t>MODULO RH</a:t>
+            </a:r>
+            <a:endParaRPr lang="pt-BR" sz="950" dirty="0"/>
+          </a:p>
+        </p:txBody>
+      </p:sp>
+      <p:sp>
+        <p:nvSpPr>
+          <p:cNvPr id="4" name="Title"/>
+          <p:cNvSpPr/>
+          <p:nvPr/>
+        </p:nvSpPr>
+        <p:spPr>
+          <a:xfrm>
+            <a:off x="457200" y="384048"/>
+            <a:ext cx="8229600" cy="594360"/>
+          </a:xfrm>
+          <a:prstGeom prst="rect">
+            <a:avLst/>
+          </a:prstGeom>
+          <a:noFill/>
+          <a:ln/>
+        </p:spPr>
+        <p:txBody>
+          <a:bodyPr wrap="square" lIns="0" tIns="0" rIns="0" bIns="0" rtlCol="0" anchor="ctr"/>
+          <a:lstStyle/>
+          <a:p>
+            <a:pPr indent="0" marL="0">
+              <a:buNone/>
+            </a:pPr>
+            <a:r>
+              <a:rPr lang="pt-BR" sz="3000" b="1" kern="0" dirty="0">
+                <a:solidFill>
+                  <a:srgbClr val="075985"/>
+                </a:solidFill>
+                <a:latin typeface="Calibri" pitchFamily="34" charset="0"/>
+                <a:ea typeface="Calibri" pitchFamily="34" charset="-122"/>
+                <a:cs typeface="Calibri" pitchFamily="34" charset="-120"/>
+              </a:rPr>
+              <a:t>Comissões de Técnicos</a:t>
+            </a:r>
+            <a:endParaRPr lang="pt-BR" sz="3000" dirty="0"/>
+          </a:p>
+        </p:txBody>
+      </p:sp>
+      <p:sp>
+        <p:nvSpPr>
+          <p:cNvPr id="5" name="Sep"/>
+          <p:cNvSpPr/>
+          <p:nvPr/>
+        </p:nvSpPr>
+        <p:spPr>
+          <a:xfrm>
+            <a:off x="457200" y="1024128"/>
+            <a:ext cx="8229600" cy="27432"/>
+          </a:xfrm>
+          <a:prstGeom prst="rect">
+            <a:avLst/>
+          </a:prstGeom>
+          <a:noFill/>
+          <a:ln w="12700">
+            <a:solidFill>
+              <a:srgbClr val="E0F2FE"/>
+            </a:solidFill>
+            <a:prstDash val="solid"/>
+          </a:ln>
+        </p:spPr>
+      </p:sp>
+      <p:sp>
+        <p:nvSpPr>
+          <p:cNvPr id="6" name="Box6"/>
+          <p:cNvSpPr/>
+          <p:nvPr/>
+        </p:nvSpPr>
+        <p:spPr>
+          <a:xfrm>
+            <a:off x="457200" y="1207008"/>
+            <a:ext cx="4023360" cy="3430080"/>
+          </a:xfrm>
+          <a:prstGeom prst="roundRect">
+            <a:avLst>
+              <a:gd name="adj" fmla="val 1975"/>
+            </a:avLst>
+          </a:prstGeom>
+          <a:noFill/>
+          <a:ln w="12700">
+            <a:solidFill>
+              <a:srgbClr val="E0F2FE"/>
+            </a:solidFill>
+            <a:prstDash val="solid"/>
+          </a:ln>
+        </p:spPr>
+      </p:sp>
+      <p:sp>
+        <p:nvSpPr>
+          <p:cNvPr id="7" name="Hdr6"/>
+          <p:cNvSpPr/>
+          <p:nvPr/>
+        </p:nvSpPr>
+        <p:spPr>
+          <a:xfrm>
+            <a:off x="594360" y="1316736"/>
+            <a:ext cx="3749040" cy="384048"/>
+          </a:xfrm>
+          <a:prstGeom prst="rect">
+            <a:avLst/>
+          </a:prstGeom>
+          <a:noFill/>
+          <a:ln/>
+        </p:spPr>
+        <p:txBody>
+          <a:bodyPr wrap="square" lIns="0" tIns="0" rIns="0" bIns="0" rtlCol="0" anchor="ctr"/>
+          <a:lstStyle/>
+          <a:p>
+            <a:pPr indent="0" marL="0">
+              <a:buNone/>
+            </a:pPr>
+            <a:r>
+              <a:rPr lang="pt-BR" sz="1350" b="1" kern="0" dirty="0">
+                <a:solidFill>
+                  <a:srgbClr val="075985"/>
+                </a:solidFill>
+                <a:latin typeface="Calibri" pitchFamily="34" charset="0"/>
+                <a:ea typeface="Calibri" pitchFamily="34" charset="-122"/>
+                <a:cs typeface="Calibri" pitchFamily="34" charset="-120"/>
+              </a:rPr>
+              <a:t>Faturada / A Faturar</a:t>
+            </a:r>
+            <a:endParaRPr lang="pt-BR" sz="1350" dirty="0"/>
+          </a:p>
+        </p:txBody>
+      </p:sp>
+      <p:sp>
+        <p:nvSpPr>
+          <p:cNvPr id="8" name="Blt6"/>
+          <p:cNvSpPr/>
+          <p:nvPr/>
+        </p:nvSpPr>
+        <p:spPr>
+          <a:xfrm>
+            <a:off x="594360" y="1755648"/>
+            <a:ext cx="3749040" cy="2771712"/>
+          </a:xfrm>
+          <a:prstGeom prst="rect">
+            <a:avLst/>
+          </a:prstGeom>
+          <a:noFill/>
+          <a:ln/>
+        </p:spPr>
+        <p:txBody>
+          <a:bodyPr wrap="square" lIns="0" tIns="0" rIns="0" bIns="0" rtlCol="0" anchor="t"/>
+          <a:lstStyle/>
+          <a:p>
+            <a:pPr marL="342900" indent="-342900">
+              <a:spcAft>
+                <a:spcPts val="500"/>
+              </a:spcAft>
+              <a:buSzPct val="100000"/>
+              <a:buChar char="•"/>
+            </a:pPr>
+            <a:r>
+              <a:rPr lang="pt-BR" sz="1150" kern="0" dirty="0">
+                <a:solidFill>
+                  <a:srgbClr val="1E293B"/>
+                </a:solidFill>
+                <a:latin typeface="Calibri" pitchFamily="34" charset="0"/>
+                <a:ea typeface="Calibri" pitchFamily="34" charset="-122"/>
+                <a:cs typeface="Calibri" pitchFamily="34" charset="-120"/>
+              </a:rPr>
+              <a:t>Toggle ✅ Faturada: OPs/OSs com NF emitida no período.</a:t>
+            </a:r>
+            <a:endParaRPr lang="pt-BR" sz="1150" dirty="0"/>
+          </a:p>
+          <a:p>
+            <a:pPr marL="342900" indent="-342900">
+              <a:spcAft>
+                <a:spcPts val="500"/>
+              </a:spcAft>
+              <a:buSzPct val="100000"/>
+              <a:buChar char="•"/>
+            </a:pPr>
+            <a:r>
+              <a:rPr lang="pt-BR" sz="1150" kern="0" dirty="0">
+                <a:solidFill>
+                  <a:srgbClr val="1E293B"/>
+                </a:solidFill>
+                <a:latin typeface="Calibri" pitchFamily="34" charset="0"/>
+                <a:ea typeface="Calibri" pitchFamily="34" charset="-122"/>
+                <a:cs typeface="Calibri" pitchFamily="34" charset="-120"/>
+              </a:rPr>
+              <a:t>Toggle ⏳ A Faturar: produção concluída, NF ainda não emitida.</a:t>
+            </a:r>
+            <a:endParaRPr lang="pt-BR" sz="1150" dirty="0"/>
+          </a:p>
+        </p:txBody>
+      </p:sp>
+      <p:sp>
+        <p:nvSpPr>
+          <p:cNvPr id="9" name="Box9"/>
+          <p:cNvSpPr/>
+          <p:nvPr/>
+        </p:nvSpPr>
+        <p:spPr>
+          <a:xfrm>
+            <a:off x="4663920" y="1207008"/>
+            <a:ext cx="4023360" cy="3430080"/>
+          </a:xfrm>
+          <a:prstGeom prst="roundRect">
+            <a:avLst>
+              <a:gd name="adj" fmla="val 1975"/>
+            </a:avLst>
+          </a:prstGeom>
+          <a:noFill/>
+          <a:ln w="12700">
+            <a:solidFill>
+              <a:srgbClr val="F0F9FF"/>
+            </a:solidFill>
+            <a:prstDash val="solid"/>
+          </a:ln>
+        </p:spPr>
+      </p:sp>
+      <p:sp>
+        <p:nvSpPr>
+          <p:cNvPr id="10" name="Hdr9"/>
+          <p:cNvSpPr/>
+          <p:nvPr/>
+        </p:nvSpPr>
+        <p:spPr>
+          <a:xfrm>
+            <a:off x="4801080" y="1316736"/>
+            <a:ext cx="3749040" cy="384048"/>
+          </a:xfrm>
+          <a:prstGeom prst="rect">
+            <a:avLst/>
+          </a:prstGeom>
+          <a:noFill/>
+          <a:ln/>
+        </p:spPr>
+        <p:txBody>
+          <a:bodyPr wrap="square" lIns="0" tIns="0" rIns="0" bIns="0" rtlCol="0" anchor="ctr"/>
+          <a:lstStyle/>
+          <a:p>
+            <a:pPr indent="0" marL="0">
+              <a:buNone/>
+            </a:pPr>
+            <a:r>
+              <a:rPr lang="pt-BR" sz="1350" b="1" kern="0" dirty="0">
+                <a:solidFill>
+                  <a:srgbClr val="075985"/>
+                </a:solidFill>
+                <a:latin typeface="Calibri" pitchFamily="34" charset="0"/>
+                <a:ea typeface="Calibri" pitchFamily="34" charset="-122"/>
+                <a:cs typeface="Calibri" pitchFamily="34" charset="-120"/>
+              </a:rPr>
+              <a:t>Pipeline e Comissão</a:t>
+            </a:r>
+            <a:endParaRPr lang="pt-BR" sz="1350" dirty="0"/>
+          </a:p>
+        </p:txBody>
+      </p:sp>
+      <p:sp>
+        <p:nvSpPr>
+          <p:cNvPr id="11" name="Blt9"/>
+          <p:cNvSpPr/>
+          <p:nvPr/>
+        </p:nvSpPr>
+        <p:spPr>
+          <a:xfrm>
+            <a:off x="4801080" y="1755648"/>
+            <a:ext cx="3749040" cy="2771712"/>
+          </a:xfrm>
+          <a:prstGeom prst="rect">
+            <a:avLst/>
+          </a:prstGeom>
+          <a:noFill/>
+          <a:ln/>
+        </p:spPr>
+        <p:txBody>
+          <a:bodyPr wrap="square" lIns="0" tIns="0" rIns="0" bIns="0" rtlCol="0" anchor="t"/>
+          <a:lstStyle/>
+          <a:p>
+            <a:pPr marL="342900" indent="-342900">
+              <a:spcAft>
+                <a:spcPts val="500"/>
+              </a:spcAft>
+              <a:buSzPct val="100000"/>
+              <a:buChar char="•"/>
+            </a:pPr>
+            <a:r>
+              <a:rPr lang="pt-BR" sz="1150" kern="0" dirty="0">
+                <a:solidFill>
+                  <a:srgbClr val="1E293B"/>
+                </a:solidFill>
+                <a:latin typeface="Calibri" pitchFamily="34" charset="0"/>
+                <a:ea typeface="Calibri" pitchFamily="34" charset="-122"/>
+                <a:cs typeface="Calibri" pitchFamily="34" charset="-120"/>
+              </a:rPr>
+              <a:t>Cards por Técnico Individual, Dupla ou Equipe (Head Line).</a:t>
+            </a:r>
+            <a:endParaRPr lang="pt-BR" sz="1150" dirty="0"/>
+          </a:p>
+          <a:p>
+            <a:pPr marL="342900" indent="-342900">
+              <a:spcAft>
+                <a:spcPts val="500"/>
+              </a:spcAft>
+              <a:buSzPct val="100000"/>
+              <a:buChar char="•"/>
+            </a:pPr>
+            <a:r>
+              <a:rPr lang="pt-BR" sz="1150" kern="0" dirty="0">
+                <a:solidFill>
+                  <a:srgbClr val="1E293B"/>
+                </a:solidFill>
+                <a:latin typeface="Calibri" pitchFamily="34" charset="0"/>
+                <a:ea typeface="Calibri" pitchFamily="34" charset="-122"/>
+                <a:cs typeface="Calibri" pitchFamily="34" charset="-120"/>
+              </a:rPr>
+              <a:t>Apoio: adicional fixo de 0,1% sobre a mão de obra.</a:t>
+            </a:r>
+            <a:endParaRPr lang="pt-BR" sz="1150" dirty="0"/>
+          </a:p>
+          <a:p>
+            <a:pPr marL="342900" indent="-342900">
+              <a:spcAft>
+                <a:spcPts val="500"/>
+              </a:spcAft>
+              <a:buSzPct val="100000"/>
+              <a:buChar char="•"/>
+            </a:pPr>
+            <a:r>
+              <a:rPr lang="pt-BR" sz="1150" kern="0" dirty="0">
+                <a:solidFill>
+                  <a:srgbClr val="1E293B"/>
+                </a:solidFill>
+                <a:latin typeface="Calibri" pitchFamily="34" charset="0"/>
+                <a:ea typeface="Calibri" pitchFamily="34" charset="-122"/>
+                <a:cs typeface="Calibri" pitchFamily="34" charset="-120"/>
+              </a:rPr>
+              <a:t>Lote de veículos: divide o valor pela quantidade de carros automaticamente.</a:t>
+            </a:r>
+            <a:endParaRPr lang="pt-BR" sz="1150" dirty="0"/>
+          </a:p>
+        </p:txBody>
+      </p:sp>
+    </p:spTree>
+  </p:cSld>
+</p:sld>
+</file>
+
+<file path=ppt/slides/slide47.xml><?xml version="1.0" encoding="utf-8"?>
+<p:sld xmlns:a="http://schemas.openxmlformats.org/drawingml/2006/main" xmlns:r="http://schemas.openxmlformats.org/officeDocument/2006/relationships" xmlns:p="http://schemas.openxmlformats.org/presentationml/2006/main">
+  <p:cSld name="Slide 47">
+    <p:spTree>
+      <p:nvGrpSpPr>
+        <p:cNvPr id="1" name=""/>
+        <p:cNvGrpSpPr/>
+        <p:nvPr/>
+      </p:nvGrpSpPr>
+      <p:grpSpPr>
+        <a:xfrm>
+          <a:off x="0" y="0"/>
+          <a:ext cx="0" cy="0"/>
+          <a:chOff x="0" y="0"/>
+          <a:chExt cx="0" cy="0"/>
+        </a:xfrm>
+      </p:grpSpPr>
+      <p:sp>
+        <p:nvSpPr>
+          <p:cNvPr id="2" name="BG"/>
+          <p:cNvSpPr/>
+          <p:nvPr/>
+        </p:nvSpPr>
+        <p:spPr>
+          <a:xfrm>
+            <a:off x="0" y="0"/>
+            <a:ext cx="9144000" cy="5143500"/>
+          </a:xfrm>
+          <a:prstGeom prst="rect">
+            <a:avLst/>
+          </a:prstGeom>
+          <a:noFill/>
+          <a:ln w="12700">
+            <a:solidFill>
+              <a:srgbClr val="FFFFFF"/>
+            </a:solidFill>
+            <a:prstDash val="solid"/>
+          </a:ln>
+        </p:spPr>
+      </p:sp>
+      <p:sp>
+        <p:nvSpPr>
+          <p:cNvPr id="3" name="Module"/>
+          <p:cNvSpPr/>
+          <p:nvPr/>
+        </p:nvSpPr>
+        <p:spPr>
+          <a:xfrm>
+            <a:off x="457200" y="182880"/>
+            <a:ext cx="7315200" cy="201168"/>
+          </a:xfrm>
+          <a:prstGeom prst="rect">
+            <a:avLst/>
+          </a:prstGeom>
+          <a:noFill/>
+          <a:ln/>
+        </p:spPr>
+        <p:txBody>
+          <a:bodyPr wrap="square" lIns="0" tIns="0" rIns="0" bIns="0" rtlCol="0" anchor="ctr"/>
+          <a:lstStyle/>
+          <a:p>
+            <a:pPr indent="0" marL="0">
+              <a:buNone/>
+            </a:pPr>
+            <a:r>
+              <a:rPr lang="pt-BR" sz="950" b="1" kern="0" dirty="0">
+                <a:solidFill>
+                  <a:srgbClr val="94A3B8"/>
+                </a:solidFill>
+                <a:latin typeface="Calibri" pitchFamily="34" charset="0"/>
+                <a:ea typeface="Calibri" pitchFamily="34" charset="-122"/>
+                <a:cs typeface="Calibri" pitchFamily="34" charset="-120"/>
+              </a:rPr>
+              <a:t>MODULO PRODUÇÃO / ENGENHARIA</a:t>
+            </a:r>
+            <a:endParaRPr lang="pt-BR" sz="950" dirty="0"/>
+          </a:p>
+        </p:txBody>
+      </p:sp>
+      <p:sp>
+        <p:nvSpPr>
+          <p:cNvPr id="4" name="Title"/>
+          <p:cNvSpPr/>
+          <p:nvPr/>
+        </p:nvSpPr>
+        <p:spPr>
+          <a:xfrm>
+            <a:off x="457200" y="384048"/>
+            <a:ext cx="8229600" cy="594360"/>
+          </a:xfrm>
+          <a:prstGeom prst="rect">
+            <a:avLst/>
+          </a:prstGeom>
+          <a:noFill/>
+          <a:ln/>
+        </p:spPr>
+        <p:txBody>
+          <a:bodyPr wrap="square" lIns="0" tIns="0" rIns="0" bIns="0" rtlCol="0" anchor="ctr"/>
+          <a:lstStyle/>
+          <a:p>
+            <a:pPr indent="0" marL="0">
+              <a:buNone/>
+            </a:pPr>
+            <a:r>
+              <a:rPr lang="pt-BR" sz="3000" b="1" kern="0" dirty="0">
+                <a:solidFill>
+                  <a:srgbClr val="075985"/>
+                </a:solidFill>
+                <a:latin typeface="Calibri" pitchFamily="34" charset="0"/>
+                <a:ea typeface="Calibri" pitchFamily="34" charset="-122"/>
+                <a:cs typeface="Calibri" pitchFamily="34" charset="-120"/>
+              </a:rPr>
+              <a:t>Horário Comercial e Pausa</a:t>
+            </a:r>
+            <a:endParaRPr lang="pt-BR" sz="3000" dirty="0"/>
+          </a:p>
+        </p:txBody>
+      </p:sp>
+      <p:sp>
+        <p:nvSpPr>
+          <p:cNvPr id="5" name="Sep"/>
+          <p:cNvSpPr/>
+          <p:nvPr/>
+        </p:nvSpPr>
+        <p:spPr>
+          <a:xfrm>
+            <a:off x="457200" y="1024128"/>
+            <a:ext cx="8229600" cy="27432"/>
+          </a:xfrm>
+          <a:prstGeom prst="rect">
+            <a:avLst/>
+          </a:prstGeom>
+          <a:noFill/>
+          <a:ln w="12700">
+            <a:solidFill>
+              <a:srgbClr val="E0F2FE"/>
+            </a:solidFill>
+            <a:prstDash val="solid"/>
+          </a:ln>
+        </p:spPr>
+      </p:sp>
+      <p:sp>
+        <p:nvSpPr>
+          <p:cNvPr id="6" name="Box6"/>
+          <p:cNvSpPr/>
+          <p:nvPr/>
+        </p:nvSpPr>
+        <p:spPr>
+          <a:xfrm>
+            <a:off x="457200" y="1207008"/>
+            <a:ext cx="4023360" cy="3430080"/>
+          </a:xfrm>
+          <a:prstGeom prst="roundRect">
+            <a:avLst>
+              <a:gd name="adj" fmla="val 1975"/>
+            </a:avLst>
+          </a:prstGeom>
+          <a:noFill/>
+          <a:ln w="12700">
+            <a:solidFill>
+              <a:srgbClr val="E0F2FE"/>
+            </a:solidFill>
+            <a:prstDash val="solid"/>
+          </a:ln>
+        </p:spPr>
+      </p:sp>
+      <p:sp>
+        <p:nvSpPr>
+          <p:cNvPr id="7" name="Hdr6"/>
+          <p:cNvSpPr/>
+          <p:nvPr/>
+        </p:nvSpPr>
+        <p:spPr>
+          <a:xfrm>
+            <a:off x="594360" y="1316736"/>
+            <a:ext cx="3749040" cy="384048"/>
+          </a:xfrm>
+          <a:prstGeom prst="rect">
+            <a:avLst/>
+          </a:prstGeom>
+          <a:noFill/>
+          <a:ln/>
+        </p:spPr>
+        <p:txBody>
+          <a:bodyPr wrap="square" lIns="0" tIns="0" rIns="0" bIns="0" rtlCol="0" anchor="ctr"/>
+          <a:lstStyle/>
+          <a:p>
+            <a:pPr indent="0" marL="0">
+              <a:buNone/>
+            </a:pPr>
+            <a:r>
+              <a:rPr lang="pt-BR" sz="1350" b="1" kern="0" dirty="0">
+                <a:solidFill>
+                  <a:srgbClr val="075985"/>
+                </a:solidFill>
+                <a:latin typeface="Calibri" pitchFamily="34" charset="0"/>
+                <a:ea typeface="Calibri" pitchFamily="34" charset="-122"/>
+                <a:cs typeface="Calibri" pitchFamily="34" charset="-120"/>
+              </a:rPr>
+              <a:t>Horário Comercial</a:t>
+            </a:r>
+            <a:endParaRPr lang="pt-BR" sz="1350" dirty="0"/>
+          </a:p>
+        </p:txBody>
+      </p:sp>
+      <p:sp>
+        <p:nvSpPr>
+          <p:cNvPr id="8" name="Blt6"/>
+          <p:cNvSpPr/>
+          <p:nvPr/>
+        </p:nvSpPr>
+        <p:spPr>
+          <a:xfrm>
+            <a:off x="594360" y="1755648"/>
+            <a:ext cx="3749040" cy="2771712"/>
+          </a:xfrm>
+          <a:prstGeom prst="rect">
+            <a:avLst/>
+          </a:prstGeom>
+          <a:noFill/>
+          <a:ln/>
+        </p:spPr>
+        <p:txBody>
+          <a:bodyPr wrap="square" lIns="0" tIns="0" rIns="0" bIns="0" rtlCol="0" anchor="t"/>
+          <a:lstStyle/>
+          <a:p>
+            <a:pPr marL="342900" indent="-342900">
+              <a:spcAft>
+                <a:spcPts val="500"/>
+              </a:spcAft>
+              <a:buSzPct val="100000"/>
+              <a:buChar char="•"/>
+            </a:pPr>
+            <a:r>
+              <a:rPr lang="pt-BR" sz="1150" kern="0" dirty="0">
+                <a:solidFill>
+                  <a:srgbClr val="1E293B"/>
+                </a:solidFill>
+                <a:latin typeface="Calibri" pitchFamily="34" charset="0"/>
+                <a:ea typeface="Calibri" pitchFamily="34" charset="-122"/>
+                <a:cs typeface="Calibri" pitchFamily="34" charset="-120"/>
+              </a:rPr>
+              <a:t>Lead Time só conta Seg–Sex, das 8h00 às 17h45.</a:t>
+            </a:r>
+            <a:endParaRPr lang="pt-BR" sz="1150" dirty="0"/>
+          </a:p>
+          <a:p>
+            <a:pPr marL="342900" indent="-342900">
+              <a:spcAft>
+                <a:spcPts val="500"/>
+              </a:spcAft>
+              <a:buSzPct val="100000"/>
+              <a:buChar char="•"/>
+            </a:pPr>
+            <a:r>
+              <a:rPr lang="pt-BR" sz="1150" kern="0" dirty="0">
+                <a:solidFill>
+                  <a:srgbClr val="1E293B"/>
+                </a:solidFill>
+                <a:latin typeface="Calibri" pitchFamily="34" charset="0"/>
+                <a:ea typeface="Calibri" pitchFamily="34" charset="-122"/>
+                <a:cs typeface="Calibri" pitchFamily="34" charset="-120"/>
+              </a:rPr>
+              <a:t>Fora do expediente, o cronômetro não avança sozinho.</a:t>
+            </a:r>
+            <a:endParaRPr lang="pt-BR" sz="1150" dirty="0"/>
+          </a:p>
+        </p:txBody>
+      </p:sp>
+      <p:sp>
+        <p:nvSpPr>
+          <p:cNvPr id="9" name="Box9"/>
+          <p:cNvSpPr/>
+          <p:nvPr/>
+        </p:nvSpPr>
+        <p:spPr>
+          <a:xfrm>
+            <a:off x="4663920" y="1207008"/>
+            <a:ext cx="4023360" cy="3430080"/>
+          </a:xfrm>
+          <a:prstGeom prst="roundRect">
+            <a:avLst>
+              <a:gd name="adj" fmla="val 1975"/>
+            </a:avLst>
+          </a:prstGeom>
+          <a:noFill/>
+          <a:ln w="12700">
+            <a:solidFill>
+              <a:srgbClr val="F0F9FF"/>
+            </a:solidFill>
+            <a:prstDash val="solid"/>
+          </a:ln>
+        </p:spPr>
+      </p:sp>
+      <p:sp>
+        <p:nvSpPr>
+          <p:cNvPr id="10" name="Hdr9"/>
+          <p:cNvSpPr/>
+          <p:nvPr/>
+        </p:nvSpPr>
+        <p:spPr>
+          <a:xfrm>
+            <a:off x="4801080" y="1316736"/>
+            <a:ext cx="3749040" cy="384048"/>
+          </a:xfrm>
+          <a:prstGeom prst="rect">
+            <a:avLst/>
+          </a:prstGeom>
+          <a:noFill/>
+          <a:ln/>
+        </p:spPr>
+        <p:txBody>
+          <a:bodyPr wrap="square" lIns="0" tIns="0" rIns="0" bIns="0" rtlCol="0" anchor="ctr"/>
+          <a:lstStyle/>
+          <a:p>
+            <a:pPr indent="0" marL="0">
+              <a:buNone/>
+            </a:pPr>
+            <a:r>
+              <a:rPr lang="pt-BR" sz="1350" b="1" kern="0" dirty="0">
+                <a:solidFill>
+                  <a:srgbClr val="075985"/>
+                </a:solidFill>
+                <a:latin typeface="Calibri" pitchFamily="34" charset="0"/>
+                <a:ea typeface="Calibri" pitchFamily="34" charset="-122"/>
+                <a:cs typeface="Calibri" pitchFamily="34" charset="-120"/>
+              </a:rPr>
+              <a:t>Botão de Pausa</a:t>
+            </a:r>
+            <a:endParaRPr lang="pt-BR" sz="1350" dirty="0"/>
+          </a:p>
+        </p:txBody>
+      </p:sp>
+      <p:sp>
+        <p:nvSpPr>
+          <p:cNvPr id="11" name="Blt9"/>
+          <p:cNvSpPr/>
+          <p:nvPr/>
+        </p:nvSpPr>
+        <p:spPr>
+          <a:xfrm>
+            <a:off x="4801080" y="1755648"/>
+            <a:ext cx="3749040" cy="2771712"/>
+          </a:xfrm>
+          <a:prstGeom prst="rect">
+            <a:avLst/>
+          </a:prstGeom>
+          <a:noFill/>
+          <a:ln/>
+        </p:spPr>
+        <p:txBody>
+          <a:bodyPr wrap="square" lIns="0" tIns="0" rIns="0" bIns="0" rtlCol="0" anchor="t"/>
+          <a:lstStyle/>
+          <a:p>
+            <a:pPr marL="342900" indent="-342900">
+              <a:spcAft>
+                <a:spcPts val="500"/>
+              </a:spcAft>
+              <a:buSzPct val="100000"/>
+              <a:buChar char="•"/>
+            </a:pPr>
+            <a:r>
+              <a:rPr lang="pt-BR" sz="1150" kern="0" dirty="0">
+                <a:solidFill>
+                  <a:srgbClr val="1E293B"/>
+                </a:solidFill>
+                <a:latin typeface="Calibri" pitchFamily="34" charset="0"/>
+                <a:ea typeface="Calibri" pitchFamily="34" charset="-122"/>
+                <a:cs typeface="Calibri" pitchFamily="34" charset="-120"/>
+              </a:rPr>
+              <a:t>Disponível em OPL "Em Análise Engenharia" e "Em Produção".</a:t>
+            </a:r>
+            <a:endParaRPr lang="pt-BR" sz="1150" dirty="0"/>
+          </a:p>
+          <a:p>
+            <a:pPr marL="342900" indent="-342900">
+              <a:spcAft>
+                <a:spcPts val="500"/>
+              </a:spcAft>
+              <a:buSzPct val="100000"/>
+              <a:buChar char="•"/>
+            </a:pPr>
+            <a:r>
+              <a:rPr lang="pt-BR" sz="1150" kern="0" dirty="0">
+                <a:solidFill>
+                  <a:srgbClr val="1E293B"/>
+                </a:solidFill>
+                <a:latin typeface="Calibri" pitchFamily="34" charset="0"/>
+                <a:ea typeface="Calibri" pitchFamily="34" charset="-122"/>
+                <a:cs typeface="Calibri" pitchFamily="34" charset="-120"/>
+              </a:rPr>
+              <a:t>Use pra pausas durante o expediente (material, prioridade).</a:t>
+            </a:r>
+            <a:endParaRPr lang="pt-BR" sz="1150" dirty="0"/>
+          </a:p>
+          <a:p>
+            <a:pPr marL="342900" indent="-342900">
+              <a:spcAft>
+                <a:spcPts val="500"/>
+              </a:spcAft>
+              <a:buSzPct val="100000"/>
+              <a:buChar char="•"/>
+            </a:pPr>
+            <a:r>
+              <a:rPr lang="pt-BR" sz="1150" kern="0" dirty="0">
+                <a:solidFill>
+                  <a:srgbClr val="1E293B"/>
+                </a:solidFill>
+                <a:latin typeface="Calibri" pitchFamily="34" charset="0"/>
+                <a:ea typeface="Calibri" pitchFamily="34" charset="-122"/>
+                <a:cs typeface="Calibri" pitchFamily="34" charset="-120"/>
+              </a:rPr>
+              <a:t>▶ Retomar volta a contar — tempo pausado é descontado do total.</a:t>
+            </a:r>
+            <a:endParaRPr lang="pt-BR" sz="1150" dirty="0"/>
+          </a:p>
+        </p:txBody>
+      </p:sp>
+    </p:spTree>
+  </p:cSld>
+</p:sld>
+</file>
+
+<file path=ppt/slides/slide48.xml><?xml version="1.0" encoding="utf-8"?>
+<p:sld xmlns:a="http://schemas.openxmlformats.org/drawingml/2006/main" xmlns:r="http://schemas.openxmlformats.org/officeDocument/2006/relationships" xmlns:p="http://schemas.openxmlformats.org/presentationml/2006/main">
+  <p:cSld name="Slide 48">
+    <p:spTree>
+      <p:nvGrpSpPr>
+        <p:cNvPr id="1" name=""/>
+        <p:cNvGrpSpPr/>
+        <p:nvPr/>
+      </p:nvGrpSpPr>
+      <p:grpSpPr>
+        <a:xfrm>
+          <a:off x="0" y="0"/>
+          <a:ext cx="0" cy="0"/>
+          <a:chOff x="0" y="0"/>
+          <a:chExt cx="0" cy="0"/>
+        </a:xfrm>
+      </p:grpSpPr>
+      <p:sp>
+        <p:nvSpPr>
+          <p:cNvPr id="2" name="BG"/>
+          <p:cNvSpPr/>
+          <p:nvPr/>
+        </p:nvSpPr>
+        <p:spPr>
+          <a:xfrm>
+            <a:off x="0" y="0"/>
+            <a:ext cx="9144000" cy="5143500"/>
+          </a:xfrm>
+          <a:prstGeom prst="rect">
+            <a:avLst/>
+          </a:prstGeom>
+          <a:noFill/>
+          <a:ln w="12700">
+            <a:solidFill>
+              <a:srgbClr val="FFFFFF"/>
+            </a:solidFill>
+            <a:prstDash val="solid"/>
+          </a:ln>
+        </p:spPr>
+      </p:sp>
+      <p:sp>
+        <p:nvSpPr>
+          <p:cNvPr id="3" name="Module"/>
+          <p:cNvSpPr/>
+          <p:nvPr/>
+        </p:nvSpPr>
+        <p:spPr>
+          <a:xfrm>
+            <a:off x="457200" y="182880"/>
+            <a:ext cx="7315200" cy="201168"/>
+          </a:xfrm>
+          <a:prstGeom prst="rect">
+            <a:avLst/>
+          </a:prstGeom>
+          <a:noFill/>
+          <a:ln/>
+        </p:spPr>
+        <p:txBody>
+          <a:bodyPr wrap="square" lIns="0" tIns="0" rIns="0" bIns="0" rtlCol="0" anchor="ctr"/>
+          <a:lstStyle/>
+          <a:p>
+            <a:pPr indent="0" marL="0">
+              <a:buNone/>
+            </a:pPr>
+            <a:r>
+              <a:rPr lang="pt-BR" sz="950" b="1" kern="0" dirty="0">
+                <a:solidFill>
+                  <a:srgbClr val="94A3B8"/>
+                </a:solidFill>
+                <a:latin typeface="Calibri" pitchFamily="34" charset="0"/>
+                <a:ea typeface="Calibri" pitchFamily="34" charset="-122"/>
+                <a:cs typeface="Calibri" pitchFamily="34" charset="-120"/>
+              </a:rPr>
+              <a:t>MODULO FORMAÇÃO DE PREÇOS</a:t>
+            </a:r>
+            <a:endParaRPr lang="pt-BR" sz="950" dirty="0"/>
+          </a:p>
+        </p:txBody>
+      </p:sp>
+      <p:sp>
+        <p:nvSpPr>
+          <p:cNvPr id="4" name="Title"/>
+          <p:cNvSpPr/>
+          <p:nvPr/>
+        </p:nvSpPr>
+        <p:spPr>
+          <a:xfrm>
+            <a:off x="457200" y="384048"/>
+            <a:ext cx="8229600" cy="594360"/>
+          </a:xfrm>
+          <a:prstGeom prst="rect">
+            <a:avLst/>
+          </a:prstGeom>
+          <a:noFill/>
+          <a:ln/>
+        </p:spPr>
+        <p:txBody>
+          <a:bodyPr wrap="square" lIns="0" tIns="0" rIns="0" bIns="0" rtlCol="0" anchor="ctr"/>
+          <a:lstStyle/>
+          <a:p>
+            <a:pPr indent="0" marL="0">
+              <a:buNone/>
+            </a:pPr>
+            <a:r>
+              <a:rPr lang="pt-BR" sz="3000" b="1" kern="0" dirty="0">
+                <a:solidFill>
+                  <a:srgbClr val="075985"/>
+                </a:solidFill>
+                <a:latin typeface="Calibri" pitchFamily="34" charset="0"/>
+                <a:ea typeface="Calibri" pitchFamily="34" charset="-122"/>
+                <a:cs typeface="Calibri" pitchFamily="34" charset="-120"/>
+              </a:rPr>
+              <a:t>Formação de Preços</a:t>
+            </a:r>
+            <a:endParaRPr lang="pt-BR" sz="3000" dirty="0"/>
+          </a:p>
+        </p:txBody>
+      </p:sp>
+      <p:sp>
+        <p:nvSpPr>
+          <p:cNvPr id="5" name="Sep"/>
+          <p:cNvSpPr/>
+          <p:nvPr/>
+        </p:nvSpPr>
+        <p:spPr>
+          <a:xfrm>
+            <a:off x="457200" y="1024128"/>
+            <a:ext cx="8229600" cy="27432"/>
+          </a:xfrm>
+          <a:prstGeom prst="rect">
+            <a:avLst/>
+          </a:prstGeom>
+          <a:noFill/>
+          <a:ln w="12700">
+            <a:solidFill>
+              <a:srgbClr val="E0F2FE"/>
+            </a:solidFill>
+            <a:prstDash val="solid"/>
+          </a:ln>
+        </p:spPr>
+      </p:sp>
+      <p:sp>
+        <p:nvSpPr>
+          <p:cNvPr id="6" name="Box6"/>
+          <p:cNvSpPr/>
+          <p:nvPr/>
+        </p:nvSpPr>
+        <p:spPr>
+          <a:xfrm>
+            <a:off x="457200" y="1207008"/>
+            <a:ext cx="4023360" cy="3430080"/>
+          </a:xfrm>
+          <a:prstGeom prst="roundRect">
+            <a:avLst>
+              <a:gd name="adj" fmla="val 1975"/>
+            </a:avLst>
+          </a:prstGeom>
+          <a:noFill/>
+          <a:ln w="12700">
+            <a:solidFill>
+              <a:srgbClr val="E0F2FE"/>
+            </a:solidFill>
+            <a:prstDash val="solid"/>
+          </a:ln>
+        </p:spPr>
+      </p:sp>
+      <p:sp>
+        <p:nvSpPr>
+          <p:cNvPr id="7" name="Hdr6"/>
+          <p:cNvSpPr/>
+          <p:nvPr/>
+        </p:nvSpPr>
+        <p:spPr>
+          <a:xfrm>
+            <a:off x="594360" y="1316736"/>
+            <a:ext cx="3749040" cy="384048"/>
+          </a:xfrm>
+          <a:prstGeom prst="rect">
+            <a:avLst/>
+          </a:prstGeom>
+          <a:noFill/>
+          <a:ln/>
+        </p:spPr>
+        <p:txBody>
+          <a:bodyPr wrap="square" lIns="0" tIns="0" rIns="0" bIns="0" rtlCol="0" anchor="ctr"/>
+          <a:lstStyle/>
+          <a:p>
+            <a:pPr indent="0" marL="0">
+              <a:buNone/>
+            </a:pPr>
+            <a:r>
+              <a:rPr lang="pt-BR" sz="1350" b="1" kern="0" dirty="0">
+                <a:solidFill>
+                  <a:srgbClr val="075985"/>
+                </a:solidFill>
+                <a:latin typeface="Calibri" pitchFamily="34" charset="0"/>
+                <a:ea typeface="Calibri" pitchFamily="34" charset="-122"/>
+                <a:cs typeface="Calibri" pitchFamily="34" charset="-120"/>
+              </a:rPr>
+              <a:t>Montagem</a:t>
+            </a:r>
+            <a:endParaRPr lang="pt-BR" sz="1350" dirty="0"/>
+          </a:p>
+        </p:txBody>
+      </p:sp>
+      <p:sp>
+        <p:nvSpPr>
+          <p:cNvPr id="8" name="Blt6"/>
+          <p:cNvSpPr/>
+          <p:nvPr/>
+        </p:nvSpPr>
+        <p:spPr>
+          <a:xfrm>
+            <a:off x="594360" y="1755648"/>
+            <a:ext cx="3749040" cy="2771712"/>
+          </a:xfrm>
+          <a:prstGeom prst="rect">
+            <a:avLst/>
+          </a:prstGeom>
+          <a:noFill/>
+          <a:ln/>
+        </p:spPr>
+        <p:txBody>
+          <a:bodyPr wrap="square" lIns="0" tIns="0" rIns="0" bIns="0" rtlCol="0" anchor="t"/>
+          <a:lstStyle/>
+          <a:p>
+            <a:pPr marL="342900" indent="-342900">
+              <a:spcAft>
+                <a:spcPts val="500"/>
+              </a:spcAft>
+              <a:buSzPct val="100000"/>
+              <a:buChar char="•"/>
+            </a:pPr>
+            <a:r>
+              <a:rPr lang="pt-BR" sz="1150" kern="0" dirty="0">
+                <a:solidFill>
+                  <a:srgbClr val="1E293B"/>
+                </a:solidFill>
+                <a:latin typeface="Calibri" pitchFamily="34" charset="0"/>
+                <a:ea typeface="Calibri" pitchFamily="34" charset="-122"/>
+                <a:cs typeface="Calibri" pitchFamily="34" charset="-120"/>
+              </a:rPr>
+              <a:t>Itens com custo, IPI%, ST%, Markup% e DIFAL%.</a:t>
+            </a:r>
+            <a:endParaRPr lang="pt-BR" sz="1150" dirty="0"/>
+          </a:p>
+          <a:p>
+            <a:pPr marL="342900" indent="-342900">
+              <a:spcAft>
+                <a:spcPts val="500"/>
+              </a:spcAft>
+              <a:buSzPct val="100000"/>
+              <a:buChar char="•"/>
+            </a:pPr>
+            <a:r>
+              <a:rPr lang="pt-BR" sz="1150" kern="0" dirty="0">
+                <a:solidFill>
+                  <a:srgbClr val="1E293B"/>
+                </a:solidFill>
+                <a:latin typeface="Calibri" pitchFamily="34" charset="0"/>
+                <a:ea typeface="Calibri" pitchFamily="34" charset="-122"/>
+                <a:cs typeface="Calibri" pitchFamily="34" charset="-120"/>
+              </a:rPr>
+              <a:t>Parâmetros globais: PTAX, impostos, markup, lote.</a:t>
+            </a:r>
+            <a:endParaRPr lang="pt-BR" sz="1150" dirty="0"/>
+          </a:p>
+          <a:p>
+            <a:pPr marL="342900" indent="-342900">
+              <a:spcAft>
+                <a:spcPts val="500"/>
+              </a:spcAft>
+              <a:buSzPct val="100000"/>
+              <a:buChar char="•"/>
+            </a:pPr>
+            <a:r>
+              <a:rPr lang="pt-BR" sz="1150" kern="0" dirty="0">
+                <a:solidFill>
+                  <a:srgbClr val="1E293B"/>
+                </a:solidFill>
+                <a:latin typeface="Calibri" pitchFamily="34" charset="0"/>
+                <a:ea typeface="Calibri" pitchFamily="34" charset="-122"/>
+                <a:cs typeface="Calibri" pitchFamily="34" charset="-120"/>
+              </a:rPr>
+              <a:t>📎 Finalizar &amp; Anexar PDF na OP/OS vinculada.</a:t>
+            </a:r>
+            <a:endParaRPr lang="pt-BR" sz="1150" dirty="0"/>
+          </a:p>
+        </p:txBody>
+      </p:sp>
+      <p:sp>
+        <p:nvSpPr>
+          <p:cNvPr id="9" name="Box9"/>
+          <p:cNvSpPr/>
+          <p:nvPr/>
+        </p:nvSpPr>
+        <p:spPr>
+          <a:xfrm>
+            <a:off x="4663920" y="1207008"/>
+            <a:ext cx="4023360" cy="3430080"/>
+          </a:xfrm>
+          <a:prstGeom prst="roundRect">
+            <a:avLst>
+              <a:gd name="adj" fmla="val 1975"/>
+            </a:avLst>
+          </a:prstGeom>
+          <a:noFill/>
+          <a:ln w="12700">
+            <a:solidFill>
+              <a:srgbClr val="F0F9FF"/>
+            </a:solidFill>
+            <a:prstDash val="solid"/>
+          </a:ln>
+        </p:spPr>
+      </p:sp>
+      <p:sp>
+        <p:nvSpPr>
+          <p:cNvPr id="10" name="Hdr9"/>
+          <p:cNvSpPr/>
+          <p:nvPr/>
+        </p:nvSpPr>
+        <p:spPr>
+          <a:xfrm>
+            <a:off x="4801080" y="1316736"/>
+            <a:ext cx="3749040" cy="384048"/>
+          </a:xfrm>
+          <a:prstGeom prst="rect">
+            <a:avLst/>
+          </a:prstGeom>
+          <a:noFill/>
+          <a:ln/>
+        </p:spPr>
+        <p:txBody>
+          <a:bodyPr wrap="square" lIns="0" tIns="0" rIns="0" bIns="0" rtlCol="0" anchor="ctr"/>
+          <a:lstStyle/>
+          <a:p>
+            <a:pPr indent="0" marL="0">
+              <a:buNone/>
+            </a:pPr>
+            <a:r>
+              <a:rPr lang="pt-BR" sz="1350" b="1" kern="0" dirty="0">
+                <a:solidFill>
+                  <a:srgbClr val="075985"/>
+                </a:solidFill>
+                <a:latin typeface="Calibri" pitchFamily="34" charset="0"/>
+                <a:ea typeface="Calibri" pitchFamily="34" charset="-122"/>
+                <a:cs typeface="Calibri" pitchFamily="34" charset="-120"/>
+              </a:rPr>
+              <a:t>Versão Final e Histórico</a:t>
+            </a:r>
+            <a:endParaRPr lang="pt-BR" sz="1350" dirty="0"/>
+          </a:p>
+        </p:txBody>
+      </p:sp>
+      <p:sp>
+        <p:nvSpPr>
+          <p:cNvPr id="11" name="Blt9"/>
+          <p:cNvSpPr/>
+          <p:nvPr/>
+        </p:nvSpPr>
+        <p:spPr>
+          <a:xfrm>
+            <a:off x="4801080" y="1755648"/>
+            <a:ext cx="3749040" cy="2771712"/>
+          </a:xfrm>
+          <a:prstGeom prst="rect">
+            <a:avLst/>
+          </a:prstGeom>
+          <a:noFill/>
+          <a:ln/>
+        </p:spPr>
+        <p:txBody>
+          <a:bodyPr wrap="square" lIns="0" tIns="0" rIns="0" bIns="0" rtlCol="0" anchor="t"/>
+          <a:lstStyle/>
+          <a:p>
+            <a:pPr marL="342900" indent="-342900">
+              <a:spcAft>
+                <a:spcPts val="500"/>
+              </a:spcAft>
+              <a:buSzPct val="100000"/>
+              <a:buChar char="•"/>
+            </a:pPr>
+            <a:r>
+              <a:rPr lang="pt-BR" sz="1150" kern="0" dirty="0">
+                <a:solidFill>
+                  <a:srgbClr val="1E293B"/>
+                </a:solidFill>
+                <a:latin typeface="Calibri" pitchFamily="34" charset="0"/>
+                <a:ea typeface="Calibri" pitchFamily="34" charset="-122"/>
+                <a:cs typeface="Calibri" pitchFamily="34" charset="-120"/>
+              </a:rPr>
+              <a:t>🔒 Registrar Versão Final: exige senha, grava responsável.</a:t>
+            </a:r>
+            <a:endParaRPr lang="pt-BR" sz="1150" dirty="0"/>
+          </a:p>
+          <a:p>
+            <a:pPr marL="342900" indent="-342900">
+              <a:spcAft>
+                <a:spcPts val="500"/>
+              </a:spcAft>
+              <a:buSzPct val="100000"/>
+              <a:buChar char="•"/>
+            </a:pPr>
+            <a:r>
+              <a:rPr lang="pt-BR" sz="1150" kern="0" dirty="0">
+                <a:solidFill>
+                  <a:srgbClr val="1E293B"/>
+                </a:solidFill>
+                <a:latin typeface="Calibri" pitchFamily="34" charset="0"/>
+                <a:ea typeface="Calibri" pitchFamily="34" charset="-122"/>
+                <a:cs typeface="Calibri" pitchFamily="34" charset="-120"/>
+              </a:rPr>
+              <a:t>Depois de finalizada, alterações viram log automático.</a:t>
+            </a:r>
+            <a:endParaRPr lang="pt-BR" sz="1150" dirty="0"/>
+          </a:p>
+          <a:p>
+            <a:pPr marL="342900" indent="-342900">
+              <a:spcAft>
+                <a:spcPts val="500"/>
+              </a:spcAft>
+              <a:buSzPct val="100000"/>
+              <a:buChar char="•"/>
+            </a:pPr>
+            <a:r>
+              <a:rPr lang="pt-BR" sz="1150" kern="0" dirty="0">
+                <a:solidFill>
+                  <a:srgbClr val="1E293B"/>
+                </a:solidFill>
+                <a:latin typeface="Calibri" pitchFamily="34" charset="0"/>
+                <a:ea typeface="Calibri" pitchFamily="34" charset="-122"/>
+                <a:cs typeface="Calibri" pitchFamily="34" charset="-120"/>
+              </a:rPr>
+              <a:t>📜 Histórico: todas as versões + 🏆 qual foi a vencedora.</a:t>
+            </a:r>
+            <a:endParaRPr lang="pt-BR" sz="1150" dirty="0"/>
+          </a:p>
+        </p:txBody>
+      </p:sp>
+    </p:spTree>
+  </p:cSld>
 </p:sld>
 </file>
 

</xml_diff>